<commit_message>
PPTX: descripcion legible debajo de cada DSD
Cada lamina de DSD ahora explica en lenguaje llano que representa el
diagrama: quien actua, que mensajes intercambian, que pasa si la
validacion falla y como termina el flujo. Encabezado 'Que representa:'
y linea con los mensajes del diagrama al pie.
</commit_message>
<xml_diff>
--- a/docs/presentacion/CRUZNEGRA_DSD_CU_Reales.pptx
+++ b/docs/presentacion/CRUZNEGRA_DSD_CU_Reales.pptx
@@ -3524,7 +3524,7 @@
         </p:nvSpPr>
         <p:spPr>
           <a:xfrm>
-            <a:off x="457200" y="201168"/>
+            <a:off x="457200" y="182880"/>
             <a:ext cx="11274552" cy="457200"/>
           </a:xfrm>
           <a:prstGeom prst="rect">
@@ -3555,48 +3555,9 @@
           </a:p>
         </p:txBody>
       </p:sp>
-      <p:sp>
-        <p:nvSpPr>
-          <p:cNvPr id="3" name="Text 1"/>
-          <p:cNvSpPr/>
-          <p:nvPr/>
-        </p:nvSpPr>
-        <p:spPr>
-          <a:xfrm>
-            <a:off x="457200" y="658368"/>
-            <a:ext cx="11274552" cy="320040"/>
-          </a:xfrm>
-          <a:prstGeom prst="rect">
-            <a:avLst/>
-          </a:prstGeom>
-          <a:noFill/>
-          <a:ln/>
-        </p:spPr>
-        <p:txBody>
-          <a:bodyPr wrap="square" lIns="0" tIns="0" rIns="0" bIns="0" rtlCol="0" anchor="ctr"/>
-          <a:lstStyle/>
-          <a:p>
-            <a:pPr indent="0" marL="0">
-              <a:buNone/>
-            </a:pPr>
-            <a:r>
-              <a:rPr lang="en-US" sz="1300" dirty="0">
-                <a:solidFill>
-                  <a:srgbClr val="64748B"/>
-                </a:solidFill>
-                <a:latin typeface="Segoe UI" pitchFamily="34" charset="0"/>
-                <a:ea typeface="Segoe UI" pitchFamily="34" charset="-122"/>
-                <a:cs typeface="Segoe UI" pitchFamily="34" charset="-120"/>
-              </a:rPr>
-              <a:t>Ejecución real en la web del sistema</a:t>
-            </a:r>
-            <a:endParaRPr lang="en-US" sz="1300" dirty="0"/>
-          </a:p>
-        </p:txBody>
-      </p:sp>
       <p:pic>
         <p:nvPicPr>
-          <p:cNvPr id="4" name="Image 0" descr="C:\laragon\www\sistema\docs\cu-reales\capturas\cu1_paso2_modal.png">    </p:cNvPr>
+          <p:cNvPr id="3" name="Image 0" descr="C:\laragon\www\sistema\docs\cu-reales\capturas\cu1_paso2_modal.png">    </p:cNvPr>
           <p:cNvPicPr>
             <a:picLocks noChangeAspect="1"/>
           </p:cNvPicPr>
@@ -3620,7 +3581,7 @@
       </p:pic>
       <p:sp>
         <p:nvSpPr>
-          <p:cNvPr id="5" name="Text 2"/>
+          <p:cNvPr id="4" name="Text 1"/>
           <p:cNvSpPr/>
           <p:nvPr/>
         </p:nvSpPr>
@@ -3711,7 +3672,7 @@
         </p:nvSpPr>
         <p:spPr>
           <a:xfrm>
-            <a:off x="457200" y="201168"/>
+            <a:off x="457200" y="182880"/>
             <a:ext cx="11274552" cy="457200"/>
           </a:xfrm>
           <a:prstGeom prst="rect">
@@ -3742,48 +3703,9 @@
           </a:p>
         </p:txBody>
       </p:sp>
-      <p:sp>
-        <p:nvSpPr>
-          <p:cNvPr id="3" name="Text 1"/>
-          <p:cNvSpPr/>
-          <p:nvPr/>
-        </p:nvSpPr>
-        <p:spPr>
-          <a:xfrm>
-            <a:off x="457200" y="658368"/>
-            <a:ext cx="11274552" cy="320040"/>
-          </a:xfrm>
-          <a:prstGeom prst="rect">
-            <a:avLst/>
-          </a:prstGeom>
-          <a:noFill/>
-          <a:ln/>
-        </p:spPr>
-        <p:txBody>
-          <a:bodyPr wrap="square" lIns="0" tIns="0" rIns="0" bIns="0" rtlCol="0" anchor="ctr"/>
-          <a:lstStyle/>
-          <a:p>
-            <a:pPr indent="0" marL="0">
-              <a:buNone/>
-            </a:pPr>
-            <a:r>
-              <a:rPr lang="en-US" sz="1300" dirty="0">
-                <a:solidFill>
-                  <a:srgbClr val="64748B"/>
-                </a:solidFill>
-                <a:latin typeface="Segoe UI" pitchFamily="34" charset="0"/>
-                <a:ea typeface="Segoe UI" pitchFamily="34" charset="-122"/>
-                <a:cs typeface="Segoe UI" pitchFamily="34" charset="-120"/>
-              </a:rPr>
-              <a:t>Ejecución real en la web del sistema</a:t>
-            </a:r>
-            <a:endParaRPr lang="en-US" sz="1300" dirty="0"/>
-          </a:p>
-        </p:txBody>
-      </p:sp>
       <p:pic>
         <p:nvPicPr>
-          <p:cNvPr id="4" name="Image 0" descr="C:\laragon\www\sistema\docs\cu-reales\capturas\cu1_paso3_completo.png">    </p:cNvPr>
+          <p:cNvPr id="3" name="Image 0" descr="C:\laragon\www\sistema\docs\cu-reales\capturas\cu1_paso3_completo.png">    </p:cNvPr>
           <p:cNvPicPr>
             <a:picLocks noChangeAspect="1"/>
           </p:cNvPicPr>
@@ -3807,7 +3729,7 @@
       </p:pic>
       <p:sp>
         <p:nvSpPr>
-          <p:cNvPr id="5" name="Text 2"/>
+          <p:cNvPr id="4" name="Text 1"/>
           <p:cNvSpPr/>
           <p:nvPr/>
         </p:nvSpPr>
@@ -3898,7 +3820,7 @@
         </p:nvSpPr>
         <p:spPr>
           <a:xfrm>
-            <a:off x="457200" y="201168"/>
+            <a:off x="457200" y="182880"/>
             <a:ext cx="11274552" cy="457200"/>
           </a:xfrm>
           <a:prstGeom prst="rect">
@@ -3929,48 +3851,9 @@
           </a:p>
         </p:txBody>
       </p:sp>
-      <p:sp>
-        <p:nvSpPr>
-          <p:cNvPr id="3" name="Text 1"/>
-          <p:cNvSpPr/>
-          <p:nvPr/>
-        </p:nvSpPr>
-        <p:spPr>
-          <a:xfrm>
-            <a:off x="457200" y="658368"/>
-            <a:ext cx="11274552" cy="320040"/>
-          </a:xfrm>
-          <a:prstGeom prst="rect">
-            <a:avLst/>
-          </a:prstGeom>
-          <a:noFill/>
-          <a:ln/>
-        </p:spPr>
-        <p:txBody>
-          <a:bodyPr wrap="square" lIns="0" tIns="0" rIns="0" bIns="0" rtlCol="0" anchor="ctr"/>
-          <a:lstStyle/>
-          <a:p>
-            <a:pPr indent="0" marL="0">
-              <a:buNone/>
-            </a:pPr>
-            <a:r>
-              <a:rPr lang="en-US" sz="1300" dirty="0">
-                <a:solidFill>
-                  <a:srgbClr val="64748B"/>
-                </a:solidFill>
-                <a:latin typeface="Segoe UI" pitchFamily="34" charset="0"/>
-                <a:ea typeface="Segoe UI" pitchFamily="34" charset="-122"/>
-                <a:cs typeface="Segoe UI" pitchFamily="34" charset="-120"/>
-              </a:rPr>
-              <a:t>Ejecución real en la web del sistema</a:t>
-            </a:r>
-            <a:endParaRPr lang="en-US" sz="1300" dirty="0"/>
-          </a:p>
-        </p:txBody>
-      </p:sp>
       <p:pic>
         <p:nvPicPr>
-          <p:cNvPr id="4" name="Image 0" descr="C:\laragon\www\sistema\docs\cu-reales\capturas\cu1_paso4_guardado.png">    </p:cNvPr>
+          <p:cNvPr id="3" name="Image 0" descr="C:\laragon\www\sistema\docs\cu-reales\capturas\cu1_paso4_guardado.png">    </p:cNvPr>
           <p:cNvPicPr>
             <a:picLocks noChangeAspect="1"/>
           </p:cNvPicPr>
@@ -3994,7 +3877,7 @@
       </p:pic>
       <p:sp>
         <p:nvSpPr>
-          <p:cNvPr id="5" name="Text 2"/>
+          <p:cNvPr id="4" name="Text 1"/>
           <p:cNvSpPr/>
           <p:nvPr/>
         </p:nvSpPr>
@@ -4085,7 +3968,7 @@
         </p:nvSpPr>
         <p:spPr>
           <a:xfrm>
-            <a:off x="457200" y="201168"/>
+            <a:off x="457200" y="182880"/>
             <a:ext cx="11274552" cy="457200"/>
           </a:xfrm>
           <a:prstGeom prst="rect">
@@ -4116,48 +3999,9 @@
           </a:p>
         </p:txBody>
       </p:sp>
-      <p:sp>
-        <p:nvSpPr>
-          <p:cNvPr id="3" name="Text 1"/>
-          <p:cNvSpPr/>
-          <p:nvPr/>
-        </p:nvSpPr>
-        <p:spPr>
-          <a:xfrm>
-            <a:off x="457200" y="658368"/>
-            <a:ext cx="11274552" cy="320040"/>
-          </a:xfrm>
-          <a:prstGeom prst="rect">
-            <a:avLst/>
-          </a:prstGeom>
-          <a:noFill/>
-          <a:ln/>
-        </p:spPr>
-        <p:txBody>
-          <a:bodyPr wrap="square" lIns="0" tIns="0" rIns="0" bIns="0" rtlCol="0" anchor="ctr"/>
-          <a:lstStyle/>
-          <a:p>
-            <a:pPr indent="0" marL="0">
-              <a:buNone/>
-            </a:pPr>
-            <a:r>
-              <a:rPr lang="en-US" sz="1300" dirty="0">
-                <a:solidFill>
-                  <a:srgbClr val="64748B"/>
-                </a:solidFill>
-                <a:latin typeface="Segoe UI" pitchFamily="34" charset="0"/>
-                <a:ea typeface="Segoe UI" pitchFamily="34" charset="-122"/>
-                <a:cs typeface="Segoe UI" pitchFamily="34" charset="-120"/>
-              </a:rPr>
-              <a:t>Ejecución real en la web del sistema</a:t>
-            </a:r>
-            <a:endParaRPr lang="en-US" sz="1300" dirty="0"/>
-          </a:p>
-        </p:txBody>
-      </p:sp>
       <p:pic>
         <p:nvPicPr>
-          <p:cNvPr id="4" name="Image 0" descr="C:\laragon\www\sistema\docs\cu-reales\capturas\cu2_paso1_listado.png">    </p:cNvPr>
+          <p:cNvPr id="3" name="Image 0" descr="C:\laragon\www\sistema\docs\cu-reales\capturas\cu2_paso1_listado.png">    </p:cNvPr>
           <p:cNvPicPr>
             <a:picLocks noChangeAspect="1"/>
           </p:cNvPicPr>
@@ -4181,7 +4025,7 @@
       </p:pic>
       <p:sp>
         <p:nvSpPr>
-          <p:cNvPr id="5" name="Text 2"/>
+          <p:cNvPr id="4" name="Text 1"/>
           <p:cNvSpPr/>
           <p:nvPr/>
         </p:nvSpPr>
@@ -4272,7 +4116,7 @@
         </p:nvSpPr>
         <p:spPr>
           <a:xfrm>
-            <a:off x="457200" y="201168"/>
+            <a:off x="457200" y="182880"/>
             <a:ext cx="11274552" cy="457200"/>
           </a:xfrm>
           <a:prstGeom prst="rect">
@@ -4303,48 +4147,9 @@
           </a:p>
         </p:txBody>
       </p:sp>
-      <p:sp>
-        <p:nvSpPr>
-          <p:cNvPr id="3" name="Text 1"/>
-          <p:cNvSpPr/>
-          <p:nvPr/>
-        </p:nvSpPr>
-        <p:spPr>
-          <a:xfrm>
-            <a:off x="457200" y="658368"/>
-            <a:ext cx="11274552" cy="320040"/>
-          </a:xfrm>
-          <a:prstGeom prst="rect">
-            <a:avLst/>
-          </a:prstGeom>
-          <a:noFill/>
-          <a:ln/>
-        </p:spPr>
-        <p:txBody>
-          <a:bodyPr wrap="square" lIns="0" tIns="0" rIns="0" bIns="0" rtlCol="0" anchor="ctr"/>
-          <a:lstStyle/>
-          <a:p>
-            <a:pPr indent="0" marL="0">
-              <a:buNone/>
-            </a:pPr>
-            <a:r>
-              <a:rPr lang="en-US" sz="1300" dirty="0">
-                <a:solidFill>
-                  <a:srgbClr val="64748B"/>
-                </a:solidFill>
-                <a:latin typeface="Segoe UI" pitchFamily="34" charset="0"/>
-                <a:ea typeface="Segoe UI" pitchFamily="34" charset="-122"/>
-                <a:cs typeface="Segoe UI" pitchFamily="34" charset="-120"/>
-              </a:rPr>
-              <a:t>Ejecución real en la web del sistema</a:t>
-            </a:r>
-            <a:endParaRPr lang="en-US" sz="1300" dirty="0"/>
-          </a:p>
-        </p:txBody>
-      </p:sp>
       <p:pic>
         <p:nvPicPr>
-          <p:cNvPr id="4" name="Image 0" descr="C:\laragon\www\sistema\docs\cu-reales\capturas\cu2_paso2_filtro.png">    </p:cNvPr>
+          <p:cNvPr id="3" name="Image 0" descr="C:\laragon\www\sistema\docs\cu-reales\capturas\cu2_paso2_filtro.png">    </p:cNvPr>
           <p:cNvPicPr>
             <a:picLocks noChangeAspect="1"/>
           </p:cNvPicPr>
@@ -4368,7 +4173,7 @@
       </p:pic>
       <p:sp>
         <p:nvSpPr>
-          <p:cNvPr id="5" name="Text 2"/>
+          <p:cNvPr id="4" name="Text 1"/>
           <p:cNvSpPr/>
           <p:nvPr/>
         </p:nvSpPr>
@@ -4459,7 +4264,7 @@
         </p:nvSpPr>
         <p:spPr>
           <a:xfrm>
-            <a:off x="457200" y="201168"/>
+            <a:off x="457200" y="182880"/>
             <a:ext cx="11274552" cy="457200"/>
           </a:xfrm>
           <a:prstGeom prst="rect">
@@ -4490,48 +4295,9 @@
           </a:p>
         </p:txBody>
       </p:sp>
-      <p:sp>
-        <p:nvSpPr>
-          <p:cNvPr id="3" name="Text 1"/>
-          <p:cNvSpPr/>
-          <p:nvPr/>
-        </p:nvSpPr>
-        <p:spPr>
-          <a:xfrm>
-            <a:off x="457200" y="658368"/>
-            <a:ext cx="11274552" cy="320040"/>
-          </a:xfrm>
-          <a:prstGeom prst="rect">
-            <a:avLst/>
-          </a:prstGeom>
-          <a:noFill/>
-          <a:ln/>
-        </p:spPr>
-        <p:txBody>
-          <a:bodyPr wrap="square" lIns="0" tIns="0" rIns="0" bIns="0" rtlCol="0" anchor="ctr"/>
-          <a:lstStyle/>
-          <a:p>
-            <a:pPr indent="0" marL="0">
-              <a:buNone/>
-            </a:pPr>
-            <a:r>
-              <a:rPr lang="en-US" sz="1300" dirty="0">
-                <a:solidFill>
-                  <a:srgbClr val="64748B"/>
-                </a:solidFill>
-                <a:latin typeface="Segoe UI" pitchFamily="34" charset="0"/>
-                <a:ea typeface="Segoe UI" pitchFamily="34" charset="-122"/>
-                <a:cs typeface="Segoe UI" pitchFamily="34" charset="-120"/>
-              </a:rPr>
-              <a:t>Ejecución real en la web del sistema</a:t>
-            </a:r>
-            <a:endParaRPr lang="en-US" sz="1300" dirty="0"/>
-          </a:p>
-        </p:txBody>
-      </p:sp>
       <p:pic>
         <p:nvPicPr>
-          <p:cNvPr id="4" name="Image 0" descr="C:\laragon\www\sistema\docs\cu-reales\capturas\cu2_paso3_detalle.png">    </p:cNvPr>
+          <p:cNvPr id="3" name="Image 0" descr="C:\laragon\www\sistema\docs\cu-reales\capturas\cu2_paso3_detalle.png">    </p:cNvPr>
           <p:cNvPicPr>
             <a:picLocks noChangeAspect="1"/>
           </p:cNvPicPr>
@@ -4555,7 +4321,7 @@
       </p:pic>
       <p:sp>
         <p:nvSpPr>
-          <p:cNvPr id="5" name="Text 2"/>
+          <p:cNvPr id="4" name="Text 1"/>
           <p:cNvSpPr/>
           <p:nvPr/>
         </p:nvSpPr>
@@ -4646,7 +4412,7 @@
         </p:nvSpPr>
         <p:spPr>
           <a:xfrm>
-            <a:off x="457200" y="201168"/>
+            <a:off x="457200" y="182880"/>
             <a:ext cx="11274552" cy="457200"/>
           </a:xfrm>
           <a:prstGeom prst="rect">
@@ -4677,48 +4443,9 @@
           </a:p>
         </p:txBody>
       </p:sp>
-      <p:sp>
-        <p:nvSpPr>
-          <p:cNvPr id="3" name="Text 1"/>
-          <p:cNvSpPr/>
-          <p:nvPr/>
-        </p:nvSpPr>
-        <p:spPr>
-          <a:xfrm>
-            <a:off x="457200" y="658368"/>
-            <a:ext cx="11274552" cy="320040"/>
-          </a:xfrm>
-          <a:prstGeom prst="rect">
-            <a:avLst/>
-          </a:prstGeom>
-          <a:noFill/>
-          <a:ln/>
-        </p:spPr>
-        <p:txBody>
-          <a:bodyPr wrap="square" lIns="0" tIns="0" rIns="0" bIns="0" rtlCol="0" anchor="ctr"/>
-          <a:lstStyle/>
-          <a:p>
-            <a:pPr indent="0" marL="0">
-              <a:buNone/>
-            </a:pPr>
-            <a:r>
-              <a:rPr lang="en-US" sz="1300" dirty="0">
-                <a:solidFill>
-                  <a:srgbClr val="64748B"/>
-                </a:solidFill>
-                <a:latin typeface="Segoe UI" pitchFamily="34" charset="0"/>
-                <a:ea typeface="Segoe UI" pitchFamily="34" charset="-122"/>
-                <a:cs typeface="Segoe UI" pitchFamily="34" charset="-120"/>
-              </a:rPr>
-              <a:t>Ejecución real en la web del sistema</a:t>
-            </a:r>
-            <a:endParaRPr lang="en-US" sz="1300" dirty="0"/>
-          </a:p>
-        </p:txBody>
-      </p:sp>
       <p:pic>
         <p:nvPicPr>
-          <p:cNvPr id="4" name="Image 0" descr="C:\laragon\www\sistema\docs\cu-reales\capturas\cu3_paso1_modal.png">    </p:cNvPr>
+          <p:cNvPr id="3" name="Image 0" descr="C:\laragon\www\sistema\docs\cu-reales\capturas\cu3_paso1_modal.png">    </p:cNvPr>
           <p:cNvPicPr>
             <a:picLocks noChangeAspect="1"/>
           </p:cNvPicPr>
@@ -4742,7 +4469,7 @@
       </p:pic>
       <p:sp>
         <p:nvSpPr>
-          <p:cNvPr id="5" name="Text 2"/>
+          <p:cNvPr id="4" name="Text 1"/>
           <p:cNvSpPr/>
           <p:nvPr/>
         </p:nvSpPr>
@@ -4833,7 +4560,7 @@
         </p:nvSpPr>
         <p:spPr>
           <a:xfrm>
-            <a:off x="457200" y="201168"/>
+            <a:off x="457200" y="182880"/>
             <a:ext cx="11274552" cy="457200"/>
           </a:xfrm>
           <a:prstGeom prst="rect">
@@ -4864,48 +4591,9 @@
           </a:p>
         </p:txBody>
       </p:sp>
-      <p:sp>
-        <p:nvSpPr>
-          <p:cNvPr id="3" name="Text 1"/>
-          <p:cNvSpPr/>
-          <p:nvPr/>
-        </p:nvSpPr>
-        <p:spPr>
-          <a:xfrm>
-            <a:off x="457200" y="658368"/>
-            <a:ext cx="11274552" cy="320040"/>
-          </a:xfrm>
-          <a:prstGeom prst="rect">
-            <a:avLst/>
-          </a:prstGeom>
-          <a:noFill/>
-          <a:ln/>
-        </p:spPr>
-        <p:txBody>
-          <a:bodyPr wrap="square" lIns="0" tIns="0" rIns="0" bIns="0" rtlCol="0" anchor="ctr"/>
-          <a:lstStyle/>
-          <a:p>
-            <a:pPr indent="0" marL="0">
-              <a:buNone/>
-            </a:pPr>
-            <a:r>
-              <a:rPr lang="en-US" sz="1300" dirty="0">
-                <a:solidFill>
-                  <a:srgbClr val="64748B"/>
-                </a:solidFill>
-                <a:latin typeface="Segoe UI" pitchFamily="34" charset="0"/>
-                <a:ea typeface="Segoe UI" pitchFamily="34" charset="-122"/>
-                <a:cs typeface="Segoe UI" pitchFamily="34" charset="-120"/>
-              </a:rPr>
-              <a:t>Ejecución real en la web del sistema</a:t>
-            </a:r>
-            <a:endParaRPr lang="en-US" sz="1300" dirty="0"/>
-          </a:p>
-        </p:txBody>
-      </p:sp>
       <p:pic>
         <p:nvPicPr>
-          <p:cNvPr id="4" name="Image 0" descr="C:\laragon\www\sistema\docs\cu-reales\capturas\cu3_paso2_estado.png">    </p:cNvPr>
+          <p:cNvPr id="3" name="Image 0" descr="C:\laragon\www\sistema\docs\cu-reales\capturas\cu3_paso2_estado.png">    </p:cNvPr>
           <p:cNvPicPr>
             <a:picLocks noChangeAspect="1"/>
           </p:cNvPicPr>
@@ -4929,7 +4617,7 @@
       </p:pic>
       <p:sp>
         <p:nvSpPr>
-          <p:cNvPr id="5" name="Text 2"/>
+          <p:cNvPr id="4" name="Text 1"/>
           <p:cNvSpPr/>
           <p:nvPr/>
         </p:nvSpPr>
@@ -5020,7 +4708,7 @@
         </p:nvSpPr>
         <p:spPr>
           <a:xfrm>
-            <a:off x="457200" y="201168"/>
+            <a:off x="457200" y="182880"/>
             <a:ext cx="11274552" cy="457200"/>
           </a:xfrm>
           <a:prstGeom prst="rect">
@@ -5051,48 +4739,9 @@
           </a:p>
         </p:txBody>
       </p:sp>
-      <p:sp>
-        <p:nvSpPr>
-          <p:cNvPr id="3" name="Text 1"/>
-          <p:cNvSpPr/>
-          <p:nvPr/>
-        </p:nvSpPr>
-        <p:spPr>
-          <a:xfrm>
-            <a:off x="457200" y="658368"/>
-            <a:ext cx="11274552" cy="320040"/>
-          </a:xfrm>
-          <a:prstGeom prst="rect">
-            <a:avLst/>
-          </a:prstGeom>
-          <a:noFill/>
-          <a:ln/>
-        </p:spPr>
-        <p:txBody>
-          <a:bodyPr wrap="square" lIns="0" tIns="0" rIns="0" bIns="0" rtlCol="0" anchor="ctr"/>
-          <a:lstStyle/>
-          <a:p>
-            <a:pPr indent="0" marL="0">
-              <a:buNone/>
-            </a:pPr>
-            <a:r>
-              <a:rPr lang="en-US" sz="1300" dirty="0">
-                <a:solidFill>
-                  <a:srgbClr val="64748B"/>
-                </a:solidFill>
-                <a:latin typeface="Segoe UI" pitchFamily="34" charset="0"/>
-                <a:ea typeface="Segoe UI" pitchFamily="34" charset="-122"/>
-                <a:cs typeface="Segoe UI" pitchFamily="34" charset="-120"/>
-              </a:rPr>
-              <a:t>Ejecución real en la web del sistema</a:t>
-            </a:r>
-            <a:endParaRPr lang="en-US" sz="1300" dirty="0"/>
-          </a:p>
-        </p:txBody>
-      </p:sp>
       <p:pic>
         <p:nvPicPr>
-          <p:cNvPr id="4" name="Image 0" descr="C:\laragon\www\sistema\docs\cu-reales\capturas\cu3_paso3_movida.png">    </p:cNvPr>
+          <p:cNvPr id="3" name="Image 0" descr="C:\laragon\www\sistema\docs\cu-reales\capturas\cu3_paso3_movida.png">    </p:cNvPr>
           <p:cNvPicPr>
             <a:picLocks noChangeAspect="1"/>
           </p:cNvPicPr>
@@ -5116,7 +4765,7 @@
       </p:pic>
       <p:sp>
         <p:nvSpPr>
-          <p:cNvPr id="5" name="Text 2"/>
+          <p:cNvPr id="4" name="Text 1"/>
           <p:cNvSpPr/>
           <p:nvPr/>
         </p:nvSpPr>
@@ -5207,7 +4856,7 @@
         </p:nvSpPr>
         <p:spPr>
           <a:xfrm>
-            <a:off x="457200" y="201168"/>
+            <a:off x="457200" y="182880"/>
             <a:ext cx="11274552" cy="457200"/>
           </a:xfrm>
           <a:prstGeom prst="rect">
@@ -5238,48 +4887,9 @@
           </a:p>
         </p:txBody>
       </p:sp>
-      <p:sp>
-        <p:nvSpPr>
-          <p:cNvPr id="3" name="Text 1"/>
-          <p:cNvSpPr/>
-          <p:nvPr/>
-        </p:nvSpPr>
-        <p:spPr>
-          <a:xfrm>
-            <a:off x="457200" y="658368"/>
-            <a:ext cx="11274552" cy="320040"/>
-          </a:xfrm>
-          <a:prstGeom prst="rect">
-            <a:avLst/>
-          </a:prstGeom>
-          <a:noFill/>
-          <a:ln/>
-        </p:spPr>
-        <p:txBody>
-          <a:bodyPr wrap="square" lIns="0" tIns="0" rIns="0" bIns="0" rtlCol="0" anchor="ctr"/>
-          <a:lstStyle/>
-          <a:p>
-            <a:pPr indent="0" marL="0">
-              <a:buNone/>
-            </a:pPr>
-            <a:r>
-              <a:rPr lang="en-US" sz="1300" dirty="0">
-                <a:solidFill>
-                  <a:srgbClr val="64748B"/>
-                </a:solidFill>
-                <a:latin typeface="Segoe UI" pitchFamily="34" charset="0"/>
-                <a:ea typeface="Segoe UI" pitchFamily="34" charset="-122"/>
-                <a:cs typeface="Segoe UI" pitchFamily="34" charset="-120"/>
-              </a:rPr>
-              <a:t>Ejecución real en la web del sistema</a:t>
-            </a:r>
-            <a:endParaRPr lang="en-US" sz="1300" dirty="0"/>
-          </a:p>
-        </p:txBody>
-      </p:sp>
       <p:pic>
         <p:nvPicPr>
-          <p:cNvPr id="4" name="Image 0" descr="C:\laragon\www\sistema\docs\cu-reales\capturas\cu4_paso1_tablero.png">    </p:cNvPr>
+          <p:cNvPr id="3" name="Image 0" descr="C:\laragon\www\sistema\docs\cu-reales\capturas\cu4_paso1_tablero.png">    </p:cNvPr>
           <p:cNvPicPr>
             <a:picLocks noChangeAspect="1"/>
           </p:cNvPicPr>
@@ -5303,7 +4913,7 @@
       </p:pic>
       <p:sp>
         <p:nvSpPr>
-          <p:cNvPr id="5" name="Text 2"/>
+          <p:cNvPr id="4" name="Text 1"/>
           <p:cNvSpPr/>
           <p:nvPr/>
         </p:nvSpPr>
@@ -5394,7 +5004,7 @@
         </p:nvSpPr>
         <p:spPr>
           <a:xfrm>
-            <a:off x="457200" y="201168"/>
+            <a:off x="457200" y="182880"/>
             <a:ext cx="11274552" cy="457200"/>
           </a:xfrm>
           <a:prstGeom prst="rect">
@@ -5425,48 +5035,9 @@
           </a:p>
         </p:txBody>
       </p:sp>
-      <p:sp>
-        <p:nvSpPr>
-          <p:cNvPr id="3" name="Text 1"/>
-          <p:cNvSpPr/>
-          <p:nvPr/>
-        </p:nvSpPr>
-        <p:spPr>
-          <a:xfrm>
-            <a:off x="457200" y="658368"/>
-            <a:ext cx="11274552" cy="320040"/>
-          </a:xfrm>
-          <a:prstGeom prst="rect">
-            <a:avLst/>
-          </a:prstGeom>
-          <a:noFill/>
-          <a:ln/>
-        </p:spPr>
-        <p:txBody>
-          <a:bodyPr wrap="square" lIns="0" tIns="0" rIns="0" bIns="0" rtlCol="0" anchor="ctr"/>
-          <a:lstStyle/>
-          <a:p>
-            <a:pPr indent="0" marL="0">
-              <a:buNone/>
-            </a:pPr>
-            <a:r>
-              <a:rPr lang="en-US" sz="1300" dirty="0">
-                <a:solidFill>
-                  <a:srgbClr val="64748B"/>
-                </a:solidFill>
-                <a:latin typeface="Segoe UI" pitchFamily="34" charset="0"/>
-                <a:ea typeface="Segoe UI" pitchFamily="34" charset="-122"/>
-                <a:cs typeface="Segoe UI" pitchFamily="34" charset="-120"/>
-              </a:rPr>
-              <a:t>Diseño detallado del caso de uso (PlantUML, generado desde el código real)</a:t>
-            </a:r>
-            <a:endParaRPr lang="en-US" sz="1300" dirty="0"/>
-          </a:p>
-        </p:txBody>
-      </p:sp>
       <p:pic>
         <p:nvPicPr>
-          <p:cNvPr id="4" name="Image 0" descr="C:\laragon\www\sistema\docs\dsd\png-hd\01_pm_crea_proyecto.png">    </p:cNvPr>
+          <p:cNvPr id="3" name="Image 0" descr="C:\laragon\www\sistema\docs\dsd\png-hd\01_pm_crea_proyecto.png">    </p:cNvPr>
           <p:cNvPicPr>
             <a:picLocks noChangeAspect="1"/>
           </p:cNvPicPr>
@@ -5480,14 +5051,73 @@
         </p:blipFill>
         <p:spPr>
           <a:xfrm>
-            <a:off x="2382461" y="1051560"/>
-            <a:ext cx="7424030" cy="4663440"/>
+            <a:off x="3073915" y="777240"/>
+            <a:ext cx="6041122" cy="3794760"/>
           </a:xfrm>
           <a:prstGeom prst="rect">
             <a:avLst/>
           </a:prstGeom>
         </p:spPr>
       </p:pic>
+      <p:sp>
+        <p:nvSpPr>
+          <p:cNvPr id="4" name="Text 1"/>
+          <p:cNvSpPr/>
+          <p:nvPr/>
+        </p:nvSpPr>
+        <p:spPr>
+          <a:xfrm>
+            <a:off x="548640" y="4709160"/>
+            <a:ext cx="11091672" cy="1417320"/>
+          </a:xfrm>
+          <a:prstGeom prst="rect">
+            <a:avLst/>
+          </a:prstGeom>
+          <a:noFill/>
+          <a:ln/>
+        </p:spPr>
+        <p:txBody>
+          <a:bodyPr wrap="square" lIns="0" tIns="0" rIns="0" bIns="0" rtlCol="0" anchor="t"/>
+          <a:lstStyle/>
+          <a:p>
+            <a:pPr algn="l" indent="0" marL="0">
+              <a:lnSpc>
+                <a:spcPct val="115000"/>
+              </a:lnSpc>
+              <a:buNone/>
+            </a:pPr>
+            <a:r>
+              <a:rPr lang="en-US" sz="1350" b="1" dirty="0">
+                <a:solidFill>
+                  <a:srgbClr val="4F46E5"/>
+                </a:solidFill>
+                <a:latin typeface="Segoe UI" pitchFamily="34" charset="0"/>
+                <a:ea typeface="Segoe UI" pitchFamily="34" charset="-122"/>
+                <a:cs typeface="Segoe UI" pitchFamily="34" charset="-120"/>
+              </a:rPr>
+              <a:t>Qué representa: </a:t>
+            </a:r>
+            <a:pPr algn="l" indent="0" marL="0">
+              <a:lnSpc>
+                <a:spcPct val="115000"/>
+              </a:lnSpc>
+              <a:buNone/>
+            </a:pPr>
+            <a:r>
+              <a:rPr lang="en-US" sz="1350" dirty="0">
+                <a:solidFill>
+                  <a:srgbClr val="1F2937"/>
+                </a:solidFill>
+                <a:latin typeface="Segoe UI" pitchFamily="34" charset="0"/>
+                <a:ea typeface="Segoe UI" pitchFamily="34" charset="-122"/>
+                <a:cs typeface="Segoe UI" pitchFamily="34" charset="-120"/>
+              </a:rPr>
+              <a:t>El PM abre el formulario de creación y el sistema prepara los desplegables: la lista de clientes y la de usuarios que pueden actuar como Project Manager (mensajes create() y las consultas a Cliente y User). Al enviar el formulario, el controller valida los datos (nombre, fechas, estado, cliente y PM obligatorios). Si algo falla, vuelve al formulario mostrando los errores; si está todo correcto, crea el proyecto, lo guarda en la base de datos y vuelve al listado con el mensaje «Proyecto creado correctamente.»</a:t>
+            </a:r>
+            <a:endParaRPr lang="en-US" sz="1350" dirty="0"/>
+          </a:p>
+        </p:txBody>
+      </p:sp>
       <p:sp>
         <p:nvSpPr>
           <p:cNvPr id="5" name="Text 2"/>
@@ -5496,8 +5126,8 @@
         </p:nvSpPr>
         <p:spPr>
           <a:xfrm>
-            <a:off x="640080" y="5897880"/>
-            <a:ext cx="10908792" cy="731520"/>
+            <a:off x="548640" y="6263640"/>
+            <a:ext cx="11091672" cy="274320"/>
           </a:xfrm>
           <a:prstGeom prst="rect">
             <a:avLst/>
@@ -5506,24 +5136,24 @@
           <a:ln/>
         </p:spPr>
         <p:txBody>
-          <a:bodyPr wrap="square" lIns="0" tIns="0" rIns="0" bIns="0" rtlCol="0" anchor="t"/>
-          <a:lstStyle/>
-          <a:p>
-            <a:pPr algn="l" indent="0" marL="0">
-              <a:buNone/>
-            </a:pPr>
-            <a:r>
-              <a:rPr lang="en-US" sz="1300" dirty="0">
-                <a:solidFill>
-                  <a:srgbClr val="000000"/>
-                </a:solidFill>
-                <a:latin typeface="Segoe UI" pitchFamily="34" charset="0"/>
-                <a:ea typeface="Segoe UI" pitchFamily="34" charset="-122"/>
-                <a:cs typeface="Segoe UI" pitchFamily="34" charset="-120"/>
-              </a:rPr>
-              <a:t>create() carga clientes y usuarios · store(req) valida los datos · Proyecto::create(data) persiste y redirige con mensaje success</a:t>
-            </a:r>
-            <a:endParaRPr lang="en-US" sz="1300" dirty="0"/>
+          <a:bodyPr wrap="square" lIns="0" tIns="0" rIns="0" bIns="0" rtlCol="0" anchor="ctr"/>
+          <a:lstStyle/>
+          <a:p>
+            <a:pPr algn="r" indent="0" marL="0">
+              <a:buNone/>
+            </a:pPr>
+            <a:r>
+              <a:rPr lang="en-US" sz="1100" dirty="0">
+                <a:solidFill>
+                  <a:srgbClr val="64748B"/>
+                </a:solidFill>
+                <a:latin typeface="Segoe UI" pitchFamily="34" charset="0"/>
+                <a:ea typeface="Segoe UI" pitchFamily="34" charset="-122"/>
+                <a:cs typeface="Segoe UI" pitchFamily="34" charset="-120"/>
+              </a:rPr>
+              <a:t>Mensajes: create() · store(req) · validate · Proyecto::create(data) · redirect con success</a:t>
+            </a:r>
+            <a:endParaRPr lang="en-US" sz="1100" dirty="0"/>
           </a:p>
         </p:txBody>
       </p:sp>
@@ -5567,7 +5197,7 @@
         </p:nvSpPr>
         <p:spPr>
           <a:xfrm>
-            <a:off x="457200" y="201168"/>
+            <a:off x="457200" y="182880"/>
             <a:ext cx="11274552" cy="457200"/>
           </a:xfrm>
           <a:prstGeom prst="rect">
@@ -5598,48 +5228,9 @@
           </a:p>
         </p:txBody>
       </p:sp>
-      <p:sp>
-        <p:nvSpPr>
-          <p:cNvPr id="3" name="Text 1"/>
-          <p:cNvSpPr/>
-          <p:nvPr/>
-        </p:nvSpPr>
-        <p:spPr>
-          <a:xfrm>
-            <a:off x="457200" y="658368"/>
-            <a:ext cx="11274552" cy="320040"/>
-          </a:xfrm>
-          <a:prstGeom prst="rect">
-            <a:avLst/>
-          </a:prstGeom>
-          <a:noFill/>
-          <a:ln/>
-        </p:spPr>
-        <p:txBody>
-          <a:bodyPr wrap="square" lIns="0" tIns="0" rIns="0" bIns="0" rtlCol="0" anchor="ctr"/>
-          <a:lstStyle/>
-          <a:p>
-            <a:pPr indent="0" marL="0">
-              <a:buNone/>
-            </a:pPr>
-            <a:r>
-              <a:rPr lang="en-US" sz="1300" dirty="0">
-                <a:solidFill>
-                  <a:srgbClr val="64748B"/>
-                </a:solidFill>
-                <a:latin typeface="Segoe UI" pitchFamily="34" charset="0"/>
-                <a:ea typeface="Segoe UI" pitchFamily="34" charset="-122"/>
-                <a:cs typeface="Segoe UI" pitchFamily="34" charset="-120"/>
-              </a:rPr>
-              <a:t>Ejecución real en la web del sistema</a:t>
-            </a:r>
-            <a:endParaRPr lang="en-US" sz="1300" dirty="0"/>
-          </a:p>
-        </p:txBody>
-      </p:sp>
       <p:pic>
         <p:nvPicPr>
-          <p:cNvPr id="4" name="Image 0" descr="C:\laragon\www\sistema\docs\cu-reales\capturas\cu4_paso2_modal.png">    </p:cNvPr>
+          <p:cNvPr id="3" name="Image 0" descr="C:\laragon\www\sistema\docs\cu-reales\capturas\cu4_paso2_modal.png">    </p:cNvPr>
           <p:cNvPicPr>
             <a:picLocks noChangeAspect="1"/>
           </p:cNvPicPr>
@@ -5663,7 +5254,7 @@
       </p:pic>
       <p:sp>
         <p:nvSpPr>
-          <p:cNvPr id="5" name="Text 2"/>
+          <p:cNvPr id="4" name="Text 1"/>
           <p:cNvSpPr/>
           <p:nvPr/>
         </p:nvSpPr>
@@ -5754,7 +5345,7 @@
         </p:nvSpPr>
         <p:spPr>
           <a:xfrm>
-            <a:off x="457200" y="201168"/>
+            <a:off x="457200" y="182880"/>
             <a:ext cx="11274552" cy="457200"/>
           </a:xfrm>
           <a:prstGeom prst="rect">
@@ -5785,48 +5376,9 @@
           </a:p>
         </p:txBody>
       </p:sp>
-      <p:sp>
-        <p:nvSpPr>
-          <p:cNvPr id="3" name="Text 1"/>
-          <p:cNvSpPr/>
-          <p:nvPr/>
-        </p:nvSpPr>
-        <p:spPr>
-          <a:xfrm>
-            <a:off x="457200" y="658368"/>
-            <a:ext cx="11274552" cy="320040"/>
-          </a:xfrm>
-          <a:prstGeom prst="rect">
-            <a:avLst/>
-          </a:prstGeom>
-          <a:noFill/>
-          <a:ln/>
-        </p:spPr>
-        <p:txBody>
-          <a:bodyPr wrap="square" lIns="0" tIns="0" rIns="0" bIns="0" rtlCol="0" anchor="ctr"/>
-          <a:lstStyle/>
-          <a:p>
-            <a:pPr indent="0" marL="0">
-              <a:buNone/>
-            </a:pPr>
-            <a:r>
-              <a:rPr lang="en-US" sz="1300" dirty="0">
-                <a:solidFill>
-                  <a:srgbClr val="64748B"/>
-                </a:solidFill>
-                <a:latin typeface="Segoe UI" pitchFamily="34" charset="0"/>
-                <a:ea typeface="Segoe UI" pitchFamily="34" charset="-122"/>
-                <a:cs typeface="Segoe UI" pitchFamily="34" charset="-120"/>
-              </a:rPr>
-              <a:t>Ejecución real en la web del sistema</a:t>
-            </a:r>
-            <a:endParaRPr lang="en-US" sz="1300" dirty="0"/>
-          </a:p>
-        </p:txBody>
-      </p:sp>
       <p:pic>
         <p:nvPicPr>
-          <p:cNvPr id="4" name="Image 0" descr="C:\laragon\www\sistema\docs\cu-reales\capturas\cu4_paso3_confirmar.png">    </p:cNvPr>
+          <p:cNvPr id="3" name="Image 0" descr="C:\laragon\www\sistema\docs\cu-reales\capturas\cu4_paso3_confirmar.png">    </p:cNvPr>
           <p:cNvPicPr>
             <a:picLocks noChangeAspect="1"/>
           </p:cNvPicPr>
@@ -5850,7 +5402,7 @@
       </p:pic>
       <p:sp>
         <p:nvSpPr>
-          <p:cNvPr id="5" name="Text 2"/>
+          <p:cNvPr id="4" name="Text 1"/>
           <p:cNvSpPr/>
           <p:nvPr/>
         </p:nvSpPr>
@@ -5941,7 +5493,7 @@
         </p:nvSpPr>
         <p:spPr>
           <a:xfrm>
-            <a:off x="457200" y="201168"/>
+            <a:off x="457200" y="182880"/>
             <a:ext cx="11274552" cy="457200"/>
           </a:xfrm>
           <a:prstGeom prst="rect">
@@ -5972,48 +5524,9 @@
           </a:p>
         </p:txBody>
       </p:sp>
-      <p:sp>
-        <p:nvSpPr>
-          <p:cNvPr id="3" name="Text 1"/>
-          <p:cNvSpPr/>
-          <p:nvPr/>
-        </p:nvSpPr>
-        <p:spPr>
-          <a:xfrm>
-            <a:off x="457200" y="658368"/>
-            <a:ext cx="11274552" cy="320040"/>
-          </a:xfrm>
-          <a:prstGeom prst="rect">
-            <a:avLst/>
-          </a:prstGeom>
-          <a:noFill/>
-          <a:ln/>
-        </p:spPr>
-        <p:txBody>
-          <a:bodyPr wrap="square" lIns="0" tIns="0" rIns="0" bIns="0" rtlCol="0" anchor="ctr"/>
-          <a:lstStyle/>
-          <a:p>
-            <a:pPr indent="0" marL="0">
-              <a:buNone/>
-            </a:pPr>
-            <a:r>
-              <a:rPr lang="en-US" sz="1300" dirty="0">
-                <a:solidFill>
-                  <a:srgbClr val="64748B"/>
-                </a:solidFill>
-                <a:latin typeface="Segoe UI" pitchFamily="34" charset="0"/>
-                <a:ea typeface="Segoe UI" pitchFamily="34" charset="-122"/>
-                <a:cs typeface="Segoe UI" pitchFamily="34" charset="-120"/>
-              </a:rPr>
-              <a:t>Ejecución real en la web del sistema</a:t>
-            </a:r>
-            <a:endParaRPr lang="en-US" sz="1300" dirty="0"/>
-          </a:p>
-        </p:txBody>
-      </p:sp>
       <p:pic>
         <p:nvPicPr>
-          <p:cNvPr id="4" name="Image 0" descr="C:\laragon\www\sistema\docs\cu-reales\capturas\cu4_paso4_eliminada.png">    </p:cNvPr>
+          <p:cNvPr id="3" name="Image 0" descr="C:\laragon\www\sistema\docs\cu-reales\capturas\cu4_paso4_eliminada.png">    </p:cNvPr>
           <p:cNvPicPr>
             <a:picLocks noChangeAspect="1"/>
           </p:cNvPicPr>
@@ -6037,7 +5550,7 @@
       </p:pic>
       <p:sp>
         <p:nvSpPr>
-          <p:cNvPr id="5" name="Text 2"/>
+          <p:cNvPr id="4" name="Text 1"/>
           <p:cNvSpPr/>
           <p:nvPr/>
         </p:nvSpPr>
@@ -6128,7 +5641,7 @@
         </p:nvSpPr>
         <p:spPr>
           <a:xfrm>
-            <a:off x="457200" y="201168"/>
+            <a:off x="457200" y="182880"/>
             <a:ext cx="11274552" cy="457200"/>
           </a:xfrm>
           <a:prstGeom prst="rect">
@@ -6159,48 +5672,9 @@
           </a:p>
         </p:txBody>
       </p:sp>
-      <p:sp>
-        <p:nvSpPr>
-          <p:cNvPr id="3" name="Text 1"/>
-          <p:cNvSpPr/>
-          <p:nvPr/>
-        </p:nvSpPr>
-        <p:spPr>
-          <a:xfrm>
-            <a:off x="457200" y="658368"/>
-            <a:ext cx="11274552" cy="320040"/>
-          </a:xfrm>
-          <a:prstGeom prst="rect">
-            <a:avLst/>
-          </a:prstGeom>
-          <a:noFill/>
-          <a:ln/>
-        </p:spPr>
-        <p:txBody>
-          <a:bodyPr wrap="square" lIns="0" tIns="0" rIns="0" bIns="0" rtlCol="0" anchor="ctr"/>
-          <a:lstStyle/>
-          <a:p>
-            <a:pPr indent="0" marL="0">
-              <a:buNone/>
-            </a:pPr>
-            <a:r>
-              <a:rPr lang="en-US" sz="1300" dirty="0">
-                <a:solidFill>
-                  <a:srgbClr val="64748B"/>
-                </a:solidFill>
-                <a:latin typeface="Segoe UI" pitchFamily="34" charset="0"/>
-                <a:ea typeface="Segoe UI" pitchFamily="34" charset="-122"/>
-                <a:cs typeface="Segoe UI" pitchFamily="34" charset="-120"/>
-              </a:rPr>
-              <a:t>Ejecución real en la web del sistema</a:t>
-            </a:r>
-            <a:endParaRPr lang="en-US" sz="1300" dirty="0"/>
-          </a:p>
-        </p:txBody>
-      </p:sp>
       <p:pic>
         <p:nvPicPr>
-          <p:cNvPr id="4" name="Image 0" descr="C:\laragon\www\sistema\docs\cu-reales\capturas\cu5_paso1_listado.png">    </p:cNvPr>
+          <p:cNvPr id="3" name="Image 0" descr="C:\laragon\www\sistema\docs\cu-reales\capturas\cu5_paso1_listado.png">    </p:cNvPr>
           <p:cNvPicPr>
             <a:picLocks noChangeAspect="1"/>
           </p:cNvPicPr>
@@ -6224,7 +5698,7 @@
       </p:pic>
       <p:sp>
         <p:nvSpPr>
-          <p:cNvPr id="5" name="Text 2"/>
+          <p:cNvPr id="4" name="Text 1"/>
           <p:cNvSpPr/>
           <p:nvPr/>
         </p:nvSpPr>
@@ -6315,7 +5789,7 @@
         </p:nvSpPr>
         <p:spPr>
           <a:xfrm>
-            <a:off x="457200" y="201168"/>
+            <a:off x="457200" y="182880"/>
             <a:ext cx="11274552" cy="457200"/>
           </a:xfrm>
           <a:prstGeom prst="rect">
@@ -6346,48 +5820,9 @@
           </a:p>
         </p:txBody>
       </p:sp>
-      <p:sp>
-        <p:nvSpPr>
-          <p:cNvPr id="3" name="Text 1"/>
-          <p:cNvSpPr/>
-          <p:nvPr/>
-        </p:nvSpPr>
-        <p:spPr>
-          <a:xfrm>
-            <a:off x="457200" y="658368"/>
-            <a:ext cx="11274552" cy="320040"/>
-          </a:xfrm>
-          <a:prstGeom prst="rect">
-            <a:avLst/>
-          </a:prstGeom>
-          <a:noFill/>
-          <a:ln/>
-        </p:spPr>
-        <p:txBody>
-          <a:bodyPr wrap="square" lIns="0" tIns="0" rIns="0" bIns="0" rtlCol="0" anchor="ctr"/>
-          <a:lstStyle/>
-          <a:p>
-            <a:pPr indent="0" marL="0">
-              <a:buNone/>
-            </a:pPr>
-            <a:r>
-              <a:rPr lang="en-US" sz="1300" dirty="0">
-                <a:solidFill>
-                  <a:srgbClr val="64748B"/>
-                </a:solidFill>
-                <a:latin typeface="Segoe UI" pitchFamily="34" charset="0"/>
-                <a:ea typeface="Segoe UI" pitchFamily="34" charset="-122"/>
-                <a:cs typeface="Segoe UI" pitchFamily="34" charset="-120"/>
-              </a:rPr>
-              <a:t>Ejecución real en la web del sistema</a:t>
-            </a:r>
-            <a:endParaRPr lang="en-US" sz="1300" dirty="0"/>
-          </a:p>
-        </p:txBody>
-      </p:sp>
       <p:pic>
         <p:nvPicPr>
-          <p:cNvPr id="4" name="Image 0" descr="C:\laragon\www\sistema\docs\cu-reales\capturas\cu5_paso2_aprobada.png">    </p:cNvPr>
+          <p:cNvPr id="3" name="Image 0" descr="C:\laragon\www\sistema\docs\cu-reales\capturas\cu5_paso2_aprobada.png">    </p:cNvPr>
           <p:cNvPicPr>
             <a:picLocks noChangeAspect="1"/>
           </p:cNvPicPr>
@@ -6411,7 +5846,7 @@
       </p:pic>
       <p:sp>
         <p:nvSpPr>
-          <p:cNvPr id="5" name="Text 2"/>
+          <p:cNvPr id="4" name="Text 1"/>
           <p:cNvSpPr/>
           <p:nvPr/>
         </p:nvSpPr>
@@ -6502,7 +5937,7 @@
         </p:nvSpPr>
         <p:spPr>
           <a:xfrm>
-            <a:off x="457200" y="201168"/>
+            <a:off x="457200" y="182880"/>
             <a:ext cx="11274552" cy="457200"/>
           </a:xfrm>
           <a:prstGeom prst="rect">
@@ -6533,48 +5968,9 @@
           </a:p>
         </p:txBody>
       </p:sp>
-      <p:sp>
-        <p:nvSpPr>
-          <p:cNvPr id="3" name="Text 1"/>
-          <p:cNvSpPr/>
-          <p:nvPr/>
-        </p:nvSpPr>
-        <p:spPr>
-          <a:xfrm>
-            <a:off x="457200" y="658368"/>
-            <a:ext cx="11274552" cy="320040"/>
-          </a:xfrm>
-          <a:prstGeom prst="rect">
-            <a:avLst/>
-          </a:prstGeom>
-          <a:noFill/>
-          <a:ln/>
-        </p:spPr>
-        <p:txBody>
-          <a:bodyPr wrap="square" lIns="0" tIns="0" rIns="0" bIns="0" rtlCol="0" anchor="ctr"/>
-          <a:lstStyle/>
-          <a:p>
-            <a:pPr indent="0" marL="0">
-              <a:buNone/>
-            </a:pPr>
-            <a:r>
-              <a:rPr lang="en-US" sz="1300" dirty="0">
-                <a:solidFill>
-                  <a:srgbClr val="64748B"/>
-                </a:solidFill>
-                <a:latin typeface="Segoe UI" pitchFamily="34" charset="0"/>
-                <a:ea typeface="Segoe UI" pitchFamily="34" charset="-122"/>
-                <a:cs typeface="Segoe UI" pitchFamily="34" charset="-120"/>
-              </a:rPr>
-              <a:t>Ejecución real en la web del sistema</a:t>
-            </a:r>
-            <a:endParaRPr lang="en-US" sz="1300" dirty="0"/>
-          </a:p>
-        </p:txBody>
-      </p:sp>
       <p:pic>
         <p:nvPicPr>
-          <p:cNvPr id="4" name="Image 0" descr="C:\laragon\www\sistema\docs\cu-reales\capturas\cu5_paso3_guardada.png">    </p:cNvPr>
+          <p:cNvPr id="3" name="Image 0" descr="C:\laragon\www\sistema\docs\cu-reales\capturas\cu5_paso3_guardada.png">    </p:cNvPr>
           <p:cNvPicPr>
             <a:picLocks noChangeAspect="1"/>
           </p:cNvPicPr>
@@ -6598,7 +5994,7 @@
       </p:pic>
       <p:sp>
         <p:nvSpPr>
-          <p:cNvPr id="5" name="Text 2"/>
+          <p:cNvPr id="4" name="Text 1"/>
           <p:cNvSpPr/>
           <p:nvPr/>
         </p:nvSpPr>
@@ -6689,7 +6085,7 @@
         </p:nvSpPr>
         <p:spPr>
           <a:xfrm>
-            <a:off x="457200" y="201168"/>
+            <a:off x="457200" y="182880"/>
             <a:ext cx="11274552" cy="457200"/>
           </a:xfrm>
           <a:prstGeom prst="rect">
@@ -6720,48 +6116,9 @@
           </a:p>
         </p:txBody>
       </p:sp>
-      <p:sp>
-        <p:nvSpPr>
-          <p:cNvPr id="3" name="Text 1"/>
-          <p:cNvSpPr/>
-          <p:nvPr/>
-        </p:nvSpPr>
-        <p:spPr>
-          <a:xfrm>
-            <a:off x="457200" y="658368"/>
-            <a:ext cx="11274552" cy="320040"/>
-          </a:xfrm>
-          <a:prstGeom prst="rect">
-            <a:avLst/>
-          </a:prstGeom>
-          <a:noFill/>
-          <a:ln/>
-        </p:spPr>
-        <p:txBody>
-          <a:bodyPr wrap="square" lIns="0" tIns="0" rIns="0" bIns="0" rtlCol="0" anchor="ctr"/>
-          <a:lstStyle/>
-          <a:p>
-            <a:pPr indent="0" marL="0">
-              <a:buNone/>
-            </a:pPr>
-            <a:r>
-              <a:rPr lang="en-US" sz="1300" dirty="0">
-                <a:solidFill>
-                  <a:srgbClr val="64748B"/>
-                </a:solidFill>
-                <a:latin typeface="Segoe UI" pitchFamily="34" charset="0"/>
-                <a:ea typeface="Segoe UI" pitchFamily="34" charset="-122"/>
-                <a:cs typeface="Segoe UI" pitchFamily="34" charset="-120"/>
-              </a:rPr>
-              <a:t>Ejecución real en la web del sistema</a:t>
-            </a:r>
-            <a:endParaRPr lang="en-US" sz="1300" dirty="0"/>
-          </a:p>
-        </p:txBody>
-      </p:sp>
       <p:pic>
         <p:nvPicPr>
-          <p:cNvPr id="4" name="Image 0" descr="C:\laragon\www\sistema\docs\cu-reales\capturas\cu6_paso1_listado.png">    </p:cNvPr>
+          <p:cNvPr id="3" name="Image 0" descr="C:\laragon\www\sistema\docs\cu-reales\capturas\cu6_paso1_listado.png">    </p:cNvPr>
           <p:cNvPicPr>
             <a:picLocks noChangeAspect="1"/>
           </p:cNvPicPr>
@@ -6785,7 +6142,7 @@
       </p:pic>
       <p:sp>
         <p:nvSpPr>
-          <p:cNvPr id="5" name="Text 2"/>
+          <p:cNvPr id="4" name="Text 1"/>
           <p:cNvSpPr/>
           <p:nvPr/>
         </p:nvSpPr>
@@ -6876,7 +6233,7 @@
         </p:nvSpPr>
         <p:spPr>
           <a:xfrm>
-            <a:off x="457200" y="201168"/>
+            <a:off x="457200" y="182880"/>
             <a:ext cx="11274552" cy="457200"/>
           </a:xfrm>
           <a:prstGeom prst="rect">
@@ -6907,48 +6264,9 @@
           </a:p>
         </p:txBody>
       </p:sp>
-      <p:sp>
-        <p:nvSpPr>
-          <p:cNvPr id="3" name="Text 1"/>
-          <p:cNvSpPr/>
-          <p:nvPr/>
-        </p:nvSpPr>
-        <p:spPr>
-          <a:xfrm>
-            <a:off x="457200" y="658368"/>
-            <a:ext cx="11274552" cy="320040"/>
-          </a:xfrm>
-          <a:prstGeom prst="rect">
-            <a:avLst/>
-          </a:prstGeom>
-          <a:noFill/>
-          <a:ln/>
-        </p:spPr>
-        <p:txBody>
-          <a:bodyPr wrap="square" lIns="0" tIns="0" rIns="0" bIns="0" rtlCol="0" anchor="ctr"/>
-          <a:lstStyle/>
-          <a:p>
-            <a:pPr indent="0" marL="0">
-              <a:buNone/>
-            </a:pPr>
-            <a:r>
-              <a:rPr lang="en-US" sz="1300" dirty="0">
-                <a:solidFill>
-                  <a:srgbClr val="64748B"/>
-                </a:solidFill>
-                <a:latin typeface="Segoe UI" pitchFamily="34" charset="0"/>
-                <a:ea typeface="Segoe UI" pitchFamily="34" charset="-122"/>
-                <a:cs typeface="Segoe UI" pitchFamily="34" charset="-120"/>
-              </a:rPr>
-              <a:t>Ejecución real en la web del sistema</a:t>
-            </a:r>
-            <a:endParaRPr lang="en-US" sz="1300" dirty="0"/>
-          </a:p>
-        </p:txBody>
-      </p:sp>
       <p:pic>
         <p:nvPicPr>
-          <p:cNvPr id="4" name="Image 0" descr="C:\laragon\www\sistema\docs\cu-reales\capturas\cu6_paso2_aprobado.png">    </p:cNvPr>
+          <p:cNvPr id="3" name="Image 0" descr="C:\laragon\www\sistema\docs\cu-reales\capturas\cu6_paso2_aprobado.png">    </p:cNvPr>
           <p:cNvPicPr>
             <a:picLocks noChangeAspect="1"/>
           </p:cNvPicPr>
@@ -6972,7 +6290,7 @@
       </p:pic>
       <p:sp>
         <p:nvSpPr>
-          <p:cNvPr id="5" name="Text 2"/>
+          <p:cNvPr id="4" name="Text 1"/>
           <p:cNvSpPr/>
           <p:nvPr/>
         </p:nvSpPr>
@@ -7063,7 +6381,7 @@
         </p:nvSpPr>
         <p:spPr>
           <a:xfrm>
-            <a:off x="457200" y="201168"/>
+            <a:off x="457200" y="182880"/>
             <a:ext cx="11274552" cy="457200"/>
           </a:xfrm>
           <a:prstGeom prst="rect">
@@ -7094,48 +6412,9 @@
           </a:p>
         </p:txBody>
       </p:sp>
-      <p:sp>
-        <p:nvSpPr>
-          <p:cNvPr id="3" name="Text 1"/>
-          <p:cNvSpPr/>
-          <p:nvPr/>
-        </p:nvSpPr>
-        <p:spPr>
-          <a:xfrm>
-            <a:off x="457200" y="658368"/>
-            <a:ext cx="11274552" cy="320040"/>
-          </a:xfrm>
-          <a:prstGeom prst="rect">
-            <a:avLst/>
-          </a:prstGeom>
-          <a:noFill/>
-          <a:ln/>
-        </p:spPr>
-        <p:txBody>
-          <a:bodyPr wrap="square" lIns="0" tIns="0" rIns="0" bIns="0" rtlCol="0" anchor="ctr"/>
-          <a:lstStyle/>
-          <a:p>
-            <a:pPr indent="0" marL="0">
-              <a:buNone/>
-            </a:pPr>
-            <a:r>
-              <a:rPr lang="en-US" sz="1300" dirty="0">
-                <a:solidFill>
-                  <a:srgbClr val="64748B"/>
-                </a:solidFill>
-                <a:latin typeface="Segoe UI" pitchFamily="34" charset="0"/>
-                <a:ea typeface="Segoe UI" pitchFamily="34" charset="-122"/>
-                <a:cs typeface="Segoe UI" pitchFamily="34" charset="-120"/>
-              </a:rPr>
-              <a:t>Ejecución real en la web del sistema</a:t>
-            </a:r>
-            <a:endParaRPr lang="en-US" sz="1300" dirty="0"/>
-          </a:p>
-        </p:txBody>
-      </p:sp>
       <p:pic>
         <p:nvPicPr>
-          <p:cNvPr id="4" name="Image 0" descr="C:\laragon\www\sistema\docs\cu-reales\capturas\cu6_paso3_guardado.png">    </p:cNvPr>
+          <p:cNvPr id="3" name="Image 0" descr="C:\laragon\www\sistema\docs\cu-reales\capturas\cu6_paso3_guardado.png">    </p:cNvPr>
           <p:cNvPicPr>
             <a:picLocks noChangeAspect="1"/>
           </p:cNvPicPr>
@@ -7159,7 +6438,7 @@
       </p:pic>
       <p:sp>
         <p:nvSpPr>
-          <p:cNvPr id="5" name="Text 2"/>
+          <p:cNvPr id="4" name="Text 1"/>
           <p:cNvSpPr/>
           <p:nvPr/>
         </p:nvSpPr>
@@ -7360,7 +6639,7 @@
         </p:nvSpPr>
         <p:spPr>
           <a:xfrm>
-            <a:off x="457200" y="201168"/>
+            <a:off x="457200" y="182880"/>
             <a:ext cx="11274552" cy="457200"/>
           </a:xfrm>
           <a:prstGeom prst="rect">
@@ -7391,48 +6670,9 @@
           </a:p>
         </p:txBody>
       </p:sp>
-      <p:sp>
-        <p:nvSpPr>
-          <p:cNvPr id="3" name="Text 1"/>
-          <p:cNvSpPr/>
-          <p:nvPr/>
-        </p:nvSpPr>
-        <p:spPr>
-          <a:xfrm>
-            <a:off x="457200" y="658368"/>
-            <a:ext cx="11274552" cy="320040"/>
-          </a:xfrm>
-          <a:prstGeom prst="rect">
-            <a:avLst/>
-          </a:prstGeom>
-          <a:noFill/>
-          <a:ln/>
-        </p:spPr>
-        <p:txBody>
-          <a:bodyPr wrap="square" lIns="0" tIns="0" rIns="0" bIns="0" rtlCol="0" anchor="ctr"/>
-          <a:lstStyle/>
-          <a:p>
-            <a:pPr indent="0" marL="0">
-              <a:buNone/>
-            </a:pPr>
-            <a:r>
-              <a:rPr lang="en-US" sz="1300" dirty="0">
-                <a:solidFill>
-                  <a:srgbClr val="64748B"/>
-                </a:solidFill>
-                <a:latin typeface="Segoe UI" pitchFamily="34" charset="0"/>
-                <a:ea typeface="Segoe UI" pitchFamily="34" charset="-122"/>
-                <a:cs typeface="Segoe UI" pitchFamily="34" charset="-120"/>
-              </a:rPr>
-              <a:t>Diseño detallado del caso de uso (PlantUML, generado desde el código real)</a:t>
-            </a:r>
-            <a:endParaRPr lang="en-US" sz="1300" dirty="0"/>
-          </a:p>
-        </p:txBody>
-      </p:sp>
       <p:pic>
         <p:nvPicPr>
-          <p:cNvPr id="4" name="Image 0" descr="C:\laragon\www\sistema\docs\dsd\png-hd\02_programador_ve_tareas.png">    </p:cNvPr>
+          <p:cNvPr id="3" name="Image 0" descr="C:\laragon\www\sistema\docs\dsd\png-hd\02_programador_ve_tareas.png">    </p:cNvPr>
           <p:cNvPicPr>
             <a:picLocks noChangeAspect="1"/>
           </p:cNvPicPr>
@@ -7446,14 +6686,73 @@
         </p:blipFill>
         <p:spPr>
           <a:xfrm>
-            <a:off x="3661546" y="1051560"/>
-            <a:ext cx="4865860" cy="4663440"/>
+            <a:off x="4114739" y="777240"/>
+            <a:ext cx="3959474" cy="3794760"/>
           </a:xfrm>
           <a:prstGeom prst="rect">
             <a:avLst/>
           </a:prstGeom>
         </p:spPr>
       </p:pic>
+      <p:sp>
+        <p:nvSpPr>
+          <p:cNvPr id="4" name="Text 1"/>
+          <p:cNvSpPr/>
+          <p:nvPr/>
+        </p:nvSpPr>
+        <p:spPr>
+          <a:xfrm>
+            <a:off x="548640" y="4709160"/>
+            <a:ext cx="11091672" cy="1417320"/>
+          </a:xfrm>
+          <a:prstGeom prst="rect">
+            <a:avLst/>
+          </a:prstGeom>
+          <a:noFill/>
+          <a:ln/>
+        </p:spPr>
+        <p:txBody>
+          <a:bodyPr wrap="square" lIns="0" tIns="0" rIns="0" bIns="0" rtlCol="0" anchor="t"/>
+          <a:lstStyle/>
+          <a:p>
+            <a:pPr algn="l" indent="0" marL="0">
+              <a:lnSpc>
+                <a:spcPct val="115000"/>
+              </a:lnSpc>
+              <a:buNone/>
+            </a:pPr>
+            <a:r>
+              <a:rPr lang="en-US" sz="1350" b="1" dirty="0">
+                <a:solidFill>
+                  <a:srgbClr val="4F46E5"/>
+                </a:solidFill>
+                <a:latin typeface="Segoe UI" pitchFamily="34" charset="0"/>
+                <a:ea typeface="Segoe UI" pitchFamily="34" charset="-122"/>
+                <a:cs typeface="Segoe UI" pitchFamily="34" charset="-120"/>
+              </a:rPr>
+              <a:t>Qué representa: </a:t>
+            </a:r>
+            <a:pPr algn="l" indent="0" marL="0">
+              <a:lnSpc>
+                <a:spcPct val="115000"/>
+              </a:lnSpc>
+              <a:buNone/>
+            </a:pPr>
+            <a:r>
+              <a:rPr lang="en-US" sz="1350" dirty="0">
+                <a:solidFill>
+                  <a:srgbClr val="1F2937"/>
+                </a:solidFill>
+                <a:latin typeface="Segoe UI" pitchFamily="34" charset="0"/>
+                <a:ea typeface="Segoe UI" pitchFamily="34" charset="-122"/>
+                <a:cs typeface="Segoe UI" pitchFamily="34" charset="-120"/>
+              </a:rPr>
+              <a:t>El Programador entra al listado de tareas. Primero el sistema determina qué puede ver: si el usuario tuviera rol Cliente, solo vería las tareas de su empresa (scope visiblePara). Luego aplica la búsqueda y el filtro de estado elegidos y devuelve las tareas paginadas de a 15, cada una con su proyecto y su responsable ya cargados. Al abrir el detalle de una tarea, el sistema la busca por su id (Route Model Binding), verifica que el usuario tenga permiso para verla —si no, responde 403—, carga el proyecto, el asignado y la solicitud de cambio asociada, y muestra la ficha completa.</a:t>
+            </a:r>
+            <a:endParaRPr lang="en-US" sz="1350" dirty="0"/>
+          </a:p>
+        </p:txBody>
+      </p:sp>
       <p:sp>
         <p:nvSpPr>
           <p:cNvPr id="5" name="Text 2"/>
@@ -7462,8 +6761,8 @@
         </p:nvSpPr>
         <p:spPr>
           <a:xfrm>
-            <a:off x="640080" y="5897880"/>
-            <a:ext cx="10908792" cy="731520"/>
+            <a:off x="548640" y="6263640"/>
+            <a:ext cx="11091672" cy="274320"/>
           </a:xfrm>
           <a:prstGeom prst="rect">
             <a:avLst/>
@@ -7472,24 +6771,24 @@
           <a:ln/>
         </p:spPr>
         <p:txBody>
-          <a:bodyPr wrap="square" lIns="0" tIns="0" rIns="0" bIns="0" rtlCol="0" anchor="t"/>
-          <a:lstStyle/>
-          <a:p>
-            <a:pPr algn="l" indent="0" marL="0">
-              <a:buNone/>
-            </a:pPr>
-            <a:r>
-              <a:rPr lang="en-US" sz="1300" dirty="0">
-                <a:solidFill>
-                  <a:srgbClr val="000000"/>
-                </a:solidFill>
-                <a:latin typeface="Segoe UI" pitchFamily="34" charset="0"/>
-                <a:ea typeface="Segoe UI" pitchFamily="34" charset="-122"/>
-                <a:cs typeface="Segoe UI" pitchFamily="34" charset="-120"/>
-              </a:rPr>
-              <a:t>index() con visiblePara, filtros y paginación (15) · show(t) por Route Model Binding · 403 si puedeVer falla</a:t>
-            </a:r>
-            <a:endParaRPr lang="en-US" sz="1300" dirty="0"/>
+          <a:bodyPr wrap="square" lIns="0" tIns="0" rIns="0" bIns="0" rtlCol="0" anchor="ctr"/>
+          <a:lstStyle/>
+          <a:p>
+            <a:pPr algn="r" indent="0" marL="0">
+              <a:buNone/>
+            </a:pPr>
+            <a:r>
+              <a:rPr lang="en-US" sz="1100" dirty="0">
+                <a:solidFill>
+                  <a:srgbClr val="64748B"/>
+                </a:solidFill>
+                <a:latin typeface="Segoe UI" pitchFamily="34" charset="0"/>
+                <a:ea typeface="Segoe UI" pitchFamily="34" charset="-122"/>
+                <a:cs typeface="Segoe UI" pitchFamily="34" charset="-120"/>
+              </a:rPr>
+              <a:t>Mensajes: index() · visiblePara · when(q/estado) · paginate(15) · show(t) · puedeVer</a:t>
+            </a:r>
+            <a:endParaRPr lang="en-US" sz="1100" dirty="0"/>
           </a:p>
         </p:txBody>
       </p:sp>
@@ -7533,7 +6832,7 @@
         </p:nvSpPr>
         <p:spPr>
           <a:xfrm>
-            <a:off x="457200" y="201168"/>
+            <a:off x="457200" y="182880"/>
             <a:ext cx="11274552" cy="457200"/>
           </a:xfrm>
           <a:prstGeom prst="rect">
@@ -7564,48 +6863,9 @@
           </a:p>
         </p:txBody>
       </p:sp>
-      <p:sp>
-        <p:nvSpPr>
-          <p:cNvPr id="3" name="Text 1"/>
-          <p:cNvSpPr/>
-          <p:nvPr/>
-        </p:nvSpPr>
-        <p:spPr>
-          <a:xfrm>
-            <a:off x="457200" y="658368"/>
-            <a:ext cx="11274552" cy="320040"/>
-          </a:xfrm>
-          <a:prstGeom prst="rect">
-            <a:avLst/>
-          </a:prstGeom>
-          <a:noFill/>
-          <a:ln/>
-        </p:spPr>
-        <p:txBody>
-          <a:bodyPr wrap="square" lIns="0" tIns="0" rIns="0" bIns="0" rtlCol="0" anchor="ctr"/>
-          <a:lstStyle/>
-          <a:p>
-            <a:pPr indent="0" marL="0">
-              <a:buNone/>
-            </a:pPr>
-            <a:r>
-              <a:rPr lang="en-US" sz="1300" dirty="0">
-                <a:solidFill>
-                  <a:srgbClr val="64748B"/>
-                </a:solidFill>
-                <a:latin typeface="Segoe UI" pitchFamily="34" charset="0"/>
-                <a:ea typeface="Segoe UI" pitchFamily="34" charset="-122"/>
-                <a:cs typeface="Segoe UI" pitchFamily="34" charset="-120"/>
-              </a:rPr>
-              <a:t>Diseño detallado del caso de uso (PlantUML, generado desde el código real)</a:t>
-            </a:r>
-            <a:endParaRPr lang="en-US" sz="1300" dirty="0"/>
-          </a:p>
-        </p:txBody>
-      </p:sp>
       <p:pic>
         <p:nvPicPr>
-          <p:cNvPr id="4" name="Image 0" descr="C:\laragon\www\sistema\docs\dsd\png-hd\03_edita_tarea_tablero.png">    </p:cNvPr>
+          <p:cNvPr id="3" name="Image 0" descr="C:\laragon\www\sistema\docs\dsd\png-hd\03_edita_tarea_tablero.png">    </p:cNvPr>
           <p:cNvPicPr>
             <a:picLocks noChangeAspect="1"/>
           </p:cNvPicPr>
@@ -7619,14 +6879,73 @@
         </p:blipFill>
         <p:spPr>
           <a:xfrm>
-            <a:off x="2994538" y="1051560"/>
-            <a:ext cx="6199877" cy="4663440"/>
+            <a:off x="3571977" y="777240"/>
+            <a:ext cx="5044998" cy="3794760"/>
           </a:xfrm>
           <a:prstGeom prst="rect">
             <a:avLst/>
           </a:prstGeom>
         </p:spPr>
       </p:pic>
+      <p:sp>
+        <p:nvSpPr>
+          <p:cNvPr id="4" name="Text 1"/>
+          <p:cNvSpPr/>
+          <p:nvPr/>
+        </p:nvSpPr>
+        <p:spPr>
+          <a:xfrm>
+            <a:off x="548640" y="4709160"/>
+            <a:ext cx="11091672" cy="1417320"/>
+          </a:xfrm>
+          <a:prstGeom prst="rect">
+            <a:avLst/>
+          </a:prstGeom>
+          <a:noFill/>
+          <a:ln/>
+        </p:spPr>
+        <p:txBody>
+          <a:bodyPr wrap="square" lIns="0" tIns="0" rIns="0" bIns="0" rtlCol="0" anchor="t"/>
+          <a:lstStyle/>
+          <a:p>
+            <a:pPr algn="l" indent="0" marL="0">
+              <a:lnSpc>
+                <a:spcPct val="115000"/>
+              </a:lnSpc>
+              <a:buNone/>
+            </a:pPr>
+            <a:r>
+              <a:rPr lang="en-US" sz="1350" b="1" dirty="0">
+                <a:solidFill>
+                  <a:srgbClr val="4F46E5"/>
+                </a:solidFill>
+                <a:latin typeface="Segoe UI" pitchFamily="34" charset="0"/>
+                <a:ea typeface="Segoe UI" pitchFamily="34" charset="-122"/>
+                <a:cs typeface="Segoe UI" pitchFamily="34" charset="-120"/>
+              </a:rPr>
+              <a:t>Qué representa: </a:t>
+            </a:r>
+            <a:pPr algn="l" indent="0" marL="0">
+              <a:lnSpc>
+                <a:spcPct val="115000"/>
+              </a:lnSpc>
+              <a:buNone/>
+            </a:pPr>
+            <a:r>
+              <a:rPr lang="en-US" sz="1350" dirty="0">
+                <a:solidFill>
+                  <a:srgbClr val="1F2937"/>
+                </a:solidFill>
+                <a:latin typeface="Segoe UI" pitchFamily="34" charset="0"/>
+                <a:ea typeface="Segoe UI" pitchFamily="34" charset="-122"/>
+                <a:cs typeface="Segoe UI" pitchFamily="34" charset="-120"/>
+              </a:rPr>
+              <a:t>El PM abre una tarjeta del tablero: el modal «Editar tarea» se completa con los datos que la tarjeta guarda en su atributo data-tarea. Al cambiar el estado a «En progreso» y guardar, el navegador envía una petición PATCH con JSON al servidor, que valida los campos. Si la validación falla responde 422 con los errores; si es correcta, actualiza la tarea en la base de datos (update = fill + save) y responde 200 con la tarea ya actualizada y sus relaciones. El JavaScript entonces reemplaza la tarjeta y la mueve a su nueva columna sin recargar la página.</a:t>
+            </a:r>
+            <a:endParaRPr lang="en-US" sz="1350" dirty="0"/>
+          </a:p>
+        </p:txBody>
+      </p:sp>
       <p:sp>
         <p:nvSpPr>
           <p:cNvPr id="5" name="Text 2"/>
@@ -7635,8 +6954,8 @@
         </p:nvSpPr>
         <p:spPr>
           <a:xfrm>
-            <a:off x="640080" y="5897880"/>
-            <a:ext cx="10908792" cy="731520"/>
+            <a:off x="548640" y="6263640"/>
+            <a:ext cx="11091672" cy="274320"/>
           </a:xfrm>
           <a:prstGeom prst="rect">
             <a:avLst/>
@@ -7645,24 +6964,24 @@
           <a:ln/>
         </p:spPr>
         <p:txBody>
-          <a:bodyPr wrap="square" lIns="0" tIns="0" rIns="0" bIns="0" rtlCol="0" anchor="t"/>
-          <a:lstStyle/>
-          <a:p>
-            <a:pPr algn="l" indent="0" marL="0">
-              <a:buNone/>
-            </a:pPr>
-            <a:r>
-              <a:rPr lang="en-US" sz="1300" dirty="0">
-                <a:solidFill>
-                  <a:srgbClr val="000000"/>
-                </a:solidFill>
-                <a:latin typeface="Segoe UI" pitchFamily="34" charset="0"/>
-                <a:ea typeface="Segoe UI" pitchFamily="34" charset="-122"/>
-                <a:cs typeface="Segoe UI" pitchFamily="34" charset="-120"/>
-              </a:rPr>
-              <a:t>PATCH AJAX con JSON · 422 con errores / 200 con la tarea · el JS mueve la tarjeta sin recargar</a:t>
-            </a:r>
-            <a:endParaRPr lang="en-US" sz="1300" dirty="0"/>
+          <a:bodyPr wrap="square" lIns="0" tIns="0" rIns="0" bIns="0" rtlCol="0" anchor="ctr"/>
+          <a:lstStyle/>
+          <a:p>
+            <a:pPr algn="r" indent="0" marL="0">
+              <a:buNone/>
+            </a:pPr>
+            <a:r>
+              <a:rPr lang="en-US" sz="1100" dirty="0">
+                <a:solidFill>
+                  <a:srgbClr val="64748B"/>
+                </a:solidFill>
+                <a:latin typeface="Segoe UI" pitchFamily="34" charset="0"/>
+                <a:ea typeface="Segoe UI" pitchFamily="34" charset="-122"/>
+                <a:cs typeface="Segoe UI" pitchFamily="34" charset="-120"/>
+              </a:rPr>
+              <a:t>Mensajes: update(req, t) · validate · update(data) · 422 con errores / 200 JSON</a:t>
+            </a:r>
+            <a:endParaRPr lang="en-US" sz="1100" dirty="0"/>
           </a:p>
         </p:txBody>
       </p:sp>
@@ -7706,7 +7025,7 @@
         </p:nvSpPr>
         <p:spPr>
           <a:xfrm>
-            <a:off x="457200" y="201168"/>
+            <a:off x="457200" y="182880"/>
             <a:ext cx="11274552" cy="457200"/>
           </a:xfrm>
           <a:prstGeom prst="rect">
@@ -7737,48 +7056,9 @@
           </a:p>
         </p:txBody>
       </p:sp>
-      <p:sp>
-        <p:nvSpPr>
-          <p:cNvPr id="3" name="Text 1"/>
-          <p:cNvSpPr/>
-          <p:nvPr/>
-        </p:nvSpPr>
-        <p:spPr>
-          <a:xfrm>
-            <a:off x="457200" y="658368"/>
-            <a:ext cx="11274552" cy="320040"/>
-          </a:xfrm>
-          <a:prstGeom prst="rect">
-            <a:avLst/>
-          </a:prstGeom>
-          <a:noFill/>
-          <a:ln/>
-        </p:spPr>
-        <p:txBody>
-          <a:bodyPr wrap="square" lIns="0" tIns="0" rIns="0" bIns="0" rtlCol="0" anchor="ctr"/>
-          <a:lstStyle/>
-          <a:p>
-            <a:pPr indent="0" marL="0">
-              <a:buNone/>
-            </a:pPr>
-            <a:r>
-              <a:rPr lang="en-US" sz="1300" dirty="0">
-                <a:solidFill>
-                  <a:srgbClr val="64748B"/>
-                </a:solidFill>
-                <a:latin typeface="Segoe UI" pitchFamily="34" charset="0"/>
-                <a:ea typeface="Segoe UI" pitchFamily="34" charset="-122"/>
-                <a:cs typeface="Segoe UI" pitchFamily="34" charset="-120"/>
-              </a:rPr>
-              <a:t>Diseño detallado del caso de uso (PlantUML, generado desde el código real)</a:t>
-            </a:r>
-            <a:endParaRPr lang="en-US" sz="1300" dirty="0"/>
-          </a:p>
-        </p:txBody>
-      </p:sp>
       <p:pic>
         <p:nvPicPr>
-          <p:cNvPr id="4" name="Image 0" descr="C:\laragon\www\sistema\docs\dsd\png-hd\04_pm_elimina_tarea.png">    </p:cNvPr>
+          <p:cNvPr id="3" name="Image 0" descr="C:\laragon\www\sistema\docs\dsd\png-hd\04_pm_elimina_tarea.png">    </p:cNvPr>
           <p:cNvPicPr>
             <a:picLocks noChangeAspect="1"/>
           </p:cNvPicPr>
@@ -7792,14 +7072,73 @@
         </p:blipFill>
         <p:spPr>
           <a:xfrm>
-            <a:off x="1821001" y="1051560"/>
-            <a:ext cx="8546951" cy="4663440"/>
+            <a:off x="2617040" y="777240"/>
+            <a:ext cx="6954872" cy="3794760"/>
           </a:xfrm>
           <a:prstGeom prst="rect">
             <a:avLst/>
           </a:prstGeom>
         </p:spPr>
       </p:pic>
+      <p:sp>
+        <p:nvSpPr>
+          <p:cNvPr id="4" name="Text 1"/>
+          <p:cNvSpPr/>
+          <p:nvPr/>
+        </p:nvSpPr>
+        <p:spPr>
+          <a:xfrm>
+            <a:off x="548640" y="4709160"/>
+            <a:ext cx="11091672" cy="1417320"/>
+          </a:xfrm>
+          <a:prstGeom prst="rect">
+            <a:avLst/>
+          </a:prstGeom>
+          <a:noFill/>
+          <a:ln/>
+        </p:spPr>
+        <p:txBody>
+          <a:bodyPr wrap="square" lIns="0" tIns="0" rIns="0" bIns="0" rtlCol="0" anchor="t"/>
+          <a:lstStyle/>
+          <a:p>
+            <a:pPr algn="l" indent="0" marL="0">
+              <a:lnSpc>
+                <a:spcPct val="115000"/>
+              </a:lnSpc>
+              <a:buNone/>
+            </a:pPr>
+            <a:r>
+              <a:rPr lang="en-US" sz="1350" b="1" dirty="0">
+                <a:solidFill>
+                  <a:srgbClr val="4F46E5"/>
+                </a:solidFill>
+                <a:latin typeface="Segoe UI" pitchFamily="34" charset="0"/>
+                <a:ea typeface="Segoe UI" pitchFamily="34" charset="-122"/>
+                <a:cs typeface="Segoe UI" pitchFamily="34" charset="-120"/>
+              </a:rPr>
+              <a:t>Qué representa: </a:t>
+            </a:r>
+            <a:pPr algn="l" indent="0" marL="0">
+              <a:lnSpc>
+                <a:spcPct val="115000"/>
+              </a:lnSpc>
+              <a:buNone/>
+            </a:pPr>
+            <a:r>
+              <a:rPr lang="en-US" sz="1350" dirty="0">
+                <a:solidFill>
+                  <a:srgbClr val="1F2937"/>
+                </a:solidFill>
+                <a:latin typeface="Segoe UI" pitchFamily="34" charset="0"/>
+                <a:ea typeface="Segoe UI" pitchFamily="34" charset="-122"/>
+                <a:cs typeface="Segoe UI" pitchFamily="34" charset="-120"/>
+              </a:rPr>
+              <a:t>El PM pulsa «Eliminar» dentro del modal de la tarea y el sistema pide confirmación con un modal propio, no con el confirm() del navegador. Al confirmar, se envía DELETE /tareas/{id}: el sistema busca la tarea por su id y la borra de la base de datos con delete(). Responde 200 con {ok:true} y el JavaScript quita la tarjeta del tablero y actualiza los contadores de cada columna, sin recargar. Si la tarea no existiera, el Route Model Binding responde 404 antes de llegar al controller.</a:t>
+            </a:r>
+            <a:endParaRPr lang="en-US" sz="1350" dirty="0"/>
+          </a:p>
+        </p:txBody>
+      </p:sp>
       <p:sp>
         <p:nvSpPr>
           <p:cNvPr id="5" name="Text 2"/>
@@ -7808,8 +7147,8 @@
         </p:nvSpPr>
         <p:spPr>
           <a:xfrm>
-            <a:off x="640080" y="5897880"/>
-            <a:ext cx="10908792" cy="731520"/>
+            <a:off x="548640" y="6263640"/>
+            <a:ext cx="11091672" cy="274320"/>
           </a:xfrm>
           <a:prstGeom prst="rect">
             <a:avLst/>
@@ -7818,24 +7157,24 @@
           <a:ln/>
         </p:spPr>
         <p:txBody>
-          <a:bodyPr wrap="square" lIns="0" tIns="0" rIns="0" bIns="0" rtlCol="0" anchor="t"/>
-          <a:lstStyle/>
-          <a:p>
-            <a:pPr algn="l" indent="0" marL="0">
-              <a:buNone/>
-            </a:pPr>
-            <a:r>
-              <a:rPr lang="en-US" sz="1300" dirty="0">
-                <a:solidFill>
-                  <a:srgbClr val="000000"/>
-                </a:solidFill>
-                <a:latin typeface="Segoe UI" pitchFamily="34" charset="0"/>
-                <a:ea typeface="Segoe UI" pitchFamily="34" charset="-122"/>
-                <a:cs typeface="Segoe UI" pitchFamily="34" charset="-120"/>
-              </a:rPr>
-              <a:t>DELETE AJAX · confirmación con modal propio · 200 {ok:true} y la tarjeta desaparece</a:t>
-            </a:r>
-            <a:endParaRPr lang="en-US" sz="1300" dirty="0"/>
+          <a:bodyPr wrap="square" lIns="0" tIns="0" rIns="0" bIns="0" rtlCol="0" anchor="ctr"/>
+          <a:lstStyle/>
+          <a:p>
+            <a:pPr algn="r" indent="0" marL="0">
+              <a:buNone/>
+            </a:pPr>
+            <a:r>
+              <a:rPr lang="en-US" sz="1100" dirty="0">
+                <a:solidFill>
+                  <a:srgbClr val="64748B"/>
+                </a:solidFill>
+                <a:latin typeface="Segoe UI" pitchFamily="34" charset="0"/>
+                <a:ea typeface="Segoe UI" pitchFamily="34" charset="-122"/>
+                <a:cs typeface="Segoe UI" pitchFamily="34" charset="-120"/>
+              </a:rPr>
+              <a:t>Mensajes: destroy(req, t) · delete() : bool · 200 {ok:true} · 404 si no existe</a:t>
+            </a:r>
+            <a:endParaRPr lang="en-US" sz="1100" dirty="0"/>
           </a:p>
         </p:txBody>
       </p:sp>
@@ -7879,7 +7218,7 @@
         </p:nvSpPr>
         <p:spPr>
           <a:xfrm>
-            <a:off x="457200" y="201168"/>
+            <a:off x="457200" y="182880"/>
             <a:ext cx="11274552" cy="457200"/>
           </a:xfrm>
           <a:prstGeom prst="rect">
@@ -7910,48 +7249,9 @@
           </a:p>
         </p:txBody>
       </p:sp>
-      <p:sp>
-        <p:nvSpPr>
-          <p:cNvPr id="3" name="Text 1"/>
-          <p:cNvSpPr/>
-          <p:nvPr/>
-        </p:nvSpPr>
-        <p:spPr>
-          <a:xfrm>
-            <a:off x="457200" y="658368"/>
-            <a:ext cx="11274552" cy="320040"/>
-          </a:xfrm>
-          <a:prstGeom prst="rect">
-            <a:avLst/>
-          </a:prstGeom>
-          <a:noFill/>
-          <a:ln/>
-        </p:spPr>
-        <p:txBody>
-          <a:bodyPr wrap="square" lIns="0" tIns="0" rIns="0" bIns="0" rtlCol="0" anchor="ctr"/>
-          <a:lstStyle/>
-          <a:p>
-            <a:pPr indent="0" marL="0">
-              <a:buNone/>
-            </a:pPr>
-            <a:r>
-              <a:rPr lang="en-US" sz="1300" dirty="0">
-                <a:solidFill>
-                  <a:srgbClr val="64748B"/>
-                </a:solidFill>
-                <a:latin typeface="Segoe UI" pitchFamily="34" charset="0"/>
-                <a:ea typeface="Segoe UI" pitchFamily="34" charset="-122"/>
-                <a:cs typeface="Segoe UI" pitchFamily="34" charset="-120"/>
-              </a:rPr>
-              <a:t>Diseño detallado del caso de uso (PlantUML, generado desde el código real)</a:t>
-            </a:r>
-            <a:endParaRPr lang="en-US" sz="1300" dirty="0"/>
-          </a:p>
-        </p:txBody>
-      </p:sp>
       <p:pic>
         <p:nvPicPr>
-          <p:cNvPr id="4" name="Image 0" descr="C:\laragon\www\sistema\docs\dsd\png-hd\05_jefe_aprueba_solicitud.png">    </p:cNvPr>
+          <p:cNvPr id="3" name="Image 0" descr="C:\laragon\www\sistema\docs\dsd\png-hd\05_jefe_aprueba_solicitud.png">    </p:cNvPr>
           <p:cNvPicPr>
             <a:picLocks noChangeAspect="1"/>
           </p:cNvPicPr>
@@ -7965,14 +7265,73 @@
         </p:blipFill>
         <p:spPr>
           <a:xfrm>
-            <a:off x="2614371" y="1051560"/>
-            <a:ext cx="6960209" cy="4663440"/>
+            <a:off x="3262626" y="777240"/>
+            <a:ext cx="5663700" cy="3794760"/>
           </a:xfrm>
           <a:prstGeom prst="rect">
             <a:avLst/>
           </a:prstGeom>
         </p:spPr>
       </p:pic>
+      <p:sp>
+        <p:nvSpPr>
+          <p:cNvPr id="4" name="Text 1"/>
+          <p:cNvSpPr/>
+          <p:nvPr/>
+        </p:nvSpPr>
+        <p:spPr>
+          <a:xfrm>
+            <a:off x="548640" y="4709160"/>
+            <a:ext cx="11091672" cy="1417320"/>
+          </a:xfrm>
+          <a:prstGeom prst="rect">
+            <a:avLst/>
+          </a:prstGeom>
+          <a:noFill/>
+          <a:ln/>
+        </p:spPr>
+        <p:txBody>
+          <a:bodyPr wrap="square" lIns="0" tIns="0" rIns="0" bIns="0" rtlCol="0" anchor="t"/>
+          <a:lstStyle/>
+          <a:p>
+            <a:pPr algn="l" indent="0" marL="0">
+              <a:lnSpc>
+                <a:spcPct val="115000"/>
+              </a:lnSpc>
+              <a:buNone/>
+            </a:pPr>
+            <a:r>
+              <a:rPr lang="en-US" sz="1350" b="1" dirty="0">
+                <a:solidFill>
+                  <a:srgbClr val="4F46E5"/>
+                </a:solidFill>
+                <a:latin typeface="Segoe UI" pitchFamily="34" charset="0"/>
+                <a:ea typeface="Segoe UI" pitchFamily="34" charset="-122"/>
+                <a:cs typeface="Segoe UI" pitchFamily="34" charset="-120"/>
+              </a:rPr>
+              <a:t>Qué representa: </a:t>
+            </a:r>
+            <a:pPr algn="l" indent="0" marL="0">
+              <a:lnSpc>
+                <a:spcPct val="115000"/>
+              </a:lnSpc>
+              <a:buNone/>
+            </a:pPr>
+            <a:r>
+              <a:rPr lang="en-US" sz="1350" dirty="0">
+                <a:solidFill>
+                  <a:srgbClr val="1F2937"/>
+                </a:solidFill>
+                <a:latin typeface="Segoe UI" pitchFamily="34" charset="0"/>
+                <a:ea typeface="Segoe UI" pitchFamily="34" charset="-122"/>
+                <a:cs typeface="Segoe UI" pitchFamily="34" charset="-120"/>
+              </a:rPr>
+              <a:t>El Jefe abre el detalle de una solicitud de cambio, que muestra el proyecto afectado, quién la solicitó y su estado actual. Al editarla y fijar el estado en «aprobada», el controller valida los datos —el estado solo puede ser pendiente, aprobada o rechazada—, actualiza el registro en la base mediante fill(data) + save() y redirige al listado con el mensaje «Solicitud de cambio actualizada correctamente.»</a:t>
+            </a:r>
+            <a:endParaRPr lang="en-US" sz="1350" dirty="0"/>
+          </a:p>
+        </p:txBody>
+      </p:sp>
       <p:sp>
         <p:nvSpPr>
           <p:cNvPr id="5" name="Text 2"/>
@@ -7981,8 +7340,8 @@
         </p:nvSpPr>
         <p:spPr>
           <a:xfrm>
-            <a:off x="640080" y="5897880"/>
-            <a:ext cx="10908792" cy="731520"/>
+            <a:off x="548640" y="6263640"/>
+            <a:ext cx="11091672" cy="274320"/>
           </a:xfrm>
           <a:prstGeom prst="rect">
             <a:avLst/>
@@ -7991,24 +7350,24 @@
           <a:ln/>
         </p:spPr>
         <p:txBody>
-          <a:bodyPr wrap="square" lIns="0" tIns="0" rIns="0" bIns="0" rtlCol="0" anchor="t"/>
-          <a:lstStyle/>
-          <a:p>
-            <a:pPr algn="l" indent="0" marL="0">
-              <a:buNone/>
-            </a:pPr>
-            <a:r>
-              <a:rPr lang="en-US" sz="1300" dirty="0">
-                <a:solidFill>
-                  <a:srgbClr val="000000"/>
-                </a:solidFill>
-                <a:latin typeface="Segoe UI" pitchFamily="34" charset="0"/>
-                <a:ea typeface="Segoe UI" pitchFamily="34" charset="-122"/>
-                <a:cs typeface="Segoe UI" pitchFamily="34" charset="-120"/>
-              </a:rPr>
-              <a:t>update(req, s) fija estado = aprobada · enum pendiente | aprobada | rechazada · redirect con success</a:t>
-            </a:r>
-            <a:endParaRPr lang="en-US" sz="1300" dirty="0"/>
+          <a:bodyPr wrap="square" lIns="0" tIns="0" rIns="0" bIns="0" rtlCol="0" anchor="ctr"/>
+          <a:lstStyle/>
+          <a:p>
+            <a:pPr algn="r" indent="0" marL="0">
+              <a:buNone/>
+            </a:pPr>
+            <a:r>
+              <a:rPr lang="en-US" sz="1100" dirty="0">
+                <a:solidFill>
+                  <a:srgbClr val="64748B"/>
+                </a:solidFill>
+                <a:latin typeface="Segoe UI" pitchFamily="34" charset="0"/>
+                <a:ea typeface="Segoe UI" pitchFamily="34" charset="-122"/>
+                <a:cs typeface="Segoe UI" pitchFamily="34" charset="-120"/>
+              </a:rPr>
+              <a:t>Mensajes: show(s) · update(req, s) · validate · update(data) · redirect con success</a:t>
+            </a:r>
+            <a:endParaRPr lang="en-US" sz="1100" dirty="0"/>
           </a:p>
         </p:txBody>
       </p:sp>
@@ -8052,7 +7411,7 @@
         </p:nvSpPr>
         <p:spPr>
           <a:xfrm>
-            <a:off x="457200" y="201168"/>
+            <a:off x="457200" y="182880"/>
             <a:ext cx="11274552" cy="457200"/>
           </a:xfrm>
           <a:prstGeom prst="rect">
@@ -8083,48 +7442,9 @@
           </a:p>
         </p:txBody>
       </p:sp>
-      <p:sp>
-        <p:nvSpPr>
-          <p:cNvPr id="3" name="Text 1"/>
-          <p:cNvSpPr/>
-          <p:nvPr/>
-        </p:nvSpPr>
-        <p:spPr>
-          <a:xfrm>
-            <a:off x="457200" y="658368"/>
-            <a:ext cx="11274552" cy="320040"/>
-          </a:xfrm>
-          <a:prstGeom prst="rect">
-            <a:avLst/>
-          </a:prstGeom>
-          <a:noFill/>
-          <a:ln/>
-        </p:spPr>
-        <p:txBody>
-          <a:bodyPr wrap="square" lIns="0" tIns="0" rIns="0" bIns="0" rtlCol="0" anchor="ctr"/>
-          <a:lstStyle/>
-          <a:p>
-            <a:pPr indent="0" marL="0">
-              <a:buNone/>
-            </a:pPr>
-            <a:r>
-              <a:rPr lang="en-US" sz="1300" dirty="0">
-                <a:solidFill>
-                  <a:srgbClr val="64748B"/>
-                </a:solidFill>
-                <a:latin typeface="Segoe UI" pitchFamily="34" charset="0"/>
-                <a:ea typeface="Segoe UI" pitchFamily="34" charset="-122"/>
-                <a:cs typeface="Segoe UI" pitchFamily="34" charset="-120"/>
-              </a:rPr>
-              <a:t>Diseño detallado del caso de uso (PlantUML, generado desde el código real)</a:t>
-            </a:r>
-            <a:endParaRPr lang="en-US" sz="1300" dirty="0"/>
-          </a:p>
-        </p:txBody>
-      </p:sp>
       <p:pic>
         <p:nvPicPr>
-          <p:cNvPr id="4" name="Image 0" descr="C:\laragon\www\sistema\docs\dsd\png-hd\06_po_gestiona_entregables.png">    </p:cNvPr>
+          <p:cNvPr id="3" name="Image 0" descr="C:\laragon\www\sistema\docs\dsd\png-hd\06_po_gestiona_entregables.png">    </p:cNvPr>
           <p:cNvPicPr>
             <a:picLocks noChangeAspect="1"/>
           </p:cNvPicPr>
@@ -8138,14 +7458,73 @@
         </p:blipFill>
         <p:spPr>
           <a:xfrm>
-            <a:off x="3182435" y="1051560"/>
-            <a:ext cx="5824081" cy="4663440"/>
+            <a:off x="3724874" y="777240"/>
+            <a:ext cx="4739203" cy="3794760"/>
           </a:xfrm>
           <a:prstGeom prst="rect">
             <a:avLst/>
           </a:prstGeom>
         </p:spPr>
       </p:pic>
+      <p:sp>
+        <p:nvSpPr>
+          <p:cNvPr id="4" name="Text 1"/>
+          <p:cNvSpPr/>
+          <p:nvPr/>
+        </p:nvSpPr>
+        <p:spPr>
+          <a:xfrm>
+            <a:off x="548640" y="4709160"/>
+            <a:ext cx="11091672" cy="1417320"/>
+          </a:xfrm>
+          <a:prstGeom prst="rect">
+            <a:avLst/>
+          </a:prstGeom>
+          <a:noFill/>
+          <a:ln/>
+        </p:spPr>
+        <p:txBody>
+          <a:bodyPr wrap="square" lIns="0" tIns="0" rIns="0" bIns="0" rtlCol="0" anchor="t"/>
+          <a:lstStyle/>
+          <a:p>
+            <a:pPr algn="l" indent="0" marL="0">
+              <a:lnSpc>
+                <a:spcPct val="115000"/>
+              </a:lnSpc>
+              <a:buNone/>
+            </a:pPr>
+            <a:r>
+              <a:rPr lang="en-US" sz="1350" b="1" dirty="0">
+                <a:solidFill>
+                  <a:srgbClr val="4F46E5"/>
+                </a:solidFill>
+                <a:latin typeface="Segoe UI" pitchFamily="34" charset="0"/>
+                <a:ea typeface="Segoe UI" pitchFamily="34" charset="-122"/>
+                <a:cs typeface="Segoe UI" pitchFamily="34" charset="-120"/>
+              </a:rPr>
+              <a:t>Qué representa: </a:t>
+            </a:r>
+            <a:pPr algn="l" indent="0" marL="0">
+              <a:lnSpc>
+                <a:spcPct val="115000"/>
+              </a:lnSpc>
+              <a:buNone/>
+            </a:pPr>
+            <a:r>
+              <a:rPr lang="en-US" sz="1350" dirty="0">
+                <a:solidFill>
+                  <a:srgbClr val="1F2937"/>
+                </a:solidFill>
+                <a:latin typeface="Segoe UI" pitchFamily="34" charset="0"/>
+                <a:ea typeface="Segoe UI" pitchFamily="34" charset="-122"/>
+                <a:cs typeface="Segoe UI" pitchFamily="34" charset="-120"/>
+              </a:rPr>
+              <a:t>El PO entra al listado de entregables IA, que muestra cada entregable con su proyecto, tipo, estado y quién lo generó (paginado de a 15). Al abrir uno, el sistema carga sus relaciones proyecto y generador. Al editarlo, el controller valida que el estado solo pueda tomar los valores borrador, revisado o aprobado —además del resto de los campos obligatorios—, actualiza el registro con update(data) y vuelve al listado con el mensaje de éxito.</a:t>
+            </a:r>
+            <a:endParaRPr lang="en-US" sz="1350" dirty="0"/>
+          </a:p>
+        </p:txBody>
+      </p:sp>
       <p:sp>
         <p:nvSpPr>
           <p:cNvPr id="5" name="Text 2"/>
@@ -8154,8 +7533,8 @@
         </p:nvSpPr>
         <p:spPr>
           <a:xfrm>
-            <a:off x="640080" y="5897880"/>
-            <a:ext cx="10908792" cy="731520"/>
+            <a:off x="548640" y="6263640"/>
+            <a:ext cx="11091672" cy="274320"/>
           </a:xfrm>
           <a:prstGeom prst="rect">
             <a:avLst/>
@@ -8164,24 +7543,24 @@
           <a:ln/>
         </p:spPr>
         <p:txBody>
-          <a:bodyPr wrap="square" lIns="0" tIns="0" rIns="0" bIns="0" rtlCol="0" anchor="t"/>
-          <a:lstStyle/>
-          <a:p>
-            <a:pPr algn="l" indent="0" marL="0">
-              <a:buNone/>
-            </a:pPr>
-            <a:r>
-              <a:rPr lang="en-US" sz="1300" dirty="0">
-                <a:solidFill>
-                  <a:srgbClr val="000000"/>
-                </a:solidFill>
-                <a:latin typeface="Segoe UI" pitchFamily="34" charset="0"/>
-                <a:ea typeface="Segoe UI" pitchFamily="34" charset="-122"/>
-                <a:cs typeface="Segoe UI" pitchFamily="34" charset="-120"/>
-              </a:rPr>
-              <a:t>update(req, e) acepta borrador | revisado | aprobado · redirect al listado con success</a:t>
-            </a:r>
-            <a:endParaRPr lang="en-US" sz="1300" dirty="0"/>
+          <a:bodyPr wrap="square" lIns="0" tIns="0" rIns="0" bIns="0" rtlCol="0" anchor="ctr"/>
+          <a:lstStyle/>
+          <a:p>
+            <a:pPr algn="r" indent="0" marL="0">
+              <a:buNone/>
+            </a:pPr>
+            <a:r>
+              <a:rPr lang="en-US" sz="1100" dirty="0">
+                <a:solidFill>
+                  <a:srgbClr val="64748B"/>
+                </a:solidFill>
+                <a:latin typeface="Segoe UI" pitchFamily="34" charset="0"/>
+                <a:ea typeface="Segoe UI" pitchFamily="34" charset="-122"/>
+                <a:cs typeface="Segoe UI" pitchFamily="34" charset="-120"/>
+              </a:rPr>
+              <a:t>Mensajes: index() · show(e) · update(req, e) · validate · update(data) · redirect</a:t>
+            </a:r>
+            <a:endParaRPr lang="en-US" sz="1100" dirty="0"/>
           </a:p>
         </p:txBody>
       </p:sp>
@@ -8335,7 +7714,7 @@
         </p:nvSpPr>
         <p:spPr>
           <a:xfrm>
-            <a:off x="457200" y="201168"/>
+            <a:off x="457200" y="182880"/>
             <a:ext cx="11274552" cy="457200"/>
           </a:xfrm>
           <a:prstGeom prst="rect">
@@ -8366,48 +7745,9 @@
           </a:p>
         </p:txBody>
       </p:sp>
-      <p:sp>
-        <p:nvSpPr>
-          <p:cNvPr id="3" name="Text 1"/>
-          <p:cNvSpPr/>
-          <p:nvPr/>
-        </p:nvSpPr>
-        <p:spPr>
-          <a:xfrm>
-            <a:off x="457200" y="658368"/>
-            <a:ext cx="11274552" cy="320040"/>
-          </a:xfrm>
-          <a:prstGeom prst="rect">
-            <a:avLst/>
-          </a:prstGeom>
-          <a:noFill/>
-          <a:ln/>
-        </p:spPr>
-        <p:txBody>
-          <a:bodyPr wrap="square" lIns="0" tIns="0" rIns="0" bIns="0" rtlCol="0" anchor="ctr"/>
-          <a:lstStyle/>
-          <a:p>
-            <a:pPr indent="0" marL="0">
-              <a:buNone/>
-            </a:pPr>
-            <a:r>
-              <a:rPr lang="en-US" sz="1300" dirty="0">
-                <a:solidFill>
-                  <a:srgbClr val="64748B"/>
-                </a:solidFill>
-                <a:latin typeface="Segoe UI" pitchFamily="34" charset="0"/>
-                <a:ea typeface="Segoe UI" pitchFamily="34" charset="-122"/>
-                <a:cs typeface="Segoe UI" pitchFamily="34" charset="-120"/>
-              </a:rPr>
-              <a:t>Ejecución real en la web del sistema</a:t>
-            </a:r>
-            <a:endParaRPr lang="en-US" sz="1300" dirty="0"/>
-          </a:p>
-        </p:txBody>
-      </p:sp>
       <p:pic>
         <p:nvPicPr>
-          <p:cNvPr id="4" name="Image 0" descr="C:\laragon\www\sistema\docs\cu-reales\capturas\cu1_paso1_listado.png">    </p:cNvPr>
+          <p:cNvPr id="3" name="Image 0" descr="C:\laragon\www\sistema\docs\cu-reales\capturas\cu1_paso1_listado.png">    </p:cNvPr>
           <p:cNvPicPr>
             <a:picLocks noChangeAspect="1"/>
           </p:cNvPicPr>
@@ -8431,7 +7771,7 @@
       </p:pic>
       <p:sp>
         <p:nvSpPr>
-          <p:cNvPr id="5" name="Text 2"/>
+          <p:cNvPr id="4" name="Text 1"/>
           <p:cNvSpPr/>
           <p:nvPr/>
         </p:nvSpPr>

</xml_diff>

<commit_message>
Completar los 2 items faltantes del visor de auditoria y limpieza final
- Filtro por usuario y por accion (created/updated/deleted) en /auditoria
- Boton Historial en los 7 listados (solo Jefe): reloj que abre la
  auditoria filtrada por ese registro concreto
- Columna de registro muestra los campos cambiados (old -> new) en updates
- Borrar layouts/navigation.blade.php: quedo sin uso tras el rediseño
  del layout (codigo muerto, item de la tarjeta Limpieza de codigo)
</commit_message>
<xml_diff>
--- a/docs/presentacion/CRUZNEGRA_DSD_CU_Reales.pptx
+++ b/docs/presentacion/CRUZNEGRA_DSD_CU_Reales.pptx
@@ -4,6 +4,9 @@
   <p:sldMasterIdLst>
     <p:sldMasterId id="2147483648" r:id="rId1"/>
   </p:sldMasterIdLst>
+  <p:notesMasterIdLst>
+    <p:notesMasterId r:id="rId31"/>
+  </p:notesMasterIdLst>
   <p:sldIdLst>
     <p:sldId id="256" r:id="rId2"/>
     <p:sldId id="257" r:id="rId3"/>
@@ -35,9 +38,6 @@
     <p:sldId id="283" r:id="rId29"/>
     <p:sldId id="284" r:id="rId30"/>
   </p:sldIdLst>
-  <p:notesMasterIdLst>
-    <p:notesMasterId r:id="rId31"/>
-  </p:notesMasterIdLst>
   <p:sldSz cx="12192000" cy="6858000"/>
   <p:notesSz cx="6858000" cy="12192000"/>
   <p:defaultTextStyle>
@@ -132,6 +132,11 @@
       </a:defRPr>
     </a:lvl9pPr>
   </p:defaultTextStyle>
+  <p:extLst>
+    <p:ext uri="{EFAFB233-063F-42B5-8137-9DF3F51BA10A}">
+      <p15:sldGuideLst xmlns:p15="http://schemas.microsoft.com/office/powerpoint/2012/main"/>
+    </p:ext>
+  </p:extLst>
 </p:presentation>
 </file>
 
@@ -157,234 +162,10 @@
           <a:chExt cx="0" cy="0"/>
         </a:xfrm>
       </p:grpSpPr>
-      <p:sp>
-        <p:nvSpPr>
-          <p:cNvPr id="2" name="Header Placeholder 1"/>
-          <p:cNvSpPr>
-            <a:spLocks noGrp="1"/>
-          </p:cNvSpPr>
-          <p:nvPr>
-            <p:ph type="hdr" sz="quarter"/>
-          </p:nvPr>
-        </p:nvSpPr>
-        <p:spPr>
-          <a:xfrm>
-            <a:off x="0" y="0"/>
-            <a:ext cx="2971800" cy="458788"/>
-          </a:xfrm>
-          <a:prstGeom prst="rect">
-            <a:avLst/>
-          </a:prstGeom>
-        </p:spPr>
-        <p:txBody>
-          <a:bodyPr vert="horz" lIns="91440" tIns="45720" rIns="91440" bIns="45720" rtlCol="0"/>
-          <a:lstStyle>
-            <a:lvl1pPr algn="l">
-              <a:defRPr sz="1200"/>
-            </a:lvl1pPr>
-          </a:lstStyle>
-          <a:p>
-            <a:endParaRPr lang="en-US"/>
-          </a:p>
-        </p:txBody>
-      </p:sp>
-      <p:sp>
-        <p:nvSpPr>
-          <p:cNvPr id="3" name="Date Placeholder 2"/>
-          <p:cNvSpPr>
-            <a:spLocks noGrp="1"/>
-          </p:cNvSpPr>
-          <p:nvPr>
-            <p:ph type="dt" idx="1"/>
-          </p:nvPr>
-        </p:nvSpPr>
-        <p:spPr>
-          <a:xfrm>
-            <a:off x="3884613" y="0"/>
-            <a:ext cx="2971800" cy="458788"/>
-          </a:xfrm>
-          <a:prstGeom prst="rect">
-            <a:avLst/>
-          </a:prstGeom>
-        </p:spPr>
-        <p:txBody>
-          <a:bodyPr vert="horz" lIns="91440" tIns="45720" rIns="91440" bIns="45720" rtlCol="0"/>
-          <a:lstStyle>
-            <a:lvl1pPr algn="r">
-              <a:defRPr sz="1200"/>
-            </a:lvl1pPr>
-          </a:lstStyle>
-          <a:p>
-            <a:fld id="{5282F153-3F37-0F45-9E97-73ACFA13230C}" type="datetimeFigureOut">
-              <a:rPr lang="en-US"/>
-              <a:t>7/23/19</a:t>
-            </a:fld>
-            <a:endParaRPr lang="en-US"/>
-          </a:p>
-        </p:txBody>
-      </p:sp>
-      <p:sp>
-        <p:nvSpPr>
-          <p:cNvPr id="4" name="Slide Image Placeholder 3"/>
-          <p:cNvSpPr>
-            <a:spLocks noGrp="1" noRot="1" noChangeAspect="1"/>
-          </p:cNvSpPr>
-          <p:nvPr>
-            <p:ph type="sldImg" idx="2"/>
-          </p:nvPr>
-        </p:nvSpPr>
-        <p:spPr>
-          <a:xfrm>
-            <a:off x="685800" y="1143000"/>
-            <a:ext cx="5486400" cy="3086100"/>
-          </a:xfrm>
-          <a:prstGeom prst="rect">
-            <a:avLst/>
-          </a:prstGeom>
-          <a:noFill/>
-          <a:ln w="12700">
-            <a:solidFill>
-              <a:prstClr val="black"/>
-            </a:solidFill>
-          </a:ln>
-        </p:spPr>
-        <p:txBody>
-          <a:bodyPr vert="horz" lIns="91440" tIns="45720" rIns="91440" bIns="45720" rtlCol="0" anchor="ctr"/>
-          <a:lstStyle/>
-          <a:p>
-            <a:endParaRPr lang="en-US"/>
-          </a:p>
-        </p:txBody>
-      </p:sp>
-      <p:sp>
-        <p:nvSpPr>
-          <p:cNvPr id="5" name="Notes Placeholder 4"/>
-          <p:cNvSpPr>
-            <a:spLocks noGrp="1"/>
-          </p:cNvSpPr>
-          <p:nvPr>
-            <p:ph type="body" sz="quarter" idx="3"/>
-          </p:nvPr>
-        </p:nvSpPr>
-        <p:spPr>
-          <a:xfrm>
-            <a:off x="685800" y="4400550"/>
-            <a:ext cx="5486400" cy="3600450"/>
-          </a:xfrm>
-          <a:prstGeom prst="rect">
-            <a:avLst/>
-          </a:prstGeom>
-        </p:spPr>
-        <p:txBody>
-          <a:bodyPr vert="horz" lIns="91440" tIns="45720" rIns="91440" bIns="45720" rtlCol="0"/>
-          <a:lstStyle/>
-          <a:p>
-            <a:pPr lvl="0"/>
-            <a:r>
-              <a:rPr lang="en-US"/>
-              <a:t>Click to edit Master text styles</a:t>
-            </a:r>
-          </a:p>
-          <a:p>
-            <a:pPr lvl="1"/>
-            <a:r>
-              <a:rPr lang="en-US"/>
-              <a:t>Second level</a:t>
-            </a:r>
-          </a:p>
-          <a:p>
-            <a:pPr lvl="2"/>
-            <a:r>
-              <a:rPr lang="en-US"/>
-              <a:t>Third level</a:t>
-            </a:r>
-          </a:p>
-          <a:p>
-            <a:pPr lvl="3"/>
-            <a:r>
-              <a:rPr lang="en-US"/>
-              <a:t>Fourth level</a:t>
-            </a:r>
-          </a:p>
-          <a:p>
-            <a:pPr lvl="4"/>
-            <a:r>
-              <a:rPr lang="en-US"/>
-              <a:t>Fifth level</a:t>
-            </a:r>
-          </a:p>
-        </p:txBody>
-      </p:sp>
-      <p:sp>
-        <p:nvSpPr>
-          <p:cNvPr id="6" name="Footer Placeholder 5"/>
-          <p:cNvSpPr>
-            <a:spLocks noGrp="1"/>
-          </p:cNvSpPr>
-          <p:nvPr>
-            <p:ph type="ftr" sz="quarter" idx="4"/>
-          </p:nvPr>
-        </p:nvSpPr>
-        <p:spPr>
-          <a:xfrm>
-            <a:off x="0" y="8685213"/>
-            <a:ext cx="2971800" cy="458787"/>
-          </a:xfrm>
-          <a:prstGeom prst="rect">
-            <a:avLst/>
-          </a:prstGeom>
-        </p:spPr>
-        <p:txBody>
-          <a:bodyPr vert="horz" lIns="91440" tIns="45720" rIns="91440" bIns="45720" rtlCol="0" anchor="b"/>
-          <a:lstStyle>
-            <a:lvl1pPr algn="l">
-              <a:defRPr sz="1200"/>
-            </a:lvl1pPr>
-          </a:lstStyle>
-          <a:p>
-            <a:endParaRPr lang="en-US"/>
-          </a:p>
-        </p:txBody>
-      </p:sp>
-      <p:sp>
-        <p:nvSpPr>
-          <p:cNvPr id="7" name="Slide Number Placeholder 6"/>
-          <p:cNvSpPr>
-            <a:spLocks noGrp="1"/>
-          </p:cNvSpPr>
-          <p:nvPr>
-            <p:ph type="sldNum" sz="quarter" idx="5"/>
-          </p:nvPr>
-        </p:nvSpPr>
-        <p:spPr>
-          <a:xfrm>
-            <a:off x="3884613" y="8685213"/>
-            <a:ext cx="2971800" cy="458787"/>
-          </a:xfrm>
-          <a:prstGeom prst="rect">
-            <a:avLst/>
-          </a:prstGeom>
-        </p:spPr>
-        <p:txBody>
-          <a:bodyPr vert="horz" lIns="91440" tIns="45720" rIns="91440" bIns="45720" rtlCol="0" anchor="b"/>
-          <a:lstStyle>
-            <a:lvl1pPr algn="r">
-              <a:defRPr sz="1200"/>
-            </a:lvl1pPr>
-          </a:lstStyle>
-          <a:p>
-            <a:fld id="{CE5E9CC1-C706-0F49-92D6-E571CC5EEA8F}" type="slidenum">
-              <a:rPr lang="en-US"/>
-              <a:t>‹#›</a:t>
-            </a:fld>
-            <a:endParaRPr lang="en-US"/>
-          </a:p>
-        </p:txBody>
-      </p:sp>
     </p:spTree>
     <p:extLst>
       <p:ext uri="{BB962C8B-B14F-4D97-AF65-F5344CB8AC3E}">
-        <p14:creationId xmlns:p14="http://schemas.microsoft.com/office/powerpoint/2010/main" val="1024086991"/>
+        <p14:creationId xmlns:p14="http://schemas.microsoft.com/office/powerpoint/2010/main" val="3828858150"/>
       </p:ext>
     </p:extLst>
   </p:cSld>
@@ -528,10 +309,6 @@
           <a:bodyPr/>
           <a:lstStyle/>
           <a:p>
-            <a:r>
-              <a:rPr lang="en-US" dirty="0"/>
-              <a:t/>
-            </a:r>
             <a:endParaRPr lang="en-US" dirty="0"/>
           </a:p>
         </p:txBody>
@@ -616,10 +393,6 @@
           <a:bodyPr/>
           <a:lstStyle/>
           <a:p>
-            <a:r>
-              <a:rPr lang="en-US" dirty="0"/>
-              <a:t/>
-            </a:r>
             <a:endParaRPr lang="en-US" dirty="0"/>
           </a:p>
         </p:txBody>
@@ -704,10 +477,6 @@
           <a:bodyPr/>
           <a:lstStyle/>
           <a:p>
-            <a:r>
-              <a:rPr lang="en-US" dirty="0"/>
-              <a:t/>
-            </a:r>
             <a:endParaRPr lang="en-US" dirty="0"/>
           </a:p>
         </p:txBody>
@@ -792,10 +561,6 @@
           <a:bodyPr/>
           <a:lstStyle/>
           <a:p>
-            <a:r>
-              <a:rPr lang="en-US" dirty="0"/>
-              <a:t/>
-            </a:r>
             <a:endParaRPr lang="en-US" dirty="0"/>
           </a:p>
         </p:txBody>
@@ -880,10 +645,6 @@
           <a:bodyPr/>
           <a:lstStyle/>
           <a:p>
-            <a:r>
-              <a:rPr lang="en-US" dirty="0"/>
-              <a:t/>
-            </a:r>
             <a:endParaRPr lang="en-US" dirty="0"/>
           </a:p>
         </p:txBody>
@@ -968,10 +729,6 @@
           <a:bodyPr/>
           <a:lstStyle/>
           <a:p>
-            <a:r>
-              <a:rPr lang="en-US" dirty="0"/>
-              <a:t/>
-            </a:r>
             <a:endParaRPr lang="en-US" dirty="0"/>
           </a:p>
         </p:txBody>
@@ -1056,10 +813,6 @@
           <a:bodyPr/>
           <a:lstStyle/>
           <a:p>
-            <a:r>
-              <a:rPr lang="en-US" dirty="0"/>
-              <a:t/>
-            </a:r>
             <a:endParaRPr lang="en-US" dirty="0"/>
           </a:p>
         </p:txBody>
@@ -1144,10 +897,6 @@
           <a:bodyPr/>
           <a:lstStyle/>
           <a:p>
-            <a:r>
-              <a:rPr lang="en-US" dirty="0"/>
-              <a:t/>
-            </a:r>
             <a:endParaRPr lang="en-US" dirty="0"/>
           </a:p>
         </p:txBody>
@@ -1232,10 +981,6 @@
           <a:bodyPr/>
           <a:lstStyle/>
           <a:p>
-            <a:r>
-              <a:rPr lang="en-US" dirty="0"/>
-              <a:t/>
-            </a:r>
             <a:endParaRPr lang="en-US" dirty="0"/>
           </a:p>
         </p:txBody>
@@ -1320,10 +1065,6 @@
           <a:bodyPr/>
           <a:lstStyle/>
           <a:p>
-            <a:r>
-              <a:rPr lang="en-US" dirty="0"/>
-              <a:t/>
-            </a:r>
             <a:endParaRPr lang="en-US" dirty="0"/>
           </a:p>
         </p:txBody>
@@ -1408,10 +1149,6 @@
           <a:bodyPr/>
           <a:lstStyle/>
           <a:p>
-            <a:r>
-              <a:rPr lang="en-US" dirty="0"/>
-              <a:t/>
-            </a:r>
             <a:endParaRPr lang="en-US" dirty="0"/>
           </a:p>
         </p:txBody>
@@ -1496,10 +1233,6 @@
           <a:bodyPr/>
           <a:lstStyle/>
           <a:p>
-            <a:r>
-              <a:rPr lang="en-US" dirty="0"/>
-              <a:t/>
-            </a:r>
             <a:endParaRPr lang="en-US" dirty="0"/>
           </a:p>
         </p:txBody>
@@ -1584,10 +1317,6 @@
           <a:bodyPr/>
           <a:lstStyle/>
           <a:p>
-            <a:r>
-              <a:rPr lang="en-US" dirty="0"/>
-              <a:t/>
-            </a:r>
             <a:endParaRPr lang="en-US" dirty="0"/>
           </a:p>
         </p:txBody>
@@ -1672,10 +1401,6 @@
           <a:bodyPr/>
           <a:lstStyle/>
           <a:p>
-            <a:r>
-              <a:rPr lang="en-US" dirty="0"/>
-              <a:t/>
-            </a:r>
             <a:endParaRPr lang="en-US" dirty="0"/>
           </a:p>
         </p:txBody>
@@ -1760,10 +1485,6 @@
           <a:bodyPr/>
           <a:lstStyle/>
           <a:p>
-            <a:r>
-              <a:rPr lang="en-US" dirty="0"/>
-              <a:t/>
-            </a:r>
             <a:endParaRPr lang="en-US" dirty="0"/>
           </a:p>
         </p:txBody>
@@ -1848,10 +1569,6 @@
           <a:bodyPr/>
           <a:lstStyle/>
           <a:p>
-            <a:r>
-              <a:rPr lang="en-US" dirty="0"/>
-              <a:t/>
-            </a:r>
             <a:endParaRPr lang="en-US" dirty="0"/>
           </a:p>
         </p:txBody>
@@ -1936,10 +1653,6 @@
           <a:bodyPr/>
           <a:lstStyle/>
           <a:p>
-            <a:r>
-              <a:rPr lang="en-US" dirty="0"/>
-              <a:t/>
-            </a:r>
             <a:endParaRPr lang="en-US" dirty="0"/>
           </a:p>
         </p:txBody>
@@ -2024,10 +1737,6 @@
           <a:bodyPr/>
           <a:lstStyle/>
           <a:p>
-            <a:r>
-              <a:rPr lang="en-US" dirty="0"/>
-              <a:t/>
-            </a:r>
             <a:endParaRPr lang="en-US" dirty="0"/>
           </a:p>
         </p:txBody>
@@ -2112,10 +1821,6 @@
           <a:bodyPr/>
           <a:lstStyle/>
           <a:p>
-            <a:r>
-              <a:rPr lang="en-US" dirty="0"/>
-              <a:t/>
-            </a:r>
             <a:endParaRPr lang="en-US" dirty="0"/>
           </a:p>
         </p:txBody>
@@ -2200,10 +1905,6 @@
           <a:bodyPr/>
           <a:lstStyle/>
           <a:p>
-            <a:r>
-              <a:rPr lang="en-US" dirty="0"/>
-              <a:t/>
-            </a:r>
             <a:endParaRPr lang="en-US" dirty="0"/>
           </a:p>
         </p:txBody>
@@ -2288,10 +1989,6 @@
           <a:bodyPr/>
           <a:lstStyle/>
           <a:p>
-            <a:r>
-              <a:rPr lang="en-US" dirty="0"/>
-              <a:t/>
-            </a:r>
             <a:endParaRPr lang="en-US" dirty="0"/>
           </a:p>
         </p:txBody>
@@ -2376,10 +2073,6 @@
           <a:bodyPr/>
           <a:lstStyle/>
           <a:p>
-            <a:r>
-              <a:rPr lang="en-US" dirty="0"/>
-              <a:t/>
-            </a:r>
             <a:endParaRPr lang="en-US" dirty="0"/>
           </a:p>
         </p:txBody>
@@ -2464,10 +2157,6 @@
           <a:bodyPr/>
           <a:lstStyle/>
           <a:p>
-            <a:r>
-              <a:rPr lang="en-US" dirty="0"/>
-              <a:t/>
-            </a:r>
             <a:endParaRPr lang="en-US" dirty="0"/>
           </a:p>
         </p:txBody>
@@ -2552,10 +2241,6 @@
           <a:bodyPr/>
           <a:lstStyle/>
           <a:p>
-            <a:r>
-              <a:rPr lang="en-US" dirty="0"/>
-              <a:t/>
-            </a:r>
             <a:endParaRPr lang="en-US" dirty="0"/>
           </a:p>
         </p:txBody>
@@ -2640,10 +2325,6 @@
           <a:bodyPr/>
           <a:lstStyle/>
           <a:p>
-            <a:r>
-              <a:rPr lang="en-US" dirty="0"/>
-              <a:t/>
-            </a:r>
             <a:endParaRPr lang="en-US" dirty="0"/>
           </a:p>
         </p:txBody>
@@ -2728,10 +2409,6 @@
           <a:bodyPr/>
           <a:lstStyle/>
           <a:p>
-            <a:r>
-              <a:rPr lang="en-US" dirty="0"/>
-              <a:t/>
-            </a:r>
             <a:endParaRPr lang="en-US" dirty="0"/>
           </a:p>
         </p:txBody>
@@ -2816,10 +2493,6 @@
           <a:bodyPr/>
           <a:lstStyle/>
           <a:p>
-            <a:r>
-              <a:rPr lang="en-US" dirty="0"/>
-              <a:t/>
-            </a:r>
             <a:endParaRPr lang="en-US" dirty="0"/>
           </a:p>
         </p:txBody>
@@ -2904,10 +2577,6 @@
           <a:bodyPr/>
           <a:lstStyle/>
           <a:p>
-            <a:r>
-              <a:rPr lang="en-US" dirty="0"/>
-              <a:t/>
-            </a:r>
             <a:endParaRPr lang="en-US" dirty="0"/>
           </a:p>
         </p:txBody>
@@ -2992,10 +2661,6 @@
           <a:bodyPr/>
           <a:lstStyle/>
           <a:p>
-            <a:r>
-              <a:rPr lang="en-US" dirty="0"/>
-              <a:t/>
-            </a:r>
             <a:endParaRPr lang="en-US" dirty="0"/>
           </a:p>
         </p:txBody>
@@ -3069,6 +2734,11 @@
 <file path=ppt/slideMasters/slideMaster1.xml><?xml version="1.0" encoding="utf-8"?>
 <p:sldMaster xmlns:a="http://schemas.openxmlformats.org/drawingml/2006/main" xmlns:r="http://schemas.openxmlformats.org/officeDocument/2006/relationships" xmlns:p="http://schemas.openxmlformats.org/presentationml/2006/main">
   <p:cSld>
+    <p:bg>
+      <p:bgRef idx="1001">
+        <a:schemeClr val="bg1"/>
+      </p:bgRef>
+    </p:bg>
     <p:spTree>
       <p:nvGrpSpPr>
         <p:cNvPr id="1" name=""/>
@@ -3351,6 +3021,7 @@
         <a:solidFill>
           <a:srgbClr val="0F172A"/>
         </a:solidFill>
+        <a:effectLst/>
       </p:bgPr>
     </p:bg>
     <p:spTree>
@@ -3375,7 +3046,7 @@
         </p:nvSpPr>
         <p:spPr>
           <a:xfrm>
-            <a:off x="0" y="1920240"/>
+            <a:off x="0" y="2427514"/>
             <a:ext cx="12188952" cy="1005840"/>
           </a:xfrm>
           <a:prstGeom prst="rect">
@@ -3388,7 +3059,7 @@
           <a:bodyPr wrap="square" rtlCol="0" anchor="ctr"/>
           <a:lstStyle/>
           <a:p>
-            <a:pPr algn="ctr" indent="0" marL="0">
+            <a:pPr marL="0" indent="0" algn="ctr">
               <a:buNone/>
             </a:pPr>
             <a:r>
@@ -3414,7 +3085,7 @@
         </p:nvSpPr>
         <p:spPr>
           <a:xfrm>
-            <a:off x="0" y="2926080"/>
+            <a:off x="-116114" y="3429000"/>
             <a:ext cx="12188952" cy="640080"/>
           </a:xfrm>
           <a:prstGeom prst="rect">
@@ -3427,7 +3098,7 @@
           <a:bodyPr wrap="square" rtlCol="0" anchor="ctr"/>
           <a:lstStyle/>
           <a:p>
-            <a:pPr algn="ctr" indent="0" marL="0">
+            <a:pPr marL="0" indent="0" algn="ctr">
               <a:buNone/>
             </a:pPr>
             <a:r>
@@ -3453,7 +3124,7 @@
         </p:nvSpPr>
         <p:spPr>
           <a:xfrm>
-            <a:off x="0" y="3657600"/>
+            <a:off x="14514" y="3703320"/>
             <a:ext cx="12188952" cy="457200"/>
           </a:xfrm>
           <a:prstGeom prst="rect">
@@ -3466,20 +3137,9 @@
           <a:bodyPr wrap="square" rtlCol="0" anchor="ctr"/>
           <a:lstStyle/>
           <a:p>
-            <a:pPr algn="ctr" indent="0" marL="0">
+            <a:pPr marL="0" indent="0" algn="ctr">
               <a:buNone/>
             </a:pPr>
-            <a:r>
-              <a:rPr lang="en-US" sz="1500" dirty="0">
-                <a:solidFill>
-                  <a:srgbClr val="94A3B8"/>
-                </a:solidFill>
-                <a:latin typeface="Segoe UI" pitchFamily="34" charset="0"/>
-                <a:ea typeface="Segoe UI" pitchFamily="34" charset="-122"/>
-                <a:cs typeface="Segoe UI" pitchFamily="34" charset="-120"/>
-              </a:rPr>
-              <a:t>Sistema de Gestión Interna · Laravel 12 · Capturas de septiembre 2026</a:t>
-            </a:r>
             <a:endParaRPr lang="en-US" sz="1500" dirty="0"/>
           </a:p>
         </p:txBody>
@@ -3500,6 +3160,7 @@
         <a:solidFill>
           <a:srgbClr val="FFFFFF"/>
         </a:solidFill>
+        <a:effectLst/>
       </p:bgPr>
     </p:bg>
     <p:spTree>
@@ -3537,7 +3198,7 @@
           <a:bodyPr wrap="square" lIns="0" tIns="0" rIns="0" bIns="0" rtlCol="0" anchor="ctr"/>
           <a:lstStyle/>
           <a:p>
-            <a:pPr indent="0" marL="0">
+            <a:pPr marL="0" indent="0">
               <a:buNone/>
             </a:pPr>
             <a:r>
@@ -3557,14 +3218,14 @@
       </p:sp>
       <p:pic>
         <p:nvPicPr>
-          <p:cNvPr id="3" name="Image 0" descr="C:\laragon\www\sistema\docs\cu-reales\capturas\cu1_paso2_modal.png">    </p:cNvPr>
+          <p:cNvPr id="3" name="Image 0" descr="C:\laragon\www\sistema\docs\cu-reales\capturas\cu1_paso2_modal.png"/>
           <p:cNvPicPr>
             <a:picLocks noChangeAspect="1"/>
           </p:cNvPicPr>
           <p:nvPr/>
         </p:nvPicPr>
         <p:blipFill>
-          <a:blip r:embed="rId1"/>
+          <a:blip r:embed="rId3"/>
           <a:stretch>
             <a:fillRect/>
           </a:stretch>
@@ -3600,7 +3261,7 @@
           <a:bodyPr wrap="square" lIns="0" tIns="0" rIns="0" bIns="0" rtlCol="0" anchor="t"/>
           <a:lstStyle/>
           <a:p>
-            <a:pPr algn="l" indent="0" marL="0">
+            <a:pPr marL="0" indent="0" algn="l">
               <a:buNone/>
             </a:pPr>
             <a:r>
@@ -3614,9 +3275,6 @@
               </a:rPr>
               <a:t>Figura 2. </a:t>
             </a:r>
-            <a:pPr algn="l" indent="0" marL="0">
-              <a:buNone/>
-            </a:pPr>
             <a:r>
               <a:rPr lang="en-US" sz="1300" dirty="0">
                 <a:solidFill>
@@ -3648,6 +3306,7 @@
         <a:solidFill>
           <a:srgbClr val="FFFFFF"/>
         </a:solidFill>
+        <a:effectLst/>
       </p:bgPr>
     </p:bg>
     <p:spTree>
@@ -3685,7 +3344,7 @@
           <a:bodyPr wrap="square" lIns="0" tIns="0" rIns="0" bIns="0" rtlCol="0" anchor="ctr"/>
           <a:lstStyle/>
           <a:p>
-            <a:pPr indent="0" marL="0">
+            <a:pPr marL="0" indent="0">
               <a:buNone/>
             </a:pPr>
             <a:r>
@@ -3705,14 +3364,14 @@
       </p:sp>
       <p:pic>
         <p:nvPicPr>
-          <p:cNvPr id="3" name="Image 0" descr="C:\laragon\www\sistema\docs\cu-reales\capturas\cu1_paso3_completo.png">    </p:cNvPr>
+          <p:cNvPr id="3" name="Image 0" descr="C:\laragon\www\sistema\docs\cu-reales\capturas\cu1_paso3_completo.png"/>
           <p:cNvPicPr>
             <a:picLocks noChangeAspect="1"/>
           </p:cNvPicPr>
           <p:nvPr/>
         </p:nvPicPr>
         <p:blipFill>
-          <a:blip r:embed="rId1"/>
+          <a:blip r:embed="rId3"/>
           <a:stretch>
             <a:fillRect/>
           </a:stretch>
@@ -3748,7 +3407,7 @@
           <a:bodyPr wrap="square" lIns="0" tIns="0" rIns="0" bIns="0" rtlCol="0" anchor="t"/>
           <a:lstStyle/>
           <a:p>
-            <a:pPr algn="l" indent="0" marL="0">
+            <a:pPr marL="0" indent="0" algn="l">
               <a:buNone/>
             </a:pPr>
             <a:r>
@@ -3762,9 +3421,6 @@
               </a:rPr>
               <a:t>Figura 3. </a:t>
             </a:r>
-            <a:pPr algn="l" indent="0" marL="0">
-              <a:buNone/>
-            </a:pPr>
             <a:r>
               <a:rPr lang="en-US" sz="1300" dirty="0">
                 <a:solidFill>
@@ -3796,6 +3452,7 @@
         <a:solidFill>
           <a:srgbClr val="FFFFFF"/>
         </a:solidFill>
+        <a:effectLst/>
       </p:bgPr>
     </p:bg>
     <p:spTree>
@@ -3833,7 +3490,7 @@
           <a:bodyPr wrap="square" lIns="0" tIns="0" rIns="0" bIns="0" rtlCol="0" anchor="ctr"/>
           <a:lstStyle/>
           <a:p>
-            <a:pPr indent="0" marL="0">
+            <a:pPr marL="0" indent="0">
               <a:buNone/>
             </a:pPr>
             <a:r>
@@ -3853,14 +3510,14 @@
       </p:sp>
       <p:pic>
         <p:nvPicPr>
-          <p:cNvPr id="3" name="Image 0" descr="C:\laragon\www\sistema\docs\cu-reales\capturas\cu1_paso4_guardado.png">    </p:cNvPr>
+          <p:cNvPr id="3" name="Image 0" descr="C:\laragon\www\sistema\docs\cu-reales\capturas\cu1_paso4_guardado.png"/>
           <p:cNvPicPr>
             <a:picLocks noChangeAspect="1"/>
           </p:cNvPicPr>
           <p:nvPr/>
         </p:nvPicPr>
         <p:blipFill>
-          <a:blip r:embed="rId1"/>
+          <a:blip r:embed="rId3"/>
           <a:stretch>
             <a:fillRect/>
           </a:stretch>
@@ -3896,7 +3553,7 @@
           <a:bodyPr wrap="square" lIns="0" tIns="0" rIns="0" bIns="0" rtlCol="0" anchor="t"/>
           <a:lstStyle/>
           <a:p>
-            <a:pPr algn="l" indent="0" marL="0">
+            <a:pPr marL="0" indent="0" algn="l">
               <a:buNone/>
             </a:pPr>
             <a:r>
@@ -3910,9 +3567,6 @@
               </a:rPr>
               <a:t>Figura 4. </a:t>
             </a:r>
-            <a:pPr algn="l" indent="0" marL="0">
-              <a:buNone/>
-            </a:pPr>
             <a:r>
               <a:rPr lang="en-US" sz="1300" dirty="0">
                 <a:solidFill>
@@ -3944,6 +3598,7 @@
         <a:solidFill>
           <a:srgbClr val="FFFFFF"/>
         </a:solidFill>
+        <a:effectLst/>
       </p:bgPr>
     </p:bg>
     <p:spTree>
@@ -3981,7 +3636,7 @@
           <a:bodyPr wrap="square" lIns="0" tIns="0" rIns="0" bIns="0" rtlCol="0" anchor="ctr"/>
           <a:lstStyle/>
           <a:p>
-            <a:pPr indent="0" marL="0">
+            <a:pPr marL="0" indent="0">
               <a:buNone/>
             </a:pPr>
             <a:r>
@@ -4001,14 +3656,14 @@
       </p:sp>
       <p:pic>
         <p:nvPicPr>
-          <p:cNvPr id="3" name="Image 0" descr="C:\laragon\www\sistema\docs\cu-reales\capturas\cu2_paso1_listado.png">    </p:cNvPr>
+          <p:cNvPr id="3" name="Image 0" descr="C:\laragon\www\sistema\docs\cu-reales\capturas\cu2_paso1_listado.png"/>
           <p:cNvPicPr>
             <a:picLocks noChangeAspect="1"/>
           </p:cNvPicPr>
           <p:nvPr/>
         </p:nvPicPr>
         <p:blipFill>
-          <a:blip r:embed="rId1"/>
+          <a:blip r:embed="rId3"/>
           <a:stretch>
             <a:fillRect/>
           </a:stretch>
@@ -4044,7 +3699,7 @@
           <a:bodyPr wrap="square" lIns="0" tIns="0" rIns="0" bIns="0" rtlCol="0" anchor="t"/>
           <a:lstStyle/>
           <a:p>
-            <a:pPr algn="l" indent="0" marL="0">
+            <a:pPr marL="0" indent="0" algn="l">
               <a:buNone/>
             </a:pPr>
             <a:r>
@@ -4058,9 +3713,6 @@
               </a:rPr>
               <a:t>Figura 5. </a:t>
             </a:r>
-            <a:pPr algn="l" indent="0" marL="0">
-              <a:buNone/>
-            </a:pPr>
             <a:r>
               <a:rPr lang="en-US" sz="1300" dirty="0">
                 <a:solidFill>
@@ -4092,6 +3744,7 @@
         <a:solidFill>
           <a:srgbClr val="FFFFFF"/>
         </a:solidFill>
+        <a:effectLst/>
       </p:bgPr>
     </p:bg>
     <p:spTree>
@@ -4129,7 +3782,7 @@
           <a:bodyPr wrap="square" lIns="0" tIns="0" rIns="0" bIns="0" rtlCol="0" anchor="ctr"/>
           <a:lstStyle/>
           <a:p>
-            <a:pPr indent="0" marL="0">
+            <a:pPr marL="0" indent="0">
               <a:buNone/>
             </a:pPr>
             <a:r>
@@ -4149,14 +3802,14 @@
       </p:sp>
       <p:pic>
         <p:nvPicPr>
-          <p:cNvPr id="3" name="Image 0" descr="C:\laragon\www\sistema\docs\cu-reales\capturas\cu2_paso2_filtro.png">    </p:cNvPr>
+          <p:cNvPr id="3" name="Image 0" descr="C:\laragon\www\sistema\docs\cu-reales\capturas\cu2_paso2_filtro.png"/>
           <p:cNvPicPr>
             <a:picLocks noChangeAspect="1"/>
           </p:cNvPicPr>
           <p:nvPr/>
         </p:nvPicPr>
         <p:blipFill>
-          <a:blip r:embed="rId1"/>
+          <a:blip r:embed="rId3"/>
           <a:stretch>
             <a:fillRect/>
           </a:stretch>
@@ -4192,7 +3845,7 @@
           <a:bodyPr wrap="square" lIns="0" tIns="0" rIns="0" bIns="0" rtlCol="0" anchor="t"/>
           <a:lstStyle/>
           <a:p>
-            <a:pPr algn="l" indent="0" marL="0">
+            <a:pPr marL="0" indent="0" algn="l">
               <a:buNone/>
             </a:pPr>
             <a:r>
@@ -4206,9 +3859,6 @@
               </a:rPr>
               <a:t>Figura 6. </a:t>
             </a:r>
-            <a:pPr algn="l" indent="0" marL="0">
-              <a:buNone/>
-            </a:pPr>
             <a:r>
               <a:rPr lang="en-US" sz="1300" dirty="0">
                 <a:solidFill>
@@ -4240,6 +3890,7 @@
         <a:solidFill>
           <a:srgbClr val="FFFFFF"/>
         </a:solidFill>
+        <a:effectLst/>
       </p:bgPr>
     </p:bg>
     <p:spTree>
@@ -4277,7 +3928,7 @@
           <a:bodyPr wrap="square" lIns="0" tIns="0" rIns="0" bIns="0" rtlCol="0" anchor="ctr"/>
           <a:lstStyle/>
           <a:p>
-            <a:pPr indent="0" marL="0">
+            <a:pPr marL="0" indent="0">
               <a:buNone/>
             </a:pPr>
             <a:r>
@@ -4297,14 +3948,14 @@
       </p:sp>
       <p:pic>
         <p:nvPicPr>
-          <p:cNvPr id="3" name="Image 0" descr="C:\laragon\www\sistema\docs\cu-reales\capturas\cu2_paso3_detalle.png">    </p:cNvPr>
+          <p:cNvPr id="3" name="Image 0" descr="C:\laragon\www\sistema\docs\cu-reales\capturas\cu2_paso3_detalle.png"/>
           <p:cNvPicPr>
             <a:picLocks noChangeAspect="1"/>
           </p:cNvPicPr>
           <p:nvPr/>
         </p:nvPicPr>
         <p:blipFill>
-          <a:blip r:embed="rId1"/>
+          <a:blip r:embed="rId3"/>
           <a:stretch>
             <a:fillRect/>
           </a:stretch>
@@ -4340,7 +3991,7 @@
           <a:bodyPr wrap="square" lIns="0" tIns="0" rIns="0" bIns="0" rtlCol="0" anchor="t"/>
           <a:lstStyle/>
           <a:p>
-            <a:pPr algn="l" indent="0" marL="0">
+            <a:pPr marL="0" indent="0" algn="l">
               <a:buNone/>
             </a:pPr>
             <a:r>
@@ -4354,9 +4005,6 @@
               </a:rPr>
               <a:t>Figura 7. </a:t>
             </a:r>
-            <a:pPr algn="l" indent="0" marL="0">
-              <a:buNone/>
-            </a:pPr>
             <a:r>
               <a:rPr lang="en-US" sz="1300" dirty="0">
                 <a:solidFill>
@@ -4388,6 +4036,7 @@
         <a:solidFill>
           <a:srgbClr val="FFFFFF"/>
         </a:solidFill>
+        <a:effectLst/>
       </p:bgPr>
     </p:bg>
     <p:spTree>
@@ -4425,7 +4074,7 @@
           <a:bodyPr wrap="square" lIns="0" tIns="0" rIns="0" bIns="0" rtlCol="0" anchor="ctr"/>
           <a:lstStyle/>
           <a:p>
-            <a:pPr indent="0" marL="0">
+            <a:pPr marL="0" indent="0">
               <a:buNone/>
             </a:pPr>
             <a:r>
@@ -4445,14 +4094,14 @@
       </p:sp>
       <p:pic>
         <p:nvPicPr>
-          <p:cNvPr id="3" name="Image 0" descr="C:\laragon\www\sistema\docs\cu-reales\capturas\cu3_paso1_modal.png">    </p:cNvPr>
+          <p:cNvPr id="3" name="Image 0" descr="C:\laragon\www\sistema\docs\cu-reales\capturas\cu3_paso1_modal.png"/>
           <p:cNvPicPr>
             <a:picLocks noChangeAspect="1"/>
           </p:cNvPicPr>
           <p:nvPr/>
         </p:nvPicPr>
         <p:blipFill>
-          <a:blip r:embed="rId1"/>
+          <a:blip r:embed="rId3"/>
           <a:stretch>
             <a:fillRect/>
           </a:stretch>
@@ -4488,7 +4137,7 @@
           <a:bodyPr wrap="square" lIns="0" tIns="0" rIns="0" bIns="0" rtlCol="0" anchor="t"/>
           <a:lstStyle/>
           <a:p>
-            <a:pPr algn="l" indent="0" marL="0">
+            <a:pPr marL="0" indent="0" algn="l">
               <a:buNone/>
             </a:pPr>
             <a:r>
@@ -4502,9 +4151,6 @@
               </a:rPr>
               <a:t>Figura 8. </a:t>
             </a:r>
-            <a:pPr algn="l" indent="0" marL="0">
-              <a:buNone/>
-            </a:pPr>
             <a:r>
               <a:rPr lang="en-US" sz="1300" dirty="0">
                 <a:solidFill>
@@ -4536,6 +4182,7 @@
         <a:solidFill>
           <a:srgbClr val="FFFFFF"/>
         </a:solidFill>
+        <a:effectLst/>
       </p:bgPr>
     </p:bg>
     <p:spTree>
@@ -4573,7 +4220,7 @@
           <a:bodyPr wrap="square" lIns="0" tIns="0" rIns="0" bIns="0" rtlCol="0" anchor="ctr"/>
           <a:lstStyle/>
           <a:p>
-            <a:pPr indent="0" marL="0">
+            <a:pPr marL="0" indent="0">
               <a:buNone/>
             </a:pPr>
             <a:r>
@@ -4593,14 +4240,14 @@
       </p:sp>
       <p:pic>
         <p:nvPicPr>
-          <p:cNvPr id="3" name="Image 0" descr="C:\laragon\www\sistema\docs\cu-reales\capturas\cu3_paso2_estado.png">    </p:cNvPr>
+          <p:cNvPr id="3" name="Image 0" descr="C:\laragon\www\sistema\docs\cu-reales\capturas\cu3_paso2_estado.png"/>
           <p:cNvPicPr>
             <a:picLocks noChangeAspect="1"/>
           </p:cNvPicPr>
           <p:nvPr/>
         </p:nvPicPr>
         <p:blipFill>
-          <a:blip r:embed="rId1"/>
+          <a:blip r:embed="rId3"/>
           <a:stretch>
             <a:fillRect/>
           </a:stretch>
@@ -4636,7 +4283,7 @@
           <a:bodyPr wrap="square" lIns="0" tIns="0" rIns="0" bIns="0" rtlCol="0" anchor="t"/>
           <a:lstStyle/>
           <a:p>
-            <a:pPr algn="l" indent="0" marL="0">
+            <a:pPr marL="0" indent="0" algn="l">
               <a:buNone/>
             </a:pPr>
             <a:r>
@@ -4650,9 +4297,6 @@
               </a:rPr>
               <a:t>Figura 9. </a:t>
             </a:r>
-            <a:pPr algn="l" indent="0" marL="0">
-              <a:buNone/>
-            </a:pPr>
             <a:r>
               <a:rPr lang="en-US" sz="1300" dirty="0">
                 <a:solidFill>
@@ -4684,6 +4328,7 @@
         <a:solidFill>
           <a:srgbClr val="FFFFFF"/>
         </a:solidFill>
+        <a:effectLst/>
       </p:bgPr>
     </p:bg>
     <p:spTree>
@@ -4721,7 +4366,7 @@
           <a:bodyPr wrap="square" lIns="0" tIns="0" rIns="0" bIns="0" rtlCol="0" anchor="ctr"/>
           <a:lstStyle/>
           <a:p>
-            <a:pPr indent="0" marL="0">
+            <a:pPr marL="0" indent="0">
               <a:buNone/>
             </a:pPr>
             <a:r>
@@ -4741,14 +4386,14 @@
       </p:sp>
       <p:pic>
         <p:nvPicPr>
-          <p:cNvPr id="3" name="Image 0" descr="C:\laragon\www\sistema\docs\cu-reales\capturas\cu3_paso3_movida.png">    </p:cNvPr>
+          <p:cNvPr id="3" name="Image 0" descr="C:\laragon\www\sistema\docs\cu-reales\capturas\cu3_paso3_movida.png"/>
           <p:cNvPicPr>
             <a:picLocks noChangeAspect="1"/>
           </p:cNvPicPr>
           <p:nvPr/>
         </p:nvPicPr>
         <p:blipFill>
-          <a:blip r:embed="rId1"/>
+          <a:blip r:embed="rId3"/>
           <a:stretch>
             <a:fillRect/>
           </a:stretch>
@@ -4784,7 +4429,7 @@
           <a:bodyPr wrap="square" lIns="0" tIns="0" rIns="0" bIns="0" rtlCol="0" anchor="t"/>
           <a:lstStyle/>
           <a:p>
-            <a:pPr algn="l" indent="0" marL="0">
+            <a:pPr marL="0" indent="0" algn="l">
               <a:buNone/>
             </a:pPr>
             <a:r>
@@ -4798,9 +4443,6 @@
               </a:rPr>
               <a:t>Figura 10. </a:t>
             </a:r>
-            <a:pPr algn="l" indent="0" marL="0">
-              <a:buNone/>
-            </a:pPr>
             <a:r>
               <a:rPr lang="en-US" sz="1300" dirty="0">
                 <a:solidFill>
@@ -4832,6 +4474,7 @@
         <a:solidFill>
           <a:srgbClr val="FFFFFF"/>
         </a:solidFill>
+        <a:effectLst/>
       </p:bgPr>
     </p:bg>
     <p:spTree>
@@ -4869,7 +4512,7 @@
           <a:bodyPr wrap="square" lIns="0" tIns="0" rIns="0" bIns="0" rtlCol="0" anchor="ctr"/>
           <a:lstStyle/>
           <a:p>
-            <a:pPr indent="0" marL="0">
+            <a:pPr marL="0" indent="0">
               <a:buNone/>
             </a:pPr>
             <a:r>
@@ -4889,14 +4532,14 @@
       </p:sp>
       <p:pic>
         <p:nvPicPr>
-          <p:cNvPr id="3" name="Image 0" descr="C:\laragon\www\sistema\docs\cu-reales\capturas\cu4_paso1_tablero.png">    </p:cNvPr>
+          <p:cNvPr id="3" name="Image 0" descr="C:\laragon\www\sistema\docs\cu-reales\capturas\cu4_paso1_tablero.png"/>
           <p:cNvPicPr>
             <a:picLocks noChangeAspect="1"/>
           </p:cNvPicPr>
           <p:nvPr/>
         </p:nvPicPr>
         <p:blipFill>
-          <a:blip r:embed="rId1"/>
+          <a:blip r:embed="rId3"/>
           <a:stretch>
             <a:fillRect/>
           </a:stretch>
@@ -4932,7 +4575,7 @@
           <a:bodyPr wrap="square" lIns="0" tIns="0" rIns="0" bIns="0" rtlCol="0" anchor="t"/>
           <a:lstStyle/>
           <a:p>
-            <a:pPr algn="l" indent="0" marL="0">
+            <a:pPr marL="0" indent="0" algn="l">
               <a:buNone/>
             </a:pPr>
             <a:r>
@@ -4946,9 +4589,6 @@
               </a:rPr>
               <a:t>Figura 11. </a:t>
             </a:r>
-            <a:pPr algn="l" indent="0" marL="0">
-              <a:buNone/>
-            </a:pPr>
             <a:r>
               <a:rPr lang="en-US" sz="1300" dirty="0">
                 <a:solidFill>
@@ -4980,6 +4620,7 @@
         <a:solidFill>
           <a:srgbClr val="FFFFFF"/>
         </a:solidFill>
+        <a:effectLst/>
       </p:bgPr>
     </p:bg>
     <p:spTree>
@@ -5017,7 +4658,7 @@
           <a:bodyPr wrap="square" lIns="0" tIns="0" rIns="0" bIns="0" rtlCol="0" anchor="ctr"/>
           <a:lstStyle/>
           <a:p>
-            <a:pPr indent="0" marL="0">
+            <a:pPr marL="0" indent="0">
               <a:buNone/>
             </a:pPr>
             <a:r>
@@ -5037,14 +4678,14 @@
       </p:sp>
       <p:pic>
         <p:nvPicPr>
-          <p:cNvPr id="3" name="Image 0" descr="C:\laragon\www\sistema\docs\dsd\png-hd\01_pm_crea_proyecto.png">    </p:cNvPr>
+          <p:cNvPr id="3" name="Image 0" descr="C:\laragon\www\sistema\docs\dsd\png-hd\01_pm_crea_proyecto.png"/>
           <p:cNvPicPr>
             <a:picLocks noChangeAspect="1"/>
           </p:cNvPicPr>
           <p:nvPr/>
         </p:nvPicPr>
         <p:blipFill>
-          <a:blip r:embed="rId1"/>
+          <a:blip r:embed="rId3"/>
           <a:stretch>
             <a:fillRect/>
           </a:stretch>
@@ -5080,7 +4721,7 @@
           <a:bodyPr wrap="square" lIns="0" tIns="0" rIns="0" bIns="0" rtlCol="0" anchor="t"/>
           <a:lstStyle/>
           <a:p>
-            <a:pPr algn="l" indent="0" marL="0">
+            <a:pPr marL="0" indent="0" algn="l">
               <a:lnSpc>
                 <a:spcPct val="115000"/>
               </a:lnSpc>
@@ -5097,12 +4738,6 @@
               </a:rPr>
               <a:t>Qué representa: </a:t>
             </a:r>
-            <a:pPr algn="l" indent="0" marL="0">
-              <a:lnSpc>
-                <a:spcPct val="115000"/>
-              </a:lnSpc>
-              <a:buNone/>
-            </a:pPr>
             <a:r>
               <a:rPr lang="en-US" sz="1350" dirty="0">
                 <a:solidFill>
@@ -5139,7 +4774,7 @@
           <a:bodyPr wrap="square" lIns="0" tIns="0" rIns="0" bIns="0" rtlCol="0" anchor="ctr"/>
           <a:lstStyle/>
           <a:p>
-            <a:pPr algn="r" indent="0" marL="0">
+            <a:pPr marL="0" indent="0" algn="r">
               <a:buNone/>
             </a:pPr>
             <a:r>
@@ -5173,6 +4808,7 @@
         <a:solidFill>
           <a:srgbClr val="FFFFFF"/>
         </a:solidFill>
+        <a:effectLst/>
       </p:bgPr>
     </p:bg>
     <p:spTree>
@@ -5210,7 +4846,7 @@
           <a:bodyPr wrap="square" lIns="0" tIns="0" rIns="0" bIns="0" rtlCol="0" anchor="ctr"/>
           <a:lstStyle/>
           <a:p>
-            <a:pPr indent="0" marL="0">
+            <a:pPr marL="0" indent="0">
               <a:buNone/>
             </a:pPr>
             <a:r>
@@ -5230,14 +4866,14 @@
       </p:sp>
       <p:pic>
         <p:nvPicPr>
-          <p:cNvPr id="3" name="Image 0" descr="C:\laragon\www\sistema\docs\cu-reales\capturas\cu4_paso2_modal.png">    </p:cNvPr>
+          <p:cNvPr id="3" name="Image 0" descr="C:\laragon\www\sistema\docs\cu-reales\capturas\cu4_paso2_modal.png"/>
           <p:cNvPicPr>
             <a:picLocks noChangeAspect="1"/>
           </p:cNvPicPr>
           <p:nvPr/>
         </p:nvPicPr>
         <p:blipFill>
-          <a:blip r:embed="rId1"/>
+          <a:blip r:embed="rId3"/>
           <a:stretch>
             <a:fillRect/>
           </a:stretch>
@@ -5273,7 +4909,7 @@
           <a:bodyPr wrap="square" lIns="0" tIns="0" rIns="0" bIns="0" rtlCol="0" anchor="t"/>
           <a:lstStyle/>
           <a:p>
-            <a:pPr algn="l" indent="0" marL="0">
+            <a:pPr marL="0" indent="0" algn="l">
               <a:buNone/>
             </a:pPr>
             <a:r>
@@ -5287,9 +4923,6 @@
               </a:rPr>
               <a:t>Figura 12. </a:t>
             </a:r>
-            <a:pPr algn="l" indent="0" marL="0">
-              <a:buNone/>
-            </a:pPr>
             <a:r>
               <a:rPr lang="en-US" sz="1300" dirty="0">
                 <a:solidFill>
@@ -5321,6 +4954,7 @@
         <a:solidFill>
           <a:srgbClr val="FFFFFF"/>
         </a:solidFill>
+        <a:effectLst/>
       </p:bgPr>
     </p:bg>
     <p:spTree>
@@ -5358,7 +4992,7 @@
           <a:bodyPr wrap="square" lIns="0" tIns="0" rIns="0" bIns="0" rtlCol="0" anchor="ctr"/>
           <a:lstStyle/>
           <a:p>
-            <a:pPr indent="0" marL="0">
+            <a:pPr marL="0" indent="0">
               <a:buNone/>
             </a:pPr>
             <a:r>
@@ -5378,14 +5012,14 @@
       </p:sp>
       <p:pic>
         <p:nvPicPr>
-          <p:cNvPr id="3" name="Image 0" descr="C:\laragon\www\sistema\docs\cu-reales\capturas\cu4_paso3_confirmar.png">    </p:cNvPr>
+          <p:cNvPr id="3" name="Image 0" descr="C:\laragon\www\sistema\docs\cu-reales\capturas\cu4_paso3_confirmar.png"/>
           <p:cNvPicPr>
             <a:picLocks noChangeAspect="1"/>
           </p:cNvPicPr>
           <p:nvPr/>
         </p:nvPicPr>
         <p:blipFill>
-          <a:blip r:embed="rId1"/>
+          <a:blip r:embed="rId3"/>
           <a:stretch>
             <a:fillRect/>
           </a:stretch>
@@ -5421,7 +5055,7 @@
           <a:bodyPr wrap="square" lIns="0" tIns="0" rIns="0" bIns="0" rtlCol="0" anchor="t"/>
           <a:lstStyle/>
           <a:p>
-            <a:pPr algn="l" indent="0" marL="0">
+            <a:pPr marL="0" indent="0" algn="l">
               <a:buNone/>
             </a:pPr>
             <a:r>
@@ -5435,9 +5069,6 @@
               </a:rPr>
               <a:t>Figura 13. </a:t>
             </a:r>
-            <a:pPr algn="l" indent="0" marL="0">
-              <a:buNone/>
-            </a:pPr>
             <a:r>
               <a:rPr lang="en-US" sz="1300" dirty="0">
                 <a:solidFill>
@@ -5469,6 +5100,7 @@
         <a:solidFill>
           <a:srgbClr val="FFFFFF"/>
         </a:solidFill>
+        <a:effectLst/>
       </p:bgPr>
     </p:bg>
     <p:spTree>
@@ -5506,7 +5138,7 @@
           <a:bodyPr wrap="square" lIns="0" tIns="0" rIns="0" bIns="0" rtlCol="0" anchor="ctr"/>
           <a:lstStyle/>
           <a:p>
-            <a:pPr indent="0" marL="0">
+            <a:pPr marL="0" indent="0">
               <a:buNone/>
             </a:pPr>
             <a:r>
@@ -5526,14 +5158,14 @@
       </p:sp>
       <p:pic>
         <p:nvPicPr>
-          <p:cNvPr id="3" name="Image 0" descr="C:\laragon\www\sistema\docs\cu-reales\capturas\cu4_paso4_eliminada.png">    </p:cNvPr>
+          <p:cNvPr id="3" name="Image 0" descr="C:\laragon\www\sistema\docs\cu-reales\capturas\cu4_paso4_eliminada.png"/>
           <p:cNvPicPr>
             <a:picLocks noChangeAspect="1"/>
           </p:cNvPicPr>
           <p:nvPr/>
         </p:nvPicPr>
         <p:blipFill>
-          <a:blip r:embed="rId1"/>
+          <a:blip r:embed="rId3"/>
           <a:stretch>
             <a:fillRect/>
           </a:stretch>
@@ -5569,7 +5201,7 @@
           <a:bodyPr wrap="square" lIns="0" tIns="0" rIns="0" bIns="0" rtlCol="0" anchor="t"/>
           <a:lstStyle/>
           <a:p>
-            <a:pPr algn="l" indent="0" marL="0">
+            <a:pPr marL="0" indent="0" algn="l">
               <a:buNone/>
             </a:pPr>
             <a:r>
@@ -5583,9 +5215,6 @@
               </a:rPr>
               <a:t>Figura 14. </a:t>
             </a:r>
-            <a:pPr algn="l" indent="0" marL="0">
-              <a:buNone/>
-            </a:pPr>
             <a:r>
               <a:rPr lang="en-US" sz="1300" dirty="0">
                 <a:solidFill>
@@ -5617,6 +5246,7 @@
         <a:solidFill>
           <a:srgbClr val="FFFFFF"/>
         </a:solidFill>
+        <a:effectLst/>
       </p:bgPr>
     </p:bg>
     <p:spTree>
@@ -5654,7 +5284,7 @@
           <a:bodyPr wrap="square" lIns="0" tIns="0" rIns="0" bIns="0" rtlCol="0" anchor="ctr"/>
           <a:lstStyle/>
           <a:p>
-            <a:pPr indent="0" marL="0">
+            <a:pPr marL="0" indent="0">
               <a:buNone/>
             </a:pPr>
             <a:r>
@@ -5674,14 +5304,14 @@
       </p:sp>
       <p:pic>
         <p:nvPicPr>
-          <p:cNvPr id="3" name="Image 0" descr="C:\laragon\www\sistema\docs\cu-reales\capturas\cu5_paso1_listado.png">    </p:cNvPr>
+          <p:cNvPr id="3" name="Image 0" descr="C:\laragon\www\sistema\docs\cu-reales\capturas\cu5_paso1_listado.png"/>
           <p:cNvPicPr>
             <a:picLocks noChangeAspect="1"/>
           </p:cNvPicPr>
           <p:nvPr/>
         </p:nvPicPr>
         <p:blipFill>
-          <a:blip r:embed="rId1"/>
+          <a:blip r:embed="rId3"/>
           <a:stretch>
             <a:fillRect/>
           </a:stretch>
@@ -5717,7 +5347,7 @@
           <a:bodyPr wrap="square" lIns="0" tIns="0" rIns="0" bIns="0" rtlCol="0" anchor="t"/>
           <a:lstStyle/>
           <a:p>
-            <a:pPr algn="l" indent="0" marL="0">
+            <a:pPr marL="0" indent="0" algn="l">
               <a:buNone/>
             </a:pPr>
             <a:r>
@@ -5731,9 +5361,6 @@
               </a:rPr>
               <a:t>Figura 15. </a:t>
             </a:r>
-            <a:pPr algn="l" indent="0" marL="0">
-              <a:buNone/>
-            </a:pPr>
             <a:r>
               <a:rPr lang="en-US" sz="1300" dirty="0">
                 <a:solidFill>
@@ -5765,6 +5392,7 @@
         <a:solidFill>
           <a:srgbClr val="FFFFFF"/>
         </a:solidFill>
+        <a:effectLst/>
       </p:bgPr>
     </p:bg>
     <p:spTree>
@@ -5802,7 +5430,7 @@
           <a:bodyPr wrap="square" lIns="0" tIns="0" rIns="0" bIns="0" rtlCol="0" anchor="ctr"/>
           <a:lstStyle/>
           <a:p>
-            <a:pPr indent="0" marL="0">
+            <a:pPr marL="0" indent="0">
               <a:buNone/>
             </a:pPr>
             <a:r>
@@ -5822,14 +5450,14 @@
       </p:sp>
       <p:pic>
         <p:nvPicPr>
-          <p:cNvPr id="3" name="Image 0" descr="C:\laragon\www\sistema\docs\cu-reales\capturas\cu5_paso2_aprobada.png">    </p:cNvPr>
+          <p:cNvPr id="3" name="Image 0" descr="C:\laragon\www\sistema\docs\cu-reales\capturas\cu5_paso2_aprobada.png"/>
           <p:cNvPicPr>
             <a:picLocks noChangeAspect="1"/>
           </p:cNvPicPr>
           <p:nvPr/>
         </p:nvPicPr>
         <p:blipFill>
-          <a:blip r:embed="rId1"/>
+          <a:blip r:embed="rId3"/>
           <a:stretch>
             <a:fillRect/>
           </a:stretch>
@@ -5865,7 +5493,7 @@
           <a:bodyPr wrap="square" lIns="0" tIns="0" rIns="0" bIns="0" rtlCol="0" anchor="t"/>
           <a:lstStyle/>
           <a:p>
-            <a:pPr algn="l" indent="0" marL="0">
+            <a:pPr marL="0" indent="0" algn="l">
               <a:buNone/>
             </a:pPr>
             <a:r>
@@ -5879,9 +5507,6 @@
               </a:rPr>
               <a:t>Figura 16. </a:t>
             </a:r>
-            <a:pPr algn="l" indent="0" marL="0">
-              <a:buNone/>
-            </a:pPr>
             <a:r>
               <a:rPr lang="en-US" sz="1300" dirty="0">
                 <a:solidFill>
@@ -5913,6 +5538,7 @@
         <a:solidFill>
           <a:srgbClr val="FFFFFF"/>
         </a:solidFill>
+        <a:effectLst/>
       </p:bgPr>
     </p:bg>
     <p:spTree>
@@ -5950,7 +5576,7 @@
           <a:bodyPr wrap="square" lIns="0" tIns="0" rIns="0" bIns="0" rtlCol="0" anchor="ctr"/>
           <a:lstStyle/>
           <a:p>
-            <a:pPr indent="0" marL="0">
+            <a:pPr marL="0" indent="0">
               <a:buNone/>
             </a:pPr>
             <a:r>
@@ -5970,14 +5596,14 @@
       </p:sp>
       <p:pic>
         <p:nvPicPr>
-          <p:cNvPr id="3" name="Image 0" descr="C:\laragon\www\sistema\docs\cu-reales\capturas\cu5_paso3_guardada.png">    </p:cNvPr>
+          <p:cNvPr id="3" name="Image 0" descr="C:\laragon\www\sistema\docs\cu-reales\capturas\cu5_paso3_guardada.png"/>
           <p:cNvPicPr>
             <a:picLocks noChangeAspect="1"/>
           </p:cNvPicPr>
           <p:nvPr/>
         </p:nvPicPr>
         <p:blipFill>
-          <a:blip r:embed="rId1"/>
+          <a:blip r:embed="rId3"/>
           <a:stretch>
             <a:fillRect/>
           </a:stretch>
@@ -6013,7 +5639,7 @@
           <a:bodyPr wrap="square" lIns="0" tIns="0" rIns="0" bIns="0" rtlCol="0" anchor="t"/>
           <a:lstStyle/>
           <a:p>
-            <a:pPr algn="l" indent="0" marL="0">
+            <a:pPr marL="0" indent="0" algn="l">
               <a:buNone/>
             </a:pPr>
             <a:r>
@@ -6027,9 +5653,6 @@
               </a:rPr>
               <a:t>Figura 17. </a:t>
             </a:r>
-            <a:pPr algn="l" indent="0" marL="0">
-              <a:buNone/>
-            </a:pPr>
             <a:r>
               <a:rPr lang="en-US" sz="1300" dirty="0">
                 <a:solidFill>
@@ -6061,6 +5684,7 @@
         <a:solidFill>
           <a:srgbClr val="FFFFFF"/>
         </a:solidFill>
+        <a:effectLst/>
       </p:bgPr>
     </p:bg>
     <p:spTree>
@@ -6098,7 +5722,7 @@
           <a:bodyPr wrap="square" lIns="0" tIns="0" rIns="0" bIns="0" rtlCol="0" anchor="ctr"/>
           <a:lstStyle/>
           <a:p>
-            <a:pPr indent="0" marL="0">
+            <a:pPr marL="0" indent="0">
               <a:buNone/>
             </a:pPr>
             <a:r>
@@ -6118,14 +5742,14 @@
       </p:sp>
       <p:pic>
         <p:nvPicPr>
-          <p:cNvPr id="3" name="Image 0" descr="C:\laragon\www\sistema\docs\cu-reales\capturas\cu6_paso1_listado.png">    </p:cNvPr>
+          <p:cNvPr id="3" name="Image 0" descr="C:\laragon\www\sistema\docs\cu-reales\capturas\cu6_paso1_listado.png"/>
           <p:cNvPicPr>
             <a:picLocks noChangeAspect="1"/>
           </p:cNvPicPr>
           <p:nvPr/>
         </p:nvPicPr>
         <p:blipFill>
-          <a:blip r:embed="rId1"/>
+          <a:blip r:embed="rId3"/>
           <a:stretch>
             <a:fillRect/>
           </a:stretch>
@@ -6161,7 +5785,7 @@
           <a:bodyPr wrap="square" lIns="0" tIns="0" rIns="0" bIns="0" rtlCol="0" anchor="t"/>
           <a:lstStyle/>
           <a:p>
-            <a:pPr algn="l" indent="0" marL="0">
+            <a:pPr marL="0" indent="0" algn="l">
               <a:buNone/>
             </a:pPr>
             <a:r>
@@ -6175,9 +5799,6 @@
               </a:rPr>
               <a:t>Figura 18. </a:t>
             </a:r>
-            <a:pPr algn="l" indent="0" marL="0">
-              <a:buNone/>
-            </a:pPr>
             <a:r>
               <a:rPr lang="en-US" sz="1300" dirty="0">
                 <a:solidFill>
@@ -6209,6 +5830,7 @@
         <a:solidFill>
           <a:srgbClr val="FFFFFF"/>
         </a:solidFill>
+        <a:effectLst/>
       </p:bgPr>
     </p:bg>
     <p:spTree>
@@ -6246,7 +5868,7 @@
           <a:bodyPr wrap="square" lIns="0" tIns="0" rIns="0" bIns="0" rtlCol="0" anchor="ctr"/>
           <a:lstStyle/>
           <a:p>
-            <a:pPr indent="0" marL="0">
+            <a:pPr marL="0" indent="0">
               <a:buNone/>
             </a:pPr>
             <a:r>
@@ -6266,14 +5888,14 @@
       </p:sp>
       <p:pic>
         <p:nvPicPr>
-          <p:cNvPr id="3" name="Image 0" descr="C:\laragon\www\sistema\docs\cu-reales\capturas\cu6_paso2_aprobado.png">    </p:cNvPr>
+          <p:cNvPr id="3" name="Image 0" descr="C:\laragon\www\sistema\docs\cu-reales\capturas\cu6_paso2_aprobado.png"/>
           <p:cNvPicPr>
             <a:picLocks noChangeAspect="1"/>
           </p:cNvPicPr>
           <p:nvPr/>
         </p:nvPicPr>
         <p:blipFill>
-          <a:blip r:embed="rId1"/>
+          <a:blip r:embed="rId3"/>
           <a:stretch>
             <a:fillRect/>
           </a:stretch>
@@ -6309,7 +5931,7 @@
           <a:bodyPr wrap="square" lIns="0" tIns="0" rIns="0" bIns="0" rtlCol="0" anchor="t"/>
           <a:lstStyle/>
           <a:p>
-            <a:pPr algn="l" indent="0" marL="0">
+            <a:pPr marL="0" indent="0" algn="l">
               <a:buNone/>
             </a:pPr>
             <a:r>
@@ -6323,9 +5945,6 @@
               </a:rPr>
               <a:t>Figura 19. </a:t>
             </a:r>
-            <a:pPr algn="l" indent="0" marL="0">
-              <a:buNone/>
-            </a:pPr>
             <a:r>
               <a:rPr lang="en-US" sz="1300" dirty="0">
                 <a:solidFill>
@@ -6357,6 +5976,7 @@
         <a:solidFill>
           <a:srgbClr val="FFFFFF"/>
         </a:solidFill>
+        <a:effectLst/>
       </p:bgPr>
     </p:bg>
     <p:spTree>
@@ -6394,7 +6014,7 @@
           <a:bodyPr wrap="square" lIns="0" tIns="0" rIns="0" bIns="0" rtlCol="0" anchor="ctr"/>
           <a:lstStyle/>
           <a:p>
-            <a:pPr indent="0" marL="0">
+            <a:pPr marL="0" indent="0">
               <a:buNone/>
             </a:pPr>
             <a:r>
@@ -6414,14 +6034,14 @@
       </p:sp>
       <p:pic>
         <p:nvPicPr>
-          <p:cNvPr id="3" name="Image 0" descr="C:\laragon\www\sistema\docs\cu-reales\capturas\cu6_paso3_guardado.png">    </p:cNvPr>
+          <p:cNvPr id="3" name="Image 0" descr="C:\laragon\www\sistema\docs\cu-reales\capturas\cu6_paso3_guardado.png"/>
           <p:cNvPicPr>
             <a:picLocks noChangeAspect="1"/>
           </p:cNvPicPr>
           <p:nvPr/>
         </p:nvPicPr>
         <p:blipFill>
-          <a:blip r:embed="rId1"/>
+          <a:blip r:embed="rId3"/>
           <a:stretch>
             <a:fillRect/>
           </a:stretch>
@@ -6457,7 +6077,7 @@
           <a:bodyPr wrap="square" lIns="0" tIns="0" rIns="0" bIns="0" rtlCol="0" anchor="t"/>
           <a:lstStyle/>
           <a:p>
-            <a:pPr algn="l" indent="0" marL="0">
+            <a:pPr marL="0" indent="0" algn="l">
               <a:buNone/>
             </a:pPr>
             <a:r>
@@ -6471,9 +6091,6 @@
               </a:rPr>
               <a:t>Figura 20. </a:t>
             </a:r>
-            <a:pPr algn="l" indent="0" marL="0">
-              <a:buNone/>
-            </a:pPr>
             <a:r>
               <a:rPr lang="en-US" sz="1300" dirty="0">
                 <a:solidFill>
@@ -6505,6 +6122,7 @@
         <a:solidFill>
           <a:srgbClr val="0F172A"/>
         </a:solidFill>
+        <a:effectLst/>
       </p:bgPr>
     </p:bg>
     <p:spTree>
@@ -6542,7 +6160,7 @@
           <a:bodyPr wrap="square" rtlCol="0" anchor="ctr"/>
           <a:lstStyle/>
           <a:p>
-            <a:pPr algn="ctr" indent="0" marL="0">
+            <a:pPr marL="0" indent="0" algn="ctr">
               <a:buNone/>
             </a:pPr>
             <a:r>
@@ -6581,7 +6199,7 @@
           <a:bodyPr wrap="square" rtlCol="0" anchor="ctr"/>
           <a:lstStyle/>
           <a:p>
-            <a:pPr algn="ctr" indent="0" marL="0">
+            <a:pPr marL="0" indent="0" algn="ctr">
               <a:buNone/>
             </a:pPr>
             <a:r>
@@ -6615,6 +6233,7 @@
         <a:solidFill>
           <a:srgbClr val="FFFFFF"/>
         </a:solidFill>
+        <a:effectLst/>
       </p:bgPr>
     </p:bg>
     <p:spTree>
@@ -6652,7 +6271,7 @@
           <a:bodyPr wrap="square" lIns="0" tIns="0" rIns="0" bIns="0" rtlCol="0" anchor="ctr"/>
           <a:lstStyle/>
           <a:p>
-            <a:pPr indent="0" marL="0">
+            <a:pPr marL="0" indent="0">
               <a:buNone/>
             </a:pPr>
             <a:r>
@@ -6672,14 +6291,14 @@
       </p:sp>
       <p:pic>
         <p:nvPicPr>
-          <p:cNvPr id="3" name="Image 0" descr="C:\laragon\www\sistema\docs\dsd\png-hd\02_programador_ve_tareas.png">    </p:cNvPr>
+          <p:cNvPr id="3" name="Image 0" descr="C:\laragon\www\sistema\docs\dsd\png-hd\02_programador_ve_tareas.png"/>
           <p:cNvPicPr>
             <a:picLocks noChangeAspect="1"/>
           </p:cNvPicPr>
           <p:nvPr/>
         </p:nvPicPr>
         <p:blipFill>
-          <a:blip r:embed="rId1"/>
+          <a:blip r:embed="rId3"/>
           <a:stretch>
             <a:fillRect/>
           </a:stretch>
@@ -6715,7 +6334,7 @@
           <a:bodyPr wrap="square" lIns="0" tIns="0" rIns="0" bIns="0" rtlCol="0" anchor="t"/>
           <a:lstStyle/>
           <a:p>
-            <a:pPr algn="l" indent="0" marL="0">
+            <a:pPr marL="0" indent="0" algn="l">
               <a:lnSpc>
                 <a:spcPct val="115000"/>
               </a:lnSpc>
@@ -6732,12 +6351,6 @@
               </a:rPr>
               <a:t>Qué representa: </a:t>
             </a:r>
-            <a:pPr algn="l" indent="0" marL="0">
-              <a:lnSpc>
-                <a:spcPct val="115000"/>
-              </a:lnSpc>
-              <a:buNone/>
-            </a:pPr>
             <a:r>
               <a:rPr lang="en-US" sz="1350" dirty="0">
                 <a:solidFill>
@@ -6774,7 +6387,7 @@
           <a:bodyPr wrap="square" lIns="0" tIns="0" rIns="0" bIns="0" rtlCol="0" anchor="ctr"/>
           <a:lstStyle/>
           <a:p>
-            <a:pPr algn="r" indent="0" marL="0">
+            <a:pPr marL="0" indent="0" algn="r">
               <a:buNone/>
             </a:pPr>
             <a:r>
@@ -6808,6 +6421,7 @@
         <a:solidFill>
           <a:srgbClr val="FFFFFF"/>
         </a:solidFill>
+        <a:effectLst/>
       </p:bgPr>
     </p:bg>
     <p:spTree>
@@ -6845,7 +6459,7 @@
           <a:bodyPr wrap="square" lIns="0" tIns="0" rIns="0" bIns="0" rtlCol="0" anchor="ctr"/>
           <a:lstStyle/>
           <a:p>
-            <a:pPr indent="0" marL="0">
+            <a:pPr marL="0" indent="0">
               <a:buNone/>
             </a:pPr>
             <a:r>
@@ -6865,14 +6479,14 @@
       </p:sp>
       <p:pic>
         <p:nvPicPr>
-          <p:cNvPr id="3" name="Image 0" descr="C:\laragon\www\sistema\docs\dsd\png-hd\03_edita_tarea_tablero.png">    </p:cNvPr>
+          <p:cNvPr id="3" name="Image 0" descr="C:\laragon\www\sistema\docs\dsd\png-hd\03_edita_tarea_tablero.png"/>
           <p:cNvPicPr>
             <a:picLocks noChangeAspect="1"/>
           </p:cNvPicPr>
           <p:nvPr/>
         </p:nvPicPr>
         <p:blipFill>
-          <a:blip r:embed="rId1"/>
+          <a:blip r:embed="rId3"/>
           <a:stretch>
             <a:fillRect/>
           </a:stretch>
@@ -6908,7 +6522,7 @@
           <a:bodyPr wrap="square" lIns="0" tIns="0" rIns="0" bIns="0" rtlCol="0" anchor="t"/>
           <a:lstStyle/>
           <a:p>
-            <a:pPr algn="l" indent="0" marL="0">
+            <a:pPr marL="0" indent="0" algn="l">
               <a:lnSpc>
                 <a:spcPct val="115000"/>
               </a:lnSpc>
@@ -6925,12 +6539,6 @@
               </a:rPr>
               <a:t>Qué representa: </a:t>
             </a:r>
-            <a:pPr algn="l" indent="0" marL="0">
-              <a:lnSpc>
-                <a:spcPct val="115000"/>
-              </a:lnSpc>
-              <a:buNone/>
-            </a:pPr>
             <a:r>
               <a:rPr lang="en-US" sz="1350" dirty="0">
                 <a:solidFill>
@@ -6967,7 +6575,7 @@
           <a:bodyPr wrap="square" lIns="0" tIns="0" rIns="0" bIns="0" rtlCol="0" anchor="ctr"/>
           <a:lstStyle/>
           <a:p>
-            <a:pPr algn="r" indent="0" marL="0">
+            <a:pPr marL="0" indent="0" algn="r">
               <a:buNone/>
             </a:pPr>
             <a:r>
@@ -7001,6 +6609,7 @@
         <a:solidFill>
           <a:srgbClr val="FFFFFF"/>
         </a:solidFill>
+        <a:effectLst/>
       </p:bgPr>
     </p:bg>
     <p:spTree>
@@ -7038,7 +6647,7 @@
           <a:bodyPr wrap="square" lIns="0" tIns="0" rIns="0" bIns="0" rtlCol="0" anchor="ctr"/>
           <a:lstStyle/>
           <a:p>
-            <a:pPr indent="0" marL="0">
+            <a:pPr marL="0" indent="0">
               <a:buNone/>
             </a:pPr>
             <a:r>
@@ -7058,14 +6667,14 @@
       </p:sp>
       <p:pic>
         <p:nvPicPr>
-          <p:cNvPr id="3" name="Image 0" descr="C:\laragon\www\sistema\docs\dsd\png-hd\04_pm_elimina_tarea.png">    </p:cNvPr>
+          <p:cNvPr id="3" name="Image 0" descr="C:\laragon\www\sistema\docs\dsd\png-hd\04_pm_elimina_tarea.png"/>
           <p:cNvPicPr>
             <a:picLocks noChangeAspect="1"/>
           </p:cNvPicPr>
           <p:nvPr/>
         </p:nvPicPr>
         <p:blipFill>
-          <a:blip r:embed="rId1"/>
+          <a:blip r:embed="rId3"/>
           <a:stretch>
             <a:fillRect/>
           </a:stretch>
@@ -7101,7 +6710,7 @@
           <a:bodyPr wrap="square" lIns="0" tIns="0" rIns="0" bIns="0" rtlCol="0" anchor="t"/>
           <a:lstStyle/>
           <a:p>
-            <a:pPr algn="l" indent="0" marL="0">
+            <a:pPr marL="0" indent="0" algn="l">
               <a:lnSpc>
                 <a:spcPct val="115000"/>
               </a:lnSpc>
@@ -7118,12 +6727,6 @@
               </a:rPr>
               <a:t>Qué representa: </a:t>
             </a:r>
-            <a:pPr algn="l" indent="0" marL="0">
-              <a:lnSpc>
-                <a:spcPct val="115000"/>
-              </a:lnSpc>
-              <a:buNone/>
-            </a:pPr>
             <a:r>
               <a:rPr lang="en-US" sz="1350" dirty="0">
                 <a:solidFill>
@@ -7160,7 +6763,7 @@
           <a:bodyPr wrap="square" lIns="0" tIns="0" rIns="0" bIns="0" rtlCol="0" anchor="ctr"/>
           <a:lstStyle/>
           <a:p>
-            <a:pPr algn="r" indent="0" marL="0">
+            <a:pPr marL="0" indent="0" algn="r">
               <a:buNone/>
             </a:pPr>
             <a:r>
@@ -7194,6 +6797,7 @@
         <a:solidFill>
           <a:srgbClr val="FFFFFF"/>
         </a:solidFill>
+        <a:effectLst/>
       </p:bgPr>
     </p:bg>
     <p:spTree>
@@ -7231,7 +6835,7 @@
           <a:bodyPr wrap="square" lIns="0" tIns="0" rIns="0" bIns="0" rtlCol="0" anchor="ctr"/>
           <a:lstStyle/>
           <a:p>
-            <a:pPr indent="0" marL="0">
+            <a:pPr marL="0" indent="0">
               <a:buNone/>
             </a:pPr>
             <a:r>
@@ -7251,14 +6855,14 @@
       </p:sp>
       <p:pic>
         <p:nvPicPr>
-          <p:cNvPr id="3" name="Image 0" descr="C:\laragon\www\sistema\docs\dsd\png-hd\05_jefe_aprueba_solicitud.png">    </p:cNvPr>
+          <p:cNvPr id="3" name="Image 0" descr="C:\laragon\www\sistema\docs\dsd\png-hd\05_jefe_aprueba_solicitud.png"/>
           <p:cNvPicPr>
             <a:picLocks noChangeAspect="1"/>
           </p:cNvPicPr>
           <p:nvPr/>
         </p:nvPicPr>
         <p:blipFill>
-          <a:blip r:embed="rId1"/>
+          <a:blip r:embed="rId3"/>
           <a:stretch>
             <a:fillRect/>
           </a:stretch>
@@ -7294,7 +6898,7 @@
           <a:bodyPr wrap="square" lIns="0" tIns="0" rIns="0" bIns="0" rtlCol="0" anchor="t"/>
           <a:lstStyle/>
           <a:p>
-            <a:pPr algn="l" indent="0" marL="0">
+            <a:pPr marL="0" indent="0" algn="l">
               <a:lnSpc>
                 <a:spcPct val="115000"/>
               </a:lnSpc>
@@ -7311,12 +6915,6 @@
               </a:rPr>
               <a:t>Qué representa: </a:t>
             </a:r>
-            <a:pPr algn="l" indent="0" marL="0">
-              <a:lnSpc>
-                <a:spcPct val="115000"/>
-              </a:lnSpc>
-              <a:buNone/>
-            </a:pPr>
             <a:r>
               <a:rPr lang="en-US" sz="1350" dirty="0">
                 <a:solidFill>
@@ -7353,7 +6951,7 @@
           <a:bodyPr wrap="square" lIns="0" tIns="0" rIns="0" bIns="0" rtlCol="0" anchor="ctr"/>
           <a:lstStyle/>
           <a:p>
-            <a:pPr algn="r" indent="0" marL="0">
+            <a:pPr marL="0" indent="0" algn="r">
               <a:buNone/>
             </a:pPr>
             <a:r>
@@ -7387,6 +6985,7 @@
         <a:solidFill>
           <a:srgbClr val="FFFFFF"/>
         </a:solidFill>
+        <a:effectLst/>
       </p:bgPr>
     </p:bg>
     <p:spTree>
@@ -7424,7 +7023,7 @@
           <a:bodyPr wrap="square" lIns="0" tIns="0" rIns="0" bIns="0" rtlCol="0" anchor="ctr"/>
           <a:lstStyle/>
           <a:p>
-            <a:pPr indent="0" marL="0">
+            <a:pPr marL="0" indent="0">
               <a:buNone/>
             </a:pPr>
             <a:r>
@@ -7444,14 +7043,14 @@
       </p:sp>
       <p:pic>
         <p:nvPicPr>
-          <p:cNvPr id="3" name="Image 0" descr="C:\laragon\www\sistema\docs\dsd\png-hd\06_po_gestiona_entregables.png">    </p:cNvPr>
+          <p:cNvPr id="3" name="Image 0" descr="C:\laragon\www\sistema\docs\dsd\png-hd\06_po_gestiona_entregables.png"/>
           <p:cNvPicPr>
             <a:picLocks noChangeAspect="1"/>
           </p:cNvPicPr>
           <p:nvPr/>
         </p:nvPicPr>
         <p:blipFill>
-          <a:blip r:embed="rId1"/>
+          <a:blip r:embed="rId3"/>
           <a:stretch>
             <a:fillRect/>
           </a:stretch>
@@ -7487,7 +7086,7 @@
           <a:bodyPr wrap="square" lIns="0" tIns="0" rIns="0" bIns="0" rtlCol="0" anchor="t"/>
           <a:lstStyle/>
           <a:p>
-            <a:pPr algn="l" indent="0" marL="0">
+            <a:pPr marL="0" indent="0" algn="l">
               <a:lnSpc>
                 <a:spcPct val="115000"/>
               </a:lnSpc>
@@ -7504,12 +7103,6 @@
               </a:rPr>
               <a:t>Qué representa: </a:t>
             </a:r>
-            <a:pPr algn="l" indent="0" marL="0">
-              <a:lnSpc>
-                <a:spcPct val="115000"/>
-              </a:lnSpc>
-              <a:buNone/>
-            </a:pPr>
             <a:r>
               <a:rPr lang="en-US" sz="1350" dirty="0">
                 <a:solidFill>
@@ -7546,7 +7139,7 @@
           <a:bodyPr wrap="square" lIns="0" tIns="0" rIns="0" bIns="0" rtlCol="0" anchor="ctr"/>
           <a:lstStyle/>
           <a:p>
-            <a:pPr algn="r" indent="0" marL="0">
+            <a:pPr marL="0" indent="0" algn="r">
               <a:buNone/>
             </a:pPr>
             <a:r>
@@ -7580,6 +7173,7 @@
         <a:solidFill>
           <a:srgbClr val="0F172A"/>
         </a:solidFill>
+        <a:effectLst/>
       </p:bgPr>
     </p:bg>
     <p:spTree>
@@ -7617,7 +7211,7 @@
           <a:bodyPr wrap="square" rtlCol="0" anchor="ctr"/>
           <a:lstStyle/>
           <a:p>
-            <a:pPr algn="ctr" indent="0" marL="0">
+            <a:pPr marL="0" indent="0" algn="ctr">
               <a:buNone/>
             </a:pPr>
             <a:r>
@@ -7656,7 +7250,7 @@
           <a:bodyPr wrap="square" rtlCol="0" anchor="ctr"/>
           <a:lstStyle/>
           <a:p>
-            <a:pPr algn="ctr" indent="0" marL="0">
+            <a:pPr marL="0" indent="0" algn="ctr">
               <a:buNone/>
             </a:pPr>
             <a:r>
@@ -7690,6 +7284,7 @@
         <a:solidFill>
           <a:srgbClr val="FFFFFF"/>
         </a:solidFill>
+        <a:effectLst/>
       </p:bgPr>
     </p:bg>
     <p:spTree>
@@ -7727,7 +7322,7 @@
           <a:bodyPr wrap="square" lIns="0" tIns="0" rIns="0" bIns="0" rtlCol="0" anchor="ctr"/>
           <a:lstStyle/>
           <a:p>
-            <a:pPr indent="0" marL="0">
+            <a:pPr marL="0" indent="0">
               <a:buNone/>
             </a:pPr>
             <a:r>
@@ -7747,14 +7342,14 @@
       </p:sp>
       <p:pic>
         <p:nvPicPr>
-          <p:cNvPr id="3" name="Image 0" descr="C:\laragon\www\sistema\docs\cu-reales\capturas\cu1_paso1_listado.png">    </p:cNvPr>
+          <p:cNvPr id="3" name="Image 0" descr="C:\laragon\www\sistema\docs\cu-reales\capturas\cu1_paso1_listado.png"/>
           <p:cNvPicPr>
             <a:picLocks noChangeAspect="1"/>
           </p:cNvPicPr>
           <p:nvPr/>
         </p:nvPicPr>
         <p:blipFill>
-          <a:blip r:embed="rId1"/>
+          <a:blip r:embed="rId3"/>
           <a:stretch>
             <a:fillRect/>
           </a:stretch>
@@ -7790,7 +7385,7 @@
           <a:bodyPr wrap="square" lIns="0" tIns="0" rIns="0" bIns="0" rtlCol="0" anchor="t"/>
           <a:lstStyle/>
           <a:p>
-            <a:pPr algn="l" indent="0" marL="0">
+            <a:pPr marL="0" indent="0" algn="l">
               <a:buNone/>
             </a:pPr>
             <a:r>
@@ -7804,9 +7399,6 @@
               </a:rPr>
               <a:t>Figura 1. </a:t>
             </a:r>
-            <a:pPr algn="l" indent="0" marL="0">
-              <a:buNone/>
-            </a:pPr>
             <a:r>
               <a:rPr lang="en-US" sz="1300" dirty="0">
                 <a:solidFill>
@@ -8123,4 +7715,299 @@
     </a:ext>
   </a:extLst>
 </a:theme>
+</file>
+
+<file path=ppt/theme/theme2.xml><?xml version="1.0" encoding="utf-8"?>
+<a:theme xmlns:a="http://schemas.openxmlformats.org/drawingml/2006/main" name="Tema de Office">
+  <a:themeElements>
+    <a:clrScheme name="Office">
+      <a:dk1>
+        <a:sysClr val="windowText" lastClr="000000"/>
+      </a:dk1>
+      <a:lt1>
+        <a:sysClr val="window" lastClr="FFFFFF"/>
+      </a:lt1>
+      <a:dk2>
+        <a:srgbClr val="44546A"/>
+      </a:dk2>
+      <a:lt2>
+        <a:srgbClr val="E7E6E6"/>
+      </a:lt2>
+      <a:accent1>
+        <a:srgbClr val="4472C4"/>
+      </a:accent1>
+      <a:accent2>
+        <a:srgbClr val="ED7D31"/>
+      </a:accent2>
+      <a:accent3>
+        <a:srgbClr val="A5A5A5"/>
+      </a:accent3>
+      <a:accent4>
+        <a:srgbClr val="FFC000"/>
+      </a:accent4>
+      <a:accent5>
+        <a:srgbClr val="5B9BD5"/>
+      </a:accent5>
+      <a:accent6>
+        <a:srgbClr val="70AD47"/>
+      </a:accent6>
+      <a:hlink>
+        <a:srgbClr val="0563C1"/>
+      </a:hlink>
+      <a:folHlink>
+        <a:srgbClr val="954F72"/>
+      </a:folHlink>
+    </a:clrScheme>
+    <a:fontScheme name="Office">
+      <a:majorFont>
+        <a:latin typeface="Calibri Light" panose="020F0302020204030204"/>
+        <a:ea typeface=""/>
+        <a:cs typeface=""/>
+        <a:font script="Jpan" typeface="游ゴシック Light"/>
+        <a:font script="Hang" typeface="맑은 고딕"/>
+        <a:font script="Hans" typeface="等线 Light"/>
+        <a:font script="Hant" typeface="新細明體"/>
+        <a:font script="Arab" typeface="Times New Roman"/>
+        <a:font script="Hebr" typeface="Times New Roman"/>
+        <a:font script="Thai" typeface="Angsana New"/>
+        <a:font script="Ethi" typeface="Nyala"/>
+        <a:font script="Beng" typeface="Vrinda"/>
+        <a:font script="Gujr" typeface="Shruti"/>
+        <a:font script="Khmr" typeface="MoolBoran"/>
+        <a:font script="Knda" typeface="Tunga"/>
+        <a:font script="Guru" typeface="Raavi"/>
+        <a:font script="Cans" typeface="Euphemia"/>
+        <a:font script="Cher" typeface="Plantagenet Cherokee"/>
+        <a:font script="Yiii" typeface="Microsoft Yi Baiti"/>
+        <a:font script="Tibt" typeface="Microsoft Himalaya"/>
+        <a:font script="Thaa" typeface="MV Boli"/>
+        <a:font script="Deva" typeface="Mangal"/>
+        <a:font script="Telu" typeface="Gautami"/>
+        <a:font script="Taml" typeface="Latha"/>
+        <a:font script="Syrc" typeface="Estrangelo Edessa"/>
+        <a:font script="Orya" typeface="Kalinga"/>
+        <a:font script="Mlym" typeface="Kartika"/>
+        <a:font script="Laoo" typeface="DokChampa"/>
+        <a:font script="Sinh" typeface="Iskoola Pota"/>
+        <a:font script="Mong" typeface="Mongolian Baiti"/>
+        <a:font script="Viet" typeface="Times New Roman"/>
+        <a:font script="Uigh" typeface="Microsoft Uighur"/>
+        <a:font script="Geor" typeface="Sylfaen"/>
+        <a:font script="Armn" typeface="Arial"/>
+        <a:font script="Bugi" typeface="Leelawadee UI"/>
+        <a:font script="Bopo" typeface="Microsoft JhengHei"/>
+        <a:font script="Java" typeface="Javanese Text"/>
+        <a:font script="Lisu" typeface="Segoe UI"/>
+        <a:font script="Mymr" typeface="Myanmar Text"/>
+        <a:font script="Nkoo" typeface="Ebrima"/>
+        <a:font script="Olck" typeface="Nirmala UI"/>
+        <a:font script="Osma" typeface="Ebrima"/>
+        <a:font script="Phag" typeface="Phagspa"/>
+        <a:font script="Syrn" typeface="Estrangelo Edessa"/>
+        <a:font script="Syrj" typeface="Estrangelo Edessa"/>
+        <a:font script="Syre" typeface="Estrangelo Edessa"/>
+        <a:font script="Sora" typeface="Nirmala UI"/>
+        <a:font script="Tale" typeface="Microsoft Tai Le"/>
+        <a:font script="Talu" typeface="Microsoft New Tai Lue"/>
+        <a:font script="Tfng" typeface="Ebrima"/>
+      </a:majorFont>
+      <a:minorFont>
+        <a:latin typeface="Calibri" panose="020F0502020204030204"/>
+        <a:ea typeface=""/>
+        <a:cs typeface=""/>
+        <a:font script="Jpan" typeface="游ゴシック"/>
+        <a:font script="Hang" typeface="맑은 고딕"/>
+        <a:font script="Hans" typeface="等线"/>
+        <a:font script="Hant" typeface="新細明體"/>
+        <a:font script="Arab" typeface="Arial"/>
+        <a:font script="Hebr" typeface="Arial"/>
+        <a:font script="Thai" typeface="Cordia New"/>
+        <a:font script="Ethi" typeface="Nyala"/>
+        <a:font script="Beng" typeface="Vrinda"/>
+        <a:font script="Gujr" typeface="Shruti"/>
+        <a:font script="Khmr" typeface="DaunPenh"/>
+        <a:font script="Knda" typeface="Tunga"/>
+        <a:font script="Guru" typeface="Raavi"/>
+        <a:font script="Cans" typeface="Euphemia"/>
+        <a:font script="Cher" typeface="Plantagenet Cherokee"/>
+        <a:font script="Yiii" typeface="Microsoft Yi Baiti"/>
+        <a:font script="Tibt" typeface="Microsoft Himalaya"/>
+        <a:font script="Thaa" typeface="MV Boli"/>
+        <a:font script="Deva" typeface="Mangal"/>
+        <a:font script="Telu" typeface="Gautami"/>
+        <a:font script="Taml" typeface="Latha"/>
+        <a:font script="Syrc" typeface="Estrangelo Edessa"/>
+        <a:font script="Orya" typeface="Kalinga"/>
+        <a:font script="Mlym" typeface="Kartika"/>
+        <a:font script="Laoo" typeface="DokChampa"/>
+        <a:font script="Sinh" typeface="Iskoola Pota"/>
+        <a:font script="Mong" typeface="Mongolian Baiti"/>
+        <a:font script="Viet" typeface="Arial"/>
+        <a:font script="Uigh" typeface="Microsoft Uighur"/>
+        <a:font script="Geor" typeface="Sylfaen"/>
+        <a:font script="Armn" typeface="Arial"/>
+        <a:font script="Bugi" typeface="Leelawadee UI"/>
+        <a:font script="Bopo" typeface="Microsoft JhengHei"/>
+        <a:font script="Java" typeface="Javanese Text"/>
+        <a:font script="Lisu" typeface="Segoe UI"/>
+        <a:font script="Mymr" typeface="Myanmar Text"/>
+        <a:font script="Nkoo" typeface="Ebrima"/>
+        <a:font script="Olck" typeface="Nirmala UI"/>
+        <a:font script="Osma" typeface="Ebrima"/>
+        <a:font script="Phag" typeface="Phagspa"/>
+        <a:font script="Syrn" typeface="Estrangelo Edessa"/>
+        <a:font script="Syrj" typeface="Estrangelo Edessa"/>
+        <a:font script="Syre" typeface="Estrangelo Edessa"/>
+        <a:font script="Sora" typeface="Nirmala UI"/>
+        <a:font script="Tale" typeface="Microsoft Tai Le"/>
+        <a:font script="Talu" typeface="Microsoft New Tai Lue"/>
+        <a:font script="Tfng" typeface="Ebrima"/>
+      </a:minorFont>
+    </a:fontScheme>
+    <a:fmtScheme name="Office">
+      <a:fillStyleLst>
+        <a:solidFill>
+          <a:schemeClr val="phClr"/>
+        </a:solidFill>
+        <a:gradFill rotWithShape="1">
+          <a:gsLst>
+            <a:gs pos="0">
+              <a:schemeClr val="phClr">
+                <a:lumMod val="110000"/>
+                <a:satMod val="105000"/>
+                <a:tint val="67000"/>
+              </a:schemeClr>
+            </a:gs>
+            <a:gs pos="50000">
+              <a:schemeClr val="phClr">
+                <a:lumMod val="105000"/>
+                <a:satMod val="103000"/>
+                <a:tint val="73000"/>
+              </a:schemeClr>
+            </a:gs>
+            <a:gs pos="100000">
+              <a:schemeClr val="phClr">
+                <a:lumMod val="105000"/>
+                <a:satMod val="109000"/>
+                <a:tint val="81000"/>
+              </a:schemeClr>
+            </a:gs>
+          </a:gsLst>
+          <a:lin ang="5400000" scaled="0"/>
+        </a:gradFill>
+        <a:gradFill rotWithShape="1">
+          <a:gsLst>
+            <a:gs pos="0">
+              <a:schemeClr val="phClr">
+                <a:satMod val="103000"/>
+                <a:lumMod val="102000"/>
+                <a:tint val="94000"/>
+              </a:schemeClr>
+            </a:gs>
+            <a:gs pos="50000">
+              <a:schemeClr val="phClr">
+                <a:satMod val="110000"/>
+                <a:lumMod val="100000"/>
+                <a:shade val="100000"/>
+              </a:schemeClr>
+            </a:gs>
+            <a:gs pos="100000">
+              <a:schemeClr val="phClr">
+                <a:lumMod val="99000"/>
+                <a:satMod val="120000"/>
+                <a:shade val="78000"/>
+              </a:schemeClr>
+            </a:gs>
+          </a:gsLst>
+          <a:lin ang="5400000" scaled="0"/>
+        </a:gradFill>
+      </a:fillStyleLst>
+      <a:lnStyleLst>
+        <a:ln w="6350" cap="flat" cmpd="sng" algn="ctr">
+          <a:solidFill>
+            <a:schemeClr val="phClr"/>
+          </a:solidFill>
+          <a:prstDash val="solid"/>
+          <a:miter lim="800000"/>
+        </a:ln>
+        <a:ln w="12700" cap="flat" cmpd="sng" algn="ctr">
+          <a:solidFill>
+            <a:schemeClr val="phClr"/>
+          </a:solidFill>
+          <a:prstDash val="solid"/>
+          <a:miter lim="800000"/>
+        </a:ln>
+        <a:ln w="19050" cap="flat" cmpd="sng" algn="ctr">
+          <a:solidFill>
+            <a:schemeClr val="phClr"/>
+          </a:solidFill>
+          <a:prstDash val="solid"/>
+          <a:miter lim="800000"/>
+        </a:ln>
+      </a:lnStyleLst>
+      <a:effectStyleLst>
+        <a:effectStyle>
+          <a:effectLst/>
+        </a:effectStyle>
+        <a:effectStyle>
+          <a:effectLst/>
+        </a:effectStyle>
+        <a:effectStyle>
+          <a:effectLst>
+            <a:outerShdw blurRad="57150" dist="19050" dir="5400000" algn="ctr" rotWithShape="0">
+              <a:srgbClr val="000000">
+                <a:alpha val="63000"/>
+              </a:srgbClr>
+            </a:outerShdw>
+          </a:effectLst>
+        </a:effectStyle>
+      </a:effectStyleLst>
+      <a:bgFillStyleLst>
+        <a:solidFill>
+          <a:schemeClr val="phClr"/>
+        </a:solidFill>
+        <a:solidFill>
+          <a:schemeClr val="phClr">
+            <a:tint val="95000"/>
+            <a:satMod val="170000"/>
+          </a:schemeClr>
+        </a:solidFill>
+        <a:gradFill rotWithShape="1">
+          <a:gsLst>
+            <a:gs pos="0">
+              <a:schemeClr val="phClr">
+                <a:tint val="93000"/>
+                <a:satMod val="150000"/>
+                <a:shade val="98000"/>
+                <a:lumMod val="102000"/>
+              </a:schemeClr>
+            </a:gs>
+            <a:gs pos="50000">
+              <a:schemeClr val="phClr">
+                <a:tint val="98000"/>
+                <a:satMod val="130000"/>
+                <a:shade val="90000"/>
+                <a:lumMod val="103000"/>
+              </a:schemeClr>
+            </a:gs>
+            <a:gs pos="100000">
+              <a:schemeClr val="phClr">
+                <a:shade val="63000"/>
+                <a:satMod val="120000"/>
+              </a:schemeClr>
+            </a:gs>
+          </a:gsLst>
+          <a:lin ang="5400000" scaled="0"/>
+        </a:gradFill>
+      </a:bgFillStyleLst>
+    </a:fmtScheme>
+  </a:themeElements>
+  <a:objectDefaults/>
+  <a:extraClrSchemeLst/>
+  <a:extLst>
+    <a:ext uri="{05A4C25C-085E-4340-85A3-A5531E510DB2}">
+      <thm15:themeFamily xmlns:thm15="http://schemas.microsoft.com/office/thememl/2012/main" name="Office Theme" id="{62F939B6-93AF-4DB8-9C6B-D6C7DFDC589F}" vid="{4A3C46E8-61CC-4603-A589-7422A47A8E4A}"/>
+    </a:ext>
+  </a:extLst>
+</a:theme>
 </file>
</xml_diff>